<commit_message>
Add detailed UAV Metadata Field Analysis Report document
</commit_message>
<xml_diff>
--- a/Drone_Footprint_Mapping_and_Metadata_Standards.pptx
+++ b/Drone_Footprint_Mapping_and_Metadata_Standards.pptx
@@ -5,17 +5,15 @@
     <p:sldMasterId id="2147483648" r:id="rId1"/>
   </p:sldMasterIdLst>
   <p:sldIdLst>
-    <p:sldId id="256" r:id="rId7"/>
-    <p:sldId id="257" r:id="rId8"/>
-    <p:sldId id="258" r:id="rId9"/>
-    <p:sldId id="259" r:id="rId10"/>
-    <p:sldId id="260" r:id="rId11"/>
-    <p:sldId id="261" r:id="rId12"/>
-    <p:sldId id="262" r:id="rId13"/>
-    <p:sldId id="263" r:id="rId14"/>
-    <p:sldId id="264" r:id="rId15"/>
+    <p:sldId id="256" r:id="rId2"/>
+    <p:sldId id="257" r:id="rId3"/>
+    <p:sldId id="260" r:id="rId4"/>
+    <p:sldId id="261" r:id="rId5"/>
+    <p:sldId id="262" r:id="rId6"/>
+    <p:sldId id="263" r:id="rId7"/>
+    <p:sldId id="264" r:id="rId8"/>
   </p:sldIdLst>
-  <p:sldSz cx="9144000" cy="5143500" type="screen4x3"/>
+  <p:sldSz cx="9144000" cy="5143500" type="screen16x9"/>
   <p:notesSz cx="6858000" cy="9144000"/>
   <p:defaultTextStyle>
     <a:defPPr>
@@ -112,6 +110,22 @@
       </a:defRPr>
     </a:lvl9pPr>
   </p:defaultTextStyle>
+  <p:extLst>
+    <p:ext uri="{EFAFB233-063F-42B5-8137-9DF3F51BA10A}">
+      <p15:sldGuideLst xmlns:p15="http://schemas.microsoft.com/office/powerpoint/2012/main">
+        <p15:guide id="1" orient="horz" pos="2160">
+          <p15:clr>
+            <a:srgbClr val="A4A3A4"/>
+          </p15:clr>
+        </p15:guide>
+        <p15:guide id="2" pos="2880">
+          <p15:clr>
+            <a:srgbClr val="A4A3A4"/>
+          </p15:clr>
+        </p15:guide>
+      </p15:sldGuideLst>
+    </p:ext>
+  </p:extLst>
 </p:presentation>
 </file>
 
@@ -153,10 +167,9 @@
           <a:lstStyle/>
           <a:p>
             <a:r>
-              <a:rPr lang="en-US" smtClean="0"/>
+              <a:rPr lang="en-US"/>
               <a:t>Click to edit Master title style</a:t>
             </a:r>
-            <a:endParaRPr lang="en-US"/>
           </a:p>
         </p:txBody>
       </p:sp>
@@ -272,10 +285,9 @@
           </a:lstStyle>
           <a:p>
             <a:r>
-              <a:rPr lang="en-US" smtClean="0"/>
+              <a:rPr lang="en-US"/>
               <a:t>Click to edit Master subtitle style</a:t>
             </a:r>
-            <a:endParaRPr lang="en-US"/>
           </a:p>
         </p:txBody>
       </p:sp>
@@ -296,7 +308,7 @@
           <a:p>
             <a:fld id="{5BCAD085-E8A6-8845-BD4E-CB4CCA059FC4}" type="datetimeFigureOut">
               <a:rPr lang="en-US" smtClean="0"/>
-              <a:t>1/27/13</a:t>
+              <a:t>8/10/2026</a:t>
             </a:fld>
             <a:endParaRPr lang="en-US"/>
           </a:p>
@@ -390,10 +402,9 @@
           <a:lstStyle/>
           <a:p>
             <a:r>
-              <a:rPr lang="en-US" smtClean="0"/>
+              <a:rPr lang="en-US"/>
               <a:t>Click to edit Master title style</a:t>
             </a:r>
-            <a:endParaRPr lang="en-US"/>
           </a:p>
         </p:txBody>
       </p:sp>
@@ -414,38 +425,37 @@
           <a:p>
             <a:pPr lvl="0"/>
             <a:r>
-              <a:rPr lang="en-US" smtClean="0"/>
+              <a:rPr lang="en-US"/>
               <a:t>Click to edit Master text styles</a:t>
             </a:r>
           </a:p>
           <a:p>
             <a:pPr lvl="1"/>
             <a:r>
-              <a:rPr lang="en-US" smtClean="0"/>
+              <a:rPr lang="en-US"/>
               <a:t>Second level</a:t>
             </a:r>
           </a:p>
           <a:p>
             <a:pPr lvl="2"/>
             <a:r>
-              <a:rPr lang="en-US" smtClean="0"/>
+              <a:rPr lang="en-US"/>
               <a:t>Third level</a:t>
             </a:r>
           </a:p>
           <a:p>
             <a:pPr lvl="3"/>
             <a:r>
-              <a:rPr lang="en-US" smtClean="0"/>
+              <a:rPr lang="en-US"/>
               <a:t>Fourth level</a:t>
             </a:r>
           </a:p>
           <a:p>
             <a:pPr lvl="4"/>
             <a:r>
-              <a:rPr lang="en-US" smtClean="0"/>
+              <a:rPr lang="en-US"/>
               <a:t>Fifth level</a:t>
             </a:r>
-            <a:endParaRPr lang="en-US"/>
           </a:p>
         </p:txBody>
       </p:sp>
@@ -466,7 +476,7 @@
           <a:p>
             <a:fld id="{5BCAD085-E8A6-8845-BD4E-CB4CCA059FC4}" type="datetimeFigureOut">
               <a:rPr lang="en-US" smtClean="0"/>
-              <a:t>1/27/13</a:t>
+              <a:t>8/10/2026</a:t>
             </a:fld>
             <a:endParaRPr lang="en-US"/>
           </a:p>
@@ -565,10 +575,9 @@
           <a:lstStyle/>
           <a:p>
             <a:r>
-              <a:rPr lang="en-US" smtClean="0"/>
+              <a:rPr lang="en-US"/>
               <a:t>Click to edit Master title style</a:t>
             </a:r>
-            <a:endParaRPr lang="en-US"/>
           </a:p>
         </p:txBody>
       </p:sp>
@@ -594,38 +603,37 @@
           <a:p>
             <a:pPr lvl="0"/>
             <a:r>
-              <a:rPr lang="en-US" smtClean="0"/>
+              <a:rPr lang="en-US"/>
               <a:t>Click to edit Master text styles</a:t>
             </a:r>
           </a:p>
           <a:p>
             <a:pPr lvl="1"/>
             <a:r>
-              <a:rPr lang="en-US" smtClean="0"/>
+              <a:rPr lang="en-US"/>
               <a:t>Second level</a:t>
             </a:r>
           </a:p>
           <a:p>
             <a:pPr lvl="2"/>
             <a:r>
-              <a:rPr lang="en-US" smtClean="0"/>
+              <a:rPr lang="en-US"/>
               <a:t>Third level</a:t>
             </a:r>
           </a:p>
           <a:p>
             <a:pPr lvl="3"/>
             <a:r>
-              <a:rPr lang="en-US" smtClean="0"/>
+              <a:rPr lang="en-US"/>
               <a:t>Fourth level</a:t>
             </a:r>
           </a:p>
           <a:p>
             <a:pPr lvl="4"/>
             <a:r>
-              <a:rPr lang="en-US" smtClean="0"/>
+              <a:rPr lang="en-US"/>
               <a:t>Fifth level</a:t>
             </a:r>
-            <a:endParaRPr lang="en-US"/>
           </a:p>
         </p:txBody>
       </p:sp>
@@ -646,7 +654,7 @@
           <a:p>
             <a:fld id="{5BCAD085-E8A6-8845-BD4E-CB4CCA059FC4}" type="datetimeFigureOut">
               <a:rPr lang="en-US" smtClean="0"/>
-              <a:t>1/27/13</a:t>
+              <a:t>8/10/2026</a:t>
             </a:fld>
             <a:endParaRPr lang="en-US"/>
           </a:p>
@@ -740,10 +748,9 @@
           <a:lstStyle/>
           <a:p>
             <a:r>
-              <a:rPr lang="en-US" smtClean="0"/>
+              <a:rPr lang="en-US"/>
               <a:t>Click to edit Master title style</a:t>
             </a:r>
-            <a:endParaRPr lang="en-US"/>
           </a:p>
         </p:txBody>
       </p:sp>
@@ -764,38 +771,37 @@
           <a:p>
             <a:pPr lvl="0"/>
             <a:r>
-              <a:rPr lang="en-US" smtClean="0"/>
+              <a:rPr lang="en-US"/>
               <a:t>Click to edit Master text styles</a:t>
             </a:r>
           </a:p>
           <a:p>
             <a:pPr lvl="1"/>
             <a:r>
-              <a:rPr lang="en-US" smtClean="0"/>
+              <a:rPr lang="en-US"/>
               <a:t>Second level</a:t>
             </a:r>
           </a:p>
           <a:p>
             <a:pPr lvl="2"/>
             <a:r>
-              <a:rPr lang="en-US" smtClean="0"/>
+              <a:rPr lang="en-US"/>
               <a:t>Third level</a:t>
             </a:r>
           </a:p>
           <a:p>
             <a:pPr lvl="3"/>
             <a:r>
-              <a:rPr lang="en-US" smtClean="0"/>
+              <a:rPr lang="en-US"/>
               <a:t>Fourth level</a:t>
             </a:r>
           </a:p>
           <a:p>
             <a:pPr lvl="4"/>
             <a:r>
-              <a:rPr lang="en-US" smtClean="0"/>
+              <a:rPr lang="en-US"/>
               <a:t>Fifth level</a:t>
             </a:r>
-            <a:endParaRPr lang="en-US"/>
           </a:p>
         </p:txBody>
       </p:sp>
@@ -816,7 +822,7 @@
           <a:p>
             <a:fld id="{5BCAD085-E8A6-8845-BD4E-CB4CCA059FC4}" type="datetimeFigureOut">
               <a:rPr lang="en-US" smtClean="0"/>
-              <a:t>1/27/13</a:t>
+              <a:t>8/10/2026</a:t>
             </a:fld>
             <a:endParaRPr lang="en-US"/>
           </a:p>
@@ -919,10 +925,9 @@
           </a:lstStyle>
           <a:p>
             <a:r>
-              <a:rPr lang="en-US" smtClean="0"/>
+              <a:rPr lang="en-US"/>
               <a:t>Click to edit Master title style</a:t>
             </a:r>
-            <a:endParaRPr lang="en-US"/>
           </a:p>
         </p:txBody>
       </p:sp>
@@ -1039,7 +1044,7 @@
           <a:p>
             <a:pPr lvl="0"/>
             <a:r>
-              <a:rPr lang="en-US" smtClean="0"/>
+              <a:rPr lang="en-US"/>
               <a:t>Click to edit Master text styles</a:t>
             </a:r>
           </a:p>
@@ -1062,7 +1067,7 @@
           <a:p>
             <a:fld id="{5BCAD085-E8A6-8845-BD4E-CB4CCA059FC4}" type="datetimeFigureOut">
               <a:rPr lang="en-US" smtClean="0"/>
-              <a:t>1/27/13</a:t>
+              <a:t>8/10/2026</a:t>
             </a:fld>
             <a:endParaRPr lang="en-US"/>
           </a:p>
@@ -1156,10 +1161,9 @@
           <a:lstStyle/>
           <a:p>
             <a:r>
-              <a:rPr lang="en-US" smtClean="0"/>
+              <a:rPr lang="en-US"/>
               <a:t>Click to edit Master title style</a:t>
             </a:r>
-            <a:endParaRPr lang="en-US"/>
           </a:p>
         </p:txBody>
       </p:sp>
@@ -1213,38 +1217,37 @@
           <a:p>
             <a:pPr lvl="0"/>
             <a:r>
-              <a:rPr lang="en-US" smtClean="0"/>
+              <a:rPr lang="en-US"/>
               <a:t>Click to edit Master text styles</a:t>
             </a:r>
           </a:p>
           <a:p>
             <a:pPr lvl="1"/>
             <a:r>
-              <a:rPr lang="en-US" smtClean="0"/>
+              <a:rPr lang="en-US"/>
               <a:t>Second level</a:t>
             </a:r>
           </a:p>
           <a:p>
             <a:pPr lvl="2"/>
             <a:r>
-              <a:rPr lang="en-US" smtClean="0"/>
+              <a:rPr lang="en-US"/>
               <a:t>Third level</a:t>
             </a:r>
           </a:p>
           <a:p>
             <a:pPr lvl="3"/>
             <a:r>
-              <a:rPr lang="en-US" smtClean="0"/>
+              <a:rPr lang="en-US"/>
               <a:t>Fourth level</a:t>
             </a:r>
           </a:p>
           <a:p>
             <a:pPr lvl="4"/>
             <a:r>
-              <a:rPr lang="en-US" smtClean="0"/>
+              <a:rPr lang="en-US"/>
               <a:t>Fifth level</a:t>
             </a:r>
-            <a:endParaRPr lang="en-US"/>
           </a:p>
         </p:txBody>
       </p:sp>
@@ -1298,38 +1301,37 @@
           <a:p>
             <a:pPr lvl="0"/>
             <a:r>
-              <a:rPr lang="en-US" smtClean="0"/>
+              <a:rPr lang="en-US"/>
               <a:t>Click to edit Master text styles</a:t>
             </a:r>
           </a:p>
           <a:p>
             <a:pPr lvl="1"/>
             <a:r>
-              <a:rPr lang="en-US" smtClean="0"/>
+              <a:rPr lang="en-US"/>
               <a:t>Second level</a:t>
             </a:r>
           </a:p>
           <a:p>
             <a:pPr lvl="2"/>
             <a:r>
-              <a:rPr lang="en-US" smtClean="0"/>
+              <a:rPr lang="en-US"/>
               <a:t>Third level</a:t>
             </a:r>
           </a:p>
           <a:p>
             <a:pPr lvl="3"/>
             <a:r>
-              <a:rPr lang="en-US" smtClean="0"/>
+              <a:rPr lang="en-US"/>
               <a:t>Fourth level</a:t>
             </a:r>
           </a:p>
           <a:p>
             <a:pPr lvl="4"/>
             <a:r>
-              <a:rPr lang="en-US" smtClean="0"/>
+              <a:rPr lang="en-US"/>
               <a:t>Fifth level</a:t>
             </a:r>
-            <a:endParaRPr lang="en-US"/>
           </a:p>
         </p:txBody>
       </p:sp>
@@ -1350,7 +1352,7 @@
           <a:p>
             <a:fld id="{5BCAD085-E8A6-8845-BD4E-CB4CCA059FC4}" type="datetimeFigureOut">
               <a:rPr lang="en-US" smtClean="0"/>
-              <a:t>1/27/13</a:t>
+              <a:t>8/10/2026</a:t>
             </a:fld>
             <a:endParaRPr lang="en-US"/>
           </a:p>
@@ -1448,10 +1450,9 @@
           </a:lstStyle>
           <a:p>
             <a:r>
-              <a:rPr lang="en-US" smtClean="0"/>
+              <a:rPr lang="en-US"/>
               <a:t>Click to edit Master title style</a:t>
             </a:r>
-            <a:endParaRPr lang="en-US"/>
           </a:p>
         </p:txBody>
       </p:sp>
@@ -1514,7 +1515,7 @@
           <a:p>
             <a:pPr lvl="0"/>
             <a:r>
-              <a:rPr lang="en-US" smtClean="0"/>
+              <a:rPr lang="en-US"/>
               <a:t>Click to edit Master text styles</a:t>
             </a:r>
           </a:p>
@@ -1570,38 +1571,37 @@
           <a:p>
             <a:pPr lvl="0"/>
             <a:r>
-              <a:rPr lang="en-US" smtClean="0"/>
+              <a:rPr lang="en-US"/>
               <a:t>Click to edit Master text styles</a:t>
             </a:r>
           </a:p>
           <a:p>
             <a:pPr lvl="1"/>
             <a:r>
-              <a:rPr lang="en-US" smtClean="0"/>
+              <a:rPr lang="en-US"/>
               <a:t>Second level</a:t>
             </a:r>
           </a:p>
           <a:p>
             <a:pPr lvl="2"/>
             <a:r>
-              <a:rPr lang="en-US" smtClean="0"/>
+              <a:rPr lang="en-US"/>
               <a:t>Third level</a:t>
             </a:r>
           </a:p>
           <a:p>
             <a:pPr lvl="3"/>
             <a:r>
-              <a:rPr lang="en-US" smtClean="0"/>
+              <a:rPr lang="en-US"/>
               <a:t>Fourth level</a:t>
             </a:r>
           </a:p>
           <a:p>
             <a:pPr lvl="4"/>
             <a:r>
-              <a:rPr lang="en-US" smtClean="0"/>
+              <a:rPr lang="en-US"/>
               <a:t>Fifth level</a:t>
             </a:r>
-            <a:endParaRPr lang="en-US"/>
           </a:p>
         </p:txBody>
       </p:sp>
@@ -1664,7 +1664,7 @@
           <a:p>
             <a:pPr lvl="0"/>
             <a:r>
-              <a:rPr lang="en-US" smtClean="0"/>
+              <a:rPr lang="en-US"/>
               <a:t>Click to edit Master text styles</a:t>
             </a:r>
           </a:p>
@@ -1720,38 +1720,37 @@
           <a:p>
             <a:pPr lvl="0"/>
             <a:r>
-              <a:rPr lang="en-US" smtClean="0"/>
+              <a:rPr lang="en-US"/>
               <a:t>Click to edit Master text styles</a:t>
             </a:r>
           </a:p>
           <a:p>
             <a:pPr lvl="1"/>
             <a:r>
-              <a:rPr lang="en-US" smtClean="0"/>
+              <a:rPr lang="en-US"/>
               <a:t>Second level</a:t>
             </a:r>
           </a:p>
           <a:p>
             <a:pPr lvl="2"/>
             <a:r>
-              <a:rPr lang="en-US" smtClean="0"/>
+              <a:rPr lang="en-US"/>
               <a:t>Third level</a:t>
             </a:r>
           </a:p>
           <a:p>
             <a:pPr lvl="3"/>
             <a:r>
-              <a:rPr lang="en-US" smtClean="0"/>
+              <a:rPr lang="en-US"/>
               <a:t>Fourth level</a:t>
             </a:r>
           </a:p>
           <a:p>
             <a:pPr lvl="4"/>
             <a:r>
-              <a:rPr lang="en-US" smtClean="0"/>
+              <a:rPr lang="en-US"/>
               <a:t>Fifth level</a:t>
             </a:r>
-            <a:endParaRPr lang="en-US"/>
           </a:p>
         </p:txBody>
       </p:sp>
@@ -1772,7 +1771,7 @@
           <a:p>
             <a:fld id="{5BCAD085-E8A6-8845-BD4E-CB4CCA059FC4}" type="datetimeFigureOut">
               <a:rPr lang="en-US" smtClean="0"/>
-              <a:t>1/27/13</a:t>
+              <a:t>8/10/2026</a:t>
             </a:fld>
             <a:endParaRPr lang="en-US"/>
           </a:p>
@@ -1866,10 +1865,9 @@
           <a:lstStyle/>
           <a:p>
             <a:r>
-              <a:rPr lang="en-US" smtClean="0"/>
+              <a:rPr lang="en-US"/>
               <a:t>Click to edit Master title style</a:t>
             </a:r>
-            <a:endParaRPr lang="en-US"/>
           </a:p>
         </p:txBody>
       </p:sp>
@@ -1890,7 +1888,7 @@
           <a:p>
             <a:fld id="{5BCAD085-E8A6-8845-BD4E-CB4CCA059FC4}" type="datetimeFigureOut">
               <a:rPr lang="en-US" smtClean="0"/>
-              <a:t>1/27/13</a:t>
+              <a:t>8/10/2026</a:t>
             </a:fld>
             <a:endParaRPr lang="en-US"/>
           </a:p>
@@ -1985,7 +1983,7 @@
           <a:p>
             <a:fld id="{5BCAD085-E8A6-8845-BD4E-CB4CCA059FC4}" type="datetimeFigureOut">
               <a:rPr lang="en-US" smtClean="0"/>
-              <a:t>1/27/13</a:t>
+              <a:t>8/10/2026</a:t>
             </a:fld>
             <a:endParaRPr lang="en-US"/>
           </a:p>
@@ -2088,10 +2086,9 @@
           </a:lstStyle>
           <a:p>
             <a:r>
-              <a:rPr lang="en-US" smtClean="0"/>
+              <a:rPr lang="en-US"/>
               <a:t>Click to edit Master title style</a:t>
             </a:r>
-            <a:endParaRPr lang="en-US"/>
           </a:p>
         </p:txBody>
       </p:sp>
@@ -2145,38 +2142,37 @@
           <a:p>
             <a:pPr lvl="0"/>
             <a:r>
-              <a:rPr lang="en-US" smtClean="0"/>
+              <a:rPr lang="en-US"/>
               <a:t>Click to edit Master text styles</a:t>
             </a:r>
           </a:p>
           <a:p>
             <a:pPr lvl="1"/>
             <a:r>
-              <a:rPr lang="en-US" smtClean="0"/>
+              <a:rPr lang="en-US"/>
               <a:t>Second level</a:t>
             </a:r>
           </a:p>
           <a:p>
             <a:pPr lvl="2"/>
             <a:r>
-              <a:rPr lang="en-US" smtClean="0"/>
+              <a:rPr lang="en-US"/>
               <a:t>Third level</a:t>
             </a:r>
           </a:p>
           <a:p>
             <a:pPr lvl="3"/>
             <a:r>
-              <a:rPr lang="en-US" smtClean="0"/>
+              <a:rPr lang="en-US"/>
               <a:t>Fourth level</a:t>
             </a:r>
           </a:p>
           <a:p>
             <a:pPr lvl="4"/>
             <a:r>
-              <a:rPr lang="en-US" smtClean="0"/>
+              <a:rPr lang="en-US"/>
               <a:t>Fifth level</a:t>
             </a:r>
-            <a:endParaRPr lang="en-US"/>
           </a:p>
         </p:txBody>
       </p:sp>
@@ -2239,7 +2235,7 @@
           <a:p>
             <a:pPr lvl="0"/>
             <a:r>
-              <a:rPr lang="en-US" smtClean="0"/>
+              <a:rPr lang="en-US"/>
               <a:t>Click to edit Master text styles</a:t>
             </a:r>
           </a:p>
@@ -2262,7 +2258,7 @@
           <a:p>
             <a:fld id="{5BCAD085-E8A6-8845-BD4E-CB4CCA059FC4}" type="datetimeFigureOut">
               <a:rPr lang="en-US" smtClean="0"/>
-              <a:t>1/27/13</a:t>
+              <a:t>8/10/2026</a:t>
             </a:fld>
             <a:endParaRPr lang="en-US"/>
           </a:p>
@@ -2365,10 +2361,9 @@
           </a:lstStyle>
           <a:p>
             <a:r>
-              <a:rPr lang="en-US" smtClean="0"/>
+              <a:rPr lang="en-US"/>
               <a:t>Click to edit Master title style</a:t>
             </a:r>
-            <a:endParaRPr lang="en-US"/>
           </a:p>
         </p:txBody>
       </p:sp>
@@ -2492,7 +2487,7 @@
           <a:p>
             <a:pPr lvl="0"/>
             <a:r>
-              <a:rPr lang="en-US" smtClean="0"/>
+              <a:rPr lang="en-US"/>
               <a:t>Click to edit Master text styles</a:t>
             </a:r>
           </a:p>
@@ -2515,7 +2510,7 @@
           <a:p>
             <a:fld id="{5BCAD085-E8A6-8845-BD4E-CB4CCA059FC4}" type="datetimeFigureOut">
               <a:rPr lang="en-US" smtClean="0"/>
-              <a:t>1/27/13</a:t>
+              <a:t>8/10/2026</a:t>
             </a:fld>
             <a:endParaRPr lang="en-US"/>
           </a:p>
@@ -2624,10 +2619,9 @@
           <a:lstStyle/>
           <a:p>
             <a:r>
-              <a:rPr lang="en-US" smtClean="0"/>
+              <a:rPr lang="en-US"/>
               <a:t>Click to edit Master title style</a:t>
             </a:r>
-            <a:endParaRPr lang="en-US"/>
           </a:p>
         </p:txBody>
       </p:sp>
@@ -2658,38 +2652,37 @@
           <a:p>
             <a:pPr lvl="0"/>
             <a:r>
-              <a:rPr lang="en-US" smtClean="0"/>
+              <a:rPr lang="en-US"/>
               <a:t>Click to edit Master text styles</a:t>
             </a:r>
           </a:p>
           <a:p>
             <a:pPr lvl="1"/>
             <a:r>
-              <a:rPr lang="en-US" smtClean="0"/>
+              <a:rPr lang="en-US"/>
               <a:t>Second level</a:t>
             </a:r>
           </a:p>
           <a:p>
             <a:pPr lvl="2"/>
             <a:r>
-              <a:rPr lang="en-US" smtClean="0"/>
+              <a:rPr lang="en-US"/>
               <a:t>Third level</a:t>
             </a:r>
           </a:p>
           <a:p>
             <a:pPr lvl="3"/>
             <a:r>
-              <a:rPr lang="en-US" smtClean="0"/>
+              <a:rPr lang="en-US"/>
               <a:t>Fourth level</a:t>
             </a:r>
           </a:p>
           <a:p>
             <a:pPr lvl="4"/>
             <a:r>
-              <a:rPr lang="en-US" smtClean="0"/>
+              <a:rPr lang="en-US"/>
               <a:t>Fifth level</a:t>
             </a:r>
-            <a:endParaRPr lang="en-US"/>
           </a:p>
         </p:txBody>
       </p:sp>
@@ -2728,7 +2721,7 @@
           <a:p>
             <a:fld id="{5BCAD085-E8A6-8845-BD4E-CB4CCA059FC4}" type="datetimeFigureOut">
               <a:rPr lang="en-US" smtClean="0"/>
-              <a:t>1/27/13</a:t>
+              <a:t>8/10/2026</a:t>
             </a:fld>
             <a:endParaRPr lang="en-US"/>
           </a:p>
@@ -3087,7 +3080,7 @@
 </file>
 
 <file path=ppt/slides/slide1.xml><?xml version="1.0" encoding="utf-8"?>
-<p:sld xmlns:a="http://schemas.openxmlformats.org/drawingml/2006/main" xmlns:p="http://schemas.openxmlformats.org/presentationml/2006/main" xmlns:r="http://schemas.openxmlformats.org/officeDocument/2006/relationships">
+<p:sld xmlns:a="http://schemas.openxmlformats.org/drawingml/2006/main" xmlns:r="http://schemas.openxmlformats.org/officeDocument/2006/relationships" xmlns:p="http://schemas.openxmlformats.org/presentationml/2006/main">
   <p:cSld>
     <p:spTree>
       <p:nvGrpSpPr>
@@ -3095,7 +3088,14 @@
         <p:cNvGrpSpPr/>
         <p:nvPr/>
       </p:nvGrpSpPr>
-      <p:grpSpPr/>
+      <p:grpSpPr>
+        <a:xfrm>
+          <a:off x="0" y="0"/>
+          <a:ext cx="0" cy="0"/>
+          <a:chOff x="0" y="0"/>
+          <a:chExt cx="0" cy="0"/>
+        </a:xfrm>
+      </p:grpSpPr>
       <p:sp>
         <p:nvSpPr>
           <p:cNvPr id="2" name="TextBox 1"/>
@@ -3140,8 +3140,8 @@
         </p:nvSpPr>
         <p:spPr>
           <a:xfrm>
-            <a:off x="457200" y="1097280"/>
-            <a:ext cx="4937760" cy="3657600"/>
+            <a:off x="457199" y="1212782"/>
+            <a:ext cx="5577842" cy="3323987"/>
           </a:xfrm>
           <a:prstGeom prst="rect">
             <a:avLst/>
@@ -3163,7 +3163,11 @@
               </a:defRPr>
             </a:pPr>
             <a:r>
-              <a:t>• Project Phase 1: Automated image telemetry processing.</a:t>
+              <a:rPr sz="1400" dirty="0">
+                <a:latin typeface="Times New Roman" panose="02020603050405020304" pitchFamily="18" charset="0"/>
+                <a:cs typeface="Times New Roman" panose="02020603050405020304" pitchFamily="18" charset="0"/>
+              </a:rPr>
+              <a:t>Project Phase 1: Automated image telemetry processing.</a:t>
             </a:r>
           </a:p>
           <a:p>
@@ -3176,7 +3180,46 @@
               </a:defRPr>
             </a:pPr>
             <a:r>
-              <a:t>• Steps 1-4 (Collection &amp; Extraction):</a:t>
+              <a:rPr sz="1400" dirty="0">
+                <a:latin typeface="Times New Roman" panose="02020603050405020304" pitchFamily="18" charset="0"/>
+                <a:cs typeface="Times New Roman" panose="02020603050405020304" pitchFamily="18" charset="0"/>
+              </a:rPr>
+              <a:t>• </a:t>
+            </a:r>
+            <a:r>
+              <a:rPr sz="1400" b="1" dirty="0">
+                <a:latin typeface="Times New Roman" panose="02020603050405020304" pitchFamily="18" charset="0"/>
+                <a:cs typeface="Times New Roman" panose="02020603050405020304" pitchFamily="18" charset="0"/>
+              </a:rPr>
+              <a:t>Step</a:t>
+            </a:r>
+            <a:r>
+              <a:rPr lang="en-IN" sz="1400" b="1" dirty="0">
+                <a:latin typeface="Times New Roman" panose="02020603050405020304" pitchFamily="18" charset="0"/>
+                <a:cs typeface="Times New Roman" panose="02020603050405020304" pitchFamily="18" charset="0"/>
+              </a:rPr>
+              <a:t>: </a:t>
+            </a:r>
+            <a:r>
+              <a:rPr sz="1400" b="1" dirty="0">
+                <a:latin typeface="Times New Roman" panose="02020603050405020304" pitchFamily="18" charset="0"/>
+                <a:cs typeface="Times New Roman" panose="02020603050405020304" pitchFamily="18" charset="0"/>
+              </a:rPr>
+              <a:t>Collection &amp; Extraction</a:t>
+            </a:r>
+            <a:r>
+              <a:rPr lang="en-IN" sz="1400" b="1" dirty="0">
+                <a:latin typeface="Times New Roman" panose="02020603050405020304" pitchFamily="18" charset="0"/>
+                <a:cs typeface="Times New Roman" panose="02020603050405020304" pitchFamily="18" charset="0"/>
+              </a:rPr>
+              <a:t> </a:t>
+            </a:r>
+            <a:r>
+              <a:rPr sz="1400" b="1" dirty="0">
+                <a:latin typeface="Times New Roman" panose="02020603050405020304" pitchFamily="18" charset="0"/>
+                <a:cs typeface="Times New Roman" panose="02020603050405020304" pitchFamily="18" charset="0"/>
+              </a:rPr>
+              <a:t>:</a:t>
             </a:r>
           </a:p>
           <a:p>
@@ -3189,8 +3232,16 @@
               </a:defRPr>
             </a:pPr>
             <a:r>
-              <a:t>   - Raw images from DJI drone flight are collected (Step 1).</a:t>
-            </a:r>
+              <a:rPr sz="1400" dirty="0">
+                <a:latin typeface="Times New Roman" panose="02020603050405020304" pitchFamily="18" charset="0"/>
+                <a:cs typeface="Times New Roman" panose="02020603050405020304" pitchFamily="18" charset="0"/>
+              </a:rPr>
+              <a:t>   - Raw images from DJI drone flight are collected </a:t>
+            </a:r>
+            <a:endParaRPr lang="en-IN" sz="1400" dirty="0">
+              <a:latin typeface="Times New Roman" panose="02020603050405020304" pitchFamily="18" charset="0"/>
+              <a:cs typeface="Times New Roman" panose="02020603050405020304" pitchFamily="18" charset="0"/>
+            </a:endParaRPr>
           </a:p>
           <a:p>
             <a:pPr lvl="1">
@@ -3202,7 +3253,32 @@
               </a:defRPr>
             </a:pPr>
             <a:r>
-              <a:t>   - ExifTool parses binary EXIF metadata automatically (Step 2-4).</a:t>
+              <a:rPr lang="en-IN" sz="1400" dirty="0">
+                <a:latin typeface="Times New Roman" panose="02020603050405020304" pitchFamily="18" charset="0"/>
+                <a:cs typeface="Times New Roman" panose="02020603050405020304" pitchFamily="18" charset="0"/>
+              </a:rPr>
+              <a:t>   </a:t>
+            </a:r>
+            <a:r>
+              <a:rPr sz="1400" dirty="0">
+                <a:latin typeface="Times New Roman" panose="02020603050405020304" pitchFamily="18" charset="0"/>
+                <a:cs typeface="Times New Roman" panose="02020603050405020304" pitchFamily="18" charset="0"/>
+              </a:rPr>
+              <a:t>- </a:t>
+            </a:r>
+            <a:r>
+              <a:rPr sz="1400" dirty="0" err="1">
+                <a:latin typeface="Times New Roman" panose="02020603050405020304" pitchFamily="18" charset="0"/>
+                <a:cs typeface="Times New Roman" panose="02020603050405020304" pitchFamily="18" charset="0"/>
+              </a:rPr>
+              <a:t>ExifTool</a:t>
+            </a:r>
+            <a:r>
+              <a:rPr sz="1400" dirty="0">
+                <a:latin typeface="Times New Roman" panose="02020603050405020304" pitchFamily="18" charset="0"/>
+                <a:cs typeface="Times New Roman" panose="02020603050405020304" pitchFamily="18" charset="0"/>
+              </a:rPr>
+              <a:t> parses binary EXIF metadata automatically</a:t>
             </a:r>
           </a:p>
           <a:p>
@@ -3215,6 +3291,10 @@
               </a:defRPr>
             </a:pPr>
             <a:r>
+              <a:rPr sz="1400" dirty="0">
+                <a:latin typeface="Times New Roman" panose="02020603050405020304" pitchFamily="18" charset="0"/>
+                <a:cs typeface="Times New Roman" panose="02020603050405020304" pitchFamily="18" charset="0"/>
+              </a:rPr>
               <a:t>   - Extracts: GPS location (Lat/Lon/Alt), flight height, and yaw/pitch orientation.</a:t>
             </a:r>
           </a:p>
@@ -3228,7 +3308,32 @@
               </a:defRPr>
             </a:pPr>
             <a:r>
-              <a:t>• Steps 5-6 (FOV Calculation):</a:t>
+              <a:rPr sz="1400" dirty="0">
+                <a:latin typeface="Times New Roman" panose="02020603050405020304" pitchFamily="18" charset="0"/>
+                <a:cs typeface="Times New Roman" panose="02020603050405020304" pitchFamily="18" charset="0"/>
+              </a:rPr>
+              <a:t>• </a:t>
+            </a:r>
+            <a:r>
+              <a:rPr sz="1400" b="1" dirty="0">
+                <a:latin typeface="Times New Roman" panose="02020603050405020304" pitchFamily="18" charset="0"/>
+                <a:cs typeface="Times New Roman" panose="02020603050405020304" pitchFamily="18" charset="0"/>
+              </a:rPr>
+              <a:t>Step</a:t>
+            </a:r>
+            <a:r>
+              <a:rPr lang="en-IN" sz="1400" b="1" dirty="0">
+                <a:latin typeface="Times New Roman" panose="02020603050405020304" pitchFamily="18" charset="0"/>
+                <a:cs typeface="Times New Roman" panose="02020603050405020304" pitchFamily="18" charset="0"/>
+              </a:rPr>
+              <a:t>: </a:t>
+            </a:r>
+            <a:r>
+              <a:rPr sz="1400" b="1" dirty="0">
+                <a:latin typeface="Times New Roman" panose="02020603050405020304" pitchFamily="18" charset="0"/>
+                <a:cs typeface="Times New Roman" panose="02020603050405020304" pitchFamily="18" charset="0"/>
+              </a:rPr>
+              <a:t>FOV Calculation:</a:t>
             </a:r>
           </a:p>
           <a:p>
@@ -3241,6 +3346,10 @@
               </a:defRPr>
             </a:pPr>
             <a:r>
+              <a:rPr sz="1400" dirty="0">
+                <a:latin typeface="Times New Roman" panose="02020603050405020304" pitchFamily="18" charset="0"/>
+                <a:cs typeface="Times New Roman" panose="02020603050405020304" pitchFamily="18" charset="0"/>
+              </a:rPr>
               <a:t>   - Physical sensor specifications are mapped to compute horizontal/vertical FOV.</a:t>
             </a:r>
           </a:p>
@@ -3254,7 +3363,32 @@
               </a:defRPr>
             </a:pPr>
             <a:r>
-              <a:t>• Steps 7-8 (Ground Footprint Corners Projection):</a:t>
+              <a:rPr sz="1400" dirty="0">
+                <a:latin typeface="Times New Roman" panose="02020603050405020304" pitchFamily="18" charset="0"/>
+                <a:cs typeface="Times New Roman" panose="02020603050405020304" pitchFamily="18" charset="0"/>
+              </a:rPr>
+              <a:t>• </a:t>
+            </a:r>
+            <a:r>
+              <a:rPr sz="1400" b="1" dirty="0">
+                <a:latin typeface="Times New Roman" panose="02020603050405020304" pitchFamily="18" charset="0"/>
+                <a:cs typeface="Times New Roman" panose="02020603050405020304" pitchFamily="18" charset="0"/>
+              </a:rPr>
+              <a:t>Step</a:t>
+            </a:r>
+            <a:r>
+              <a:rPr lang="en-IN" sz="1400" b="1" dirty="0">
+                <a:latin typeface="Times New Roman" panose="02020603050405020304" pitchFamily="18" charset="0"/>
+                <a:cs typeface="Times New Roman" panose="02020603050405020304" pitchFamily="18" charset="0"/>
+              </a:rPr>
+              <a:t>: </a:t>
+            </a:r>
+            <a:r>
+              <a:rPr sz="1400" b="1" dirty="0">
+                <a:latin typeface="Times New Roman" panose="02020603050405020304" pitchFamily="18" charset="0"/>
+                <a:cs typeface="Times New Roman" panose="02020603050405020304" pitchFamily="18" charset="0"/>
+              </a:rPr>
+              <a:t>Ground Footprint Corners Projection:</a:t>
             </a:r>
           </a:p>
           <a:p>
@@ -3267,6 +3401,10 @@
               </a:defRPr>
             </a:pPr>
             <a:r>
+              <a:rPr sz="1400" dirty="0">
+                <a:latin typeface="Times New Roman" panose="02020603050405020304" pitchFamily="18" charset="0"/>
+                <a:cs typeface="Times New Roman" panose="02020603050405020304" pitchFamily="18" charset="0"/>
+              </a:rPr>
               <a:t>   - Combines camera viewing angles, drone altitude, and yaw rotation coordinates.</a:t>
             </a:r>
           </a:p>
@@ -3280,7 +3418,32 @@
               </a:defRPr>
             </a:pPr>
             <a:r>
-              <a:t>• Steps 9-10 (Polygon Building &amp; GIS Export):</a:t>
+              <a:rPr sz="1400" dirty="0">
+                <a:latin typeface="Times New Roman" panose="02020603050405020304" pitchFamily="18" charset="0"/>
+                <a:cs typeface="Times New Roman" panose="02020603050405020304" pitchFamily="18" charset="0"/>
+              </a:rPr>
+              <a:t>• </a:t>
+            </a:r>
+            <a:r>
+              <a:rPr sz="1400" b="1" dirty="0">
+                <a:latin typeface="Times New Roman" panose="02020603050405020304" pitchFamily="18" charset="0"/>
+                <a:cs typeface="Times New Roman" panose="02020603050405020304" pitchFamily="18" charset="0"/>
+              </a:rPr>
+              <a:t>Step</a:t>
+            </a:r>
+            <a:r>
+              <a:rPr lang="en-IN" sz="1400" b="1" dirty="0">
+                <a:latin typeface="Times New Roman" panose="02020603050405020304" pitchFamily="18" charset="0"/>
+                <a:cs typeface="Times New Roman" panose="02020603050405020304" pitchFamily="18" charset="0"/>
+              </a:rPr>
+              <a:t>: </a:t>
+            </a:r>
+            <a:r>
+              <a:rPr sz="1400" b="1" dirty="0">
+                <a:latin typeface="Times New Roman" panose="02020603050405020304" pitchFamily="18" charset="0"/>
+                <a:cs typeface="Times New Roman" panose="02020603050405020304" pitchFamily="18" charset="0"/>
+              </a:rPr>
+              <a:t>Polygon Building &amp; GIS Export:</a:t>
             </a:r>
           </a:p>
           <a:p>
@@ -3293,7 +3456,25 @@
               </a:defRPr>
             </a:pPr>
             <a:r>
-              <a:t>   - Loops coordinates as a polygon, and exports footprints in WGS 84 GeoJSON.</a:t>
+              <a:rPr sz="1400" dirty="0">
+                <a:latin typeface="Times New Roman" panose="02020603050405020304" pitchFamily="18" charset="0"/>
+                <a:cs typeface="Times New Roman" panose="02020603050405020304" pitchFamily="18" charset="0"/>
+              </a:rPr>
+              <a:t>   - Loops coordinates as a polygon, and exports footprints in WGS 84 </a:t>
+            </a:r>
+            <a:r>
+              <a:rPr sz="1400" dirty="0" err="1">
+                <a:latin typeface="Times New Roman" panose="02020603050405020304" pitchFamily="18" charset="0"/>
+                <a:cs typeface="Times New Roman" panose="02020603050405020304" pitchFamily="18" charset="0"/>
+              </a:rPr>
+              <a:t>GeoJSON</a:t>
+            </a:r>
+            <a:r>
+              <a:rPr sz="1400" dirty="0">
+                <a:latin typeface="Times New Roman" panose="02020603050405020304" pitchFamily="18" charset="0"/>
+                <a:cs typeface="Times New Roman" panose="02020603050405020304" pitchFamily="18" charset="0"/>
+              </a:rPr>
+              <a:t>.</a:t>
             </a:r>
           </a:p>
         </p:txBody>
@@ -3308,14 +3489,13 @@
         </p:nvPicPr>
         <p:blipFill>
           <a:blip r:embed="rId2"/>
-          <a:stretch>
-            <a:fillRect/>
-          </a:stretch>
+          <a:srcRect l="28098" t="5877" r="26546" b="5412"/>
+          <a:stretch/>
         </p:blipFill>
         <p:spPr>
           <a:xfrm>
-            <a:off x="5577840" y="1097280"/>
-            <a:ext cx="3108960" cy="3906129"/>
+            <a:off x="6718434" y="988854"/>
+            <a:ext cx="1443789" cy="3547915"/>
           </a:xfrm>
           <a:prstGeom prst="rect">
             <a:avLst/>
@@ -3331,7 +3511,7 @@
 </file>
 
 <file path=ppt/slides/slide2.xml><?xml version="1.0" encoding="utf-8"?>
-<p:sld xmlns:a="http://schemas.openxmlformats.org/drawingml/2006/main" xmlns:p="http://schemas.openxmlformats.org/presentationml/2006/main" xmlns:r="http://schemas.openxmlformats.org/officeDocument/2006/relationships">
+<p:sld xmlns:a="http://schemas.openxmlformats.org/drawingml/2006/main" xmlns:r="http://schemas.openxmlformats.org/officeDocument/2006/relationships" xmlns:p="http://schemas.openxmlformats.org/presentationml/2006/main">
   <p:cSld>
     <p:spTree>
       <p:nvGrpSpPr>
@@ -3339,7 +3519,14 @@
         <p:cNvGrpSpPr/>
         <p:nvPr/>
       </p:nvGrpSpPr>
-      <p:grpSpPr/>
+      <p:grpSpPr>
+        <a:xfrm>
+          <a:off x="0" y="0"/>
+          <a:ext cx="0" cy="0"/>
+          <a:chOff x="0" y="0"/>
+          <a:chExt cx="0" cy="0"/>
+        </a:xfrm>
+      </p:grpSpPr>
       <p:sp>
         <p:nvSpPr>
           <p:cNvPr id="2" name="TextBox 1"/>
@@ -3371,6 +3558,7 @@
               </a:defRPr>
             </a:pPr>
             <a:r>
+              <a:rPr dirty="0"/>
               <a:t>CAMERA FIELD OF VIEW &amp; COVERAGE MATH</a:t>
             </a:r>
           </a:p>
@@ -3384,8 +3572,8 @@
         </p:nvSpPr>
         <p:spPr>
           <a:xfrm>
-            <a:off x="457200" y="1097280"/>
-            <a:ext cx="4937760" cy="3657600"/>
+            <a:off x="457200" y="774859"/>
+            <a:ext cx="4937760" cy="4185761"/>
           </a:xfrm>
           <a:prstGeom prst="rect">
             <a:avLst/>
@@ -3407,8 +3595,34 @@
               </a:defRPr>
             </a:pPr>
             <a:r>
-              <a:t>• Key Parameters: Focal length (f = 3.61 mm), Sensor size (Sw = 6.17 mm, Sh = 4.55 mm).</a:t>
-            </a:r>
+              <a:rPr sz="1400" dirty="0"/>
+              <a:t>• </a:t>
+            </a:r>
+            <a:r>
+              <a:rPr sz="1400" b="1" dirty="0"/>
+              <a:t>Key Parameters: </a:t>
+            </a:r>
+            <a:r>
+              <a:rPr sz="1400" dirty="0"/>
+              <a:t>Focal length (f = 3.61 mm), Sensor size (</a:t>
+            </a:r>
+            <a:r>
+              <a:rPr sz="1400" dirty="0" err="1"/>
+              <a:t>Sw</a:t>
+            </a:r>
+            <a:r>
+              <a:rPr sz="1400" dirty="0"/>
+              <a:t> = 6.17 mm, </a:t>
+            </a:r>
+            <a:r>
+              <a:rPr sz="1400" dirty="0" err="1"/>
+              <a:t>Sh</a:t>
+            </a:r>
+            <a:r>
+              <a:rPr sz="1400" dirty="0"/>
+              <a:t> = 4.55 mm).</a:t>
+            </a:r>
+            <a:endParaRPr lang="en-IN" sz="1400" dirty="0"/>
           </a:p>
           <a:p>
             <a:pPr>
@@ -3419,8 +3633,24 @@
                 <a:latin typeface="Arial"/>
               </a:defRPr>
             </a:pPr>
-            <a:r>
-              <a:t>• Step 6: Calculating viewing angles (FOV):</a:t>
+            <a:endParaRPr sz="1400" dirty="0"/>
+          </a:p>
+          <a:p>
+            <a:pPr>
+              <a:defRPr sz="1300">
+                <a:solidFill>
+                  <a:srgbClr val="1E1E1E"/>
+                </a:solidFill>
+                <a:latin typeface="Arial"/>
+              </a:defRPr>
+            </a:pPr>
+            <a:r>
+              <a:rPr sz="1400" dirty="0"/>
+              <a:t>• </a:t>
+            </a:r>
+            <a:r>
+              <a:rPr sz="1400" b="1" dirty="0"/>
+              <a:t>Step: Calculating viewing angles (FOV):</a:t>
             </a:r>
           </a:p>
           <a:p>
@@ -3433,7 +3663,16 @@
               </a:defRPr>
             </a:pPr>
             <a:r>
-              <a:t>   - Horizontal FOV = 2 * arctan(Sw / (2 * f)) = 81.03°</a:t>
+              <a:rPr sz="1400" dirty="0"/>
+              <a:t>   - Horizontal FOV = 2 * arctan(</a:t>
+            </a:r>
+            <a:r>
+              <a:rPr sz="1400" dirty="0" err="1"/>
+              <a:t>Sw</a:t>
+            </a:r>
+            <a:r>
+              <a:rPr sz="1400" dirty="0"/>
+              <a:t> / (2 * f)) = 81.03°</a:t>
             </a:r>
           </a:p>
           <a:p>
@@ -3446,8 +3685,29 @@
               </a:defRPr>
             </a:pPr>
             <a:r>
-              <a:t>   - Vertical FOV = 2 * arctan(Sh / (2 * f)) = 64.44°</a:t>
-            </a:r>
+              <a:rPr sz="1400" dirty="0"/>
+              <a:t>   - Vertical FOV = 2 * arctan(</a:t>
+            </a:r>
+            <a:r>
+              <a:rPr sz="1400" dirty="0" err="1"/>
+              <a:t>Sh</a:t>
+            </a:r>
+            <a:r>
+              <a:rPr sz="1400" dirty="0"/>
+              <a:t> / (2 * f)) = 64.44°</a:t>
+            </a:r>
+            <a:endParaRPr lang="en-IN" sz="1400" dirty="0"/>
+          </a:p>
+          <a:p>
+            <a:pPr lvl="1">
+              <a:defRPr sz="1100">
+                <a:solidFill>
+                  <a:srgbClr val="1E1E1E"/>
+                </a:solidFill>
+                <a:latin typeface="Arial"/>
+              </a:defRPr>
+            </a:pPr>
+            <a:endParaRPr sz="1400" dirty="0"/>
           </a:p>
           <a:p>
             <a:pPr>
@@ -3459,7 +3719,12 @@
               </a:defRPr>
             </a:pPr>
             <a:r>
-              <a:t>• Step 7: Ground footprint dimensions (at nadir/straight-down):</a:t>
+              <a:rPr sz="1400" dirty="0"/>
+              <a:t>• </a:t>
+            </a:r>
+            <a:r>
+              <a:rPr sz="1400" b="1" dirty="0"/>
+              <a:t>Step: Ground footprint dimensions (at nadir/straight-down):</a:t>
             </a:r>
           </a:p>
           <a:p>
@@ -3472,6 +3737,7 @@
               </a:defRPr>
             </a:pPr>
             <a:r>
+              <a:rPr sz="1400" dirty="0"/>
               <a:t>   - Width = 2 * Altitude * tan(Horizontal FOV / 2) ≈ 1.71 * Altitude</a:t>
             </a:r>
           </a:p>
@@ -3485,6 +3751,7 @@
               </a:defRPr>
             </a:pPr>
             <a:r>
+              <a:rPr sz="1400" dirty="0"/>
               <a:t>   - Height = 2 * Altitude * tan(Vertical FOV / 2) ≈ 1.28 * Altitude</a:t>
             </a:r>
           </a:p>
@@ -3498,8 +3765,21 @@
               </a:defRPr>
             </a:pPr>
             <a:r>
+              <a:rPr sz="1400" dirty="0"/>
               <a:t>   - Oblique imagery (camera tilt/pitch) distorts rectangles into quadrilaterals.</a:t>
             </a:r>
+            <a:endParaRPr lang="en-IN" sz="1400" dirty="0"/>
+          </a:p>
+          <a:p>
+            <a:pPr lvl="1">
+              <a:defRPr sz="1100">
+                <a:solidFill>
+                  <a:srgbClr val="1E1E1E"/>
+                </a:solidFill>
+                <a:latin typeface="Arial"/>
+              </a:defRPr>
+            </a:pPr>
+            <a:endParaRPr sz="1400" dirty="0"/>
           </a:p>
           <a:p>
             <a:pPr>
@@ -3511,7 +3791,12 @@
               </a:defRPr>
             </a:pPr>
             <a:r>
-              <a:t>• Step 8: 2D Rotation using Yaw Orientation:</a:t>
+              <a:rPr sz="1400" dirty="0"/>
+              <a:t>• </a:t>
+            </a:r>
+            <a:r>
+              <a:rPr sz="1400" b="1" dirty="0"/>
+              <a:t>Step: 2D Rotation using Yaw Orientation:</a:t>
             </a:r>
           </a:p>
           <a:p>
@@ -3524,7 +3809,32 @@
               </a:defRPr>
             </a:pPr>
             <a:r>
-              <a:t>   - X_rot = X_local * cos(yaw) + Y_local * sin(yaw)</a:t>
+              <a:rPr sz="1400" dirty="0"/>
+              <a:t>   - </a:t>
+            </a:r>
+            <a:r>
+              <a:rPr sz="1400" dirty="0" err="1"/>
+              <a:t>X_rot</a:t>
+            </a:r>
+            <a:r>
+              <a:rPr sz="1400" dirty="0"/>
+              <a:t> = </a:t>
+            </a:r>
+            <a:r>
+              <a:rPr sz="1400" dirty="0" err="1"/>
+              <a:t>X_local</a:t>
+            </a:r>
+            <a:r>
+              <a:rPr sz="1400" dirty="0"/>
+              <a:t> * cos(yaw) + </a:t>
+            </a:r>
+            <a:r>
+              <a:rPr sz="1400" dirty="0" err="1"/>
+              <a:t>Y_local</a:t>
+            </a:r>
+            <a:r>
+              <a:rPr sz="1400" dirty="0"/>
+              <a:t> * sin(yaw)</a:t>
             </a:r>
           </a:p>
           <a:p>
@@ -3537,7 +3847,32 @@
               </a:defRPr>
             </a:pPr>
             <a:r>
-              <a:t>   - Y_rot = -X_local * sin(yaw) + Y_local * cos(yaw)</a:t>
+              <a:rPr sz="1400" dirty="0"/>
+              <a:t>   - </a:t>
+            </a:r>
+            <a:r>
+              <a:rPr sz="1400" dirty="0" err="1"/>
+              <a:t>Y_rot</a:t>
+            </a:r>
+            <a:r>
+              <a:rPr sz="1400" dirty="0"/>
+              <a:t> = -</a:t>
+            </a:r>
+            <a:r>
+              <a:rPr sz="1400" dirty="0" err="1"/>
+              <a:t>X_local</a:t>
+            </a:r>
+            <a:r>
+              <a:rPr sz="1400" dirty="0"/>
+              <a:t> * sin(yaw) + </a:t>
+            </a:r>
+            <a:r>
+              <a:rPr sz="1400" dirty="0" err="1"/>
+              <a:t>Y_local</a:t>
+            </a:r>
+            <a:r>
+              <a:rPr sz="1400" dirty="0"/>
+              <a:t> * cos(yaw)</a:t>
             </a:r>
           </a:p>
         </p:txBody>
@@ -3575,7 +3910,7 @@
 </file>
 
 <file path=ppt/slides/slide3.xml><?xml version="1.0" encoding="utf-8"?>
-<p:sld xmlns:a="http://schemas.openxmlformats.org/drawingml/2006/main" xmlns:p="http://schemas.openxmlformats.org/presentationml/2006/main" xmlns:r="http://schemas.openxmlformats.org/officeDocument/2006/relationships">
+<p:sld xmlns:a="http://schemas.openxmlformats.org/drawingml/2006/main" xmlns:r="http://schemas.openxmlformats.org/officeDocument/2006/relationships" xmlns:p="http://schemas.openxmlformats.org/presentationml/2006/main">
   <p:cSld>
     <p:spTree>
       <p:nvGrpSpPr>
@@ -3583,7 +3918,14 @@
         <p:cNvGrpSpPr/>
         <p:nvPr/>
       </p:nvGrpSpPr>
-      <p:grpSpPr/>
+      <p:grpSpPr>
+        <a:xfrm>
+          <a:off x="0" y="0"/>
+          <a:ext cx="0" cy="0"/>
+          <a:chOff x="0" y="0"/>
+          <a:chExt cx="0" cy="0"/>
+        </a:xfrm>
+      </p:grpSpPr>
       <p:sp>
         <p:nvSpPr>
           <p:cNvPr id="2" name="TextBox 1"/>
@@ -3615,7 +3957,7 @@
               </a:defRPr>
             </a:pPr>
             <a:r>
-              <a:t>COORDINATE REFERENCE SYSTEMS &amp; PROJECTIONS</a:t>
+              <a:t>UAV METADATA STANDARDS &amp; FAIR PRINCIPLES</a:t>
             </a:r>
           </a:p>
         </p:txBody>
@@ -3629,7 +3971,7 @@
         <p:spPr>
           <a:xfrm>
             <a:off x="457200" y="1097280"/>
-            <a:ext cx="4937760" cy="3657600"/>
+            <a:ext cx="8229600" cy="2893100"/>
           </a:xfrm>
           <a:prstGeom prst="rect">
             <a:avLst/>
@@ -3651,8 +3993,16 @@
               </a:defRPr>
             </a:pPr>
             <a:r>
-              <a:t>• Global Reference System: Drone images log coordinates in WGS 84 (EPSG:4326) degrees.</a:t>
-            </a:r>
+              <a:rPr sz="1400" dirty="0">
+                <a:latin typeface="Times New Roman" panose="02020603050405020304" pitchFamily="18" charset="0"/>
+                <a:cs typeface="Times New Roman" panose="02020603050405020304" pitchFamily="18" charset="0"/>
+              </a:rPr>
+              <a:t>• Objective: Compare metadata schemas to ensure UAV data interoperability.</a:t>
+            </a:r>
+            <a:endParaRPr lang="en-IN" sz="1400" dirty="0">
+              <a:latin typeface="Times New Roman" panose="02020603050405020304" pitchFamily="18" charset="0"/>
+              <a:cs typeface="Times New Roman" panose="02020603050405020304" pitchFamily="18" charset="0"/>
+            </a:endParaRPr>
           </a:p>
           <a:p>
             <a:pPr>
@@ -3663,9 +4013,10 @@
                 <a:latin typeface="Arial"/>
               </a:defRPr>
             </a:pPr>
-            <a:r>
-              <a:t>• Flattening Map System: Calculations (meters) require projecting to UTM grid.</a:t>
-            </a:r>
+            <a:endParaRPr sz="1400" dirty="0">
+              <a:latin typeface="Times New Roman" panose="02020603050405020304" pitchFamily="18" charset="0"/>
+              <a:cs typeface="Times New Roman" panose="02020603050405020304" pitchFamily="18" charset="0"/>
+            </a:endParaRPr>
           </a:p>
           <a:p>
             <a:pPr>
@@ -3677,8 +4028,16 @@
               </a:defRPr>
             </a:pPr>
             <a:r>
-              <a:t>• UTM Zone 15N (EPSG:32615) covers Duluth, Minnesota area.</a:t>
-            </a:r>
+              <a:rPr sz="1400" dirty="0">
+                <a:latin typeface="Times New Roman" panose="02020603050405020304" pitchFamily="18" charset="0"/>
+                <a:cs typeface="Times New Roman" panose="02020603050405020304" pitchFamily="18" charset="0"/>
+              </a:rPr>
+              <a:t>• Why Metadata Standards Matter: Drone missions produce heterogeneous formats. Standardized tags ensure files are easily discovered and loaded.</a:t>
+            </a:r>
+            <a:endParaRPr lang="en-IN" sz="1400" dirty="0">
+              <a:latin typeface="Times New Roman" panose="02020603050405020304" pitchFamily="18" charset="0"/>
+              <a:cs typeface="Times New Roman" panose="02020603050405020304" pitchFamily="18" charset="0"/>
+            </a:endParaRPr>
           </a:p>
           <a:p>
             <a:pPr>
@@ -3689,8 +4048,26 @@
                 <a:latin typeface="Arial"/>
               </a:defRPr>
             </a:pPr>
-            <a:r>
-              <a:t>• OGR Coordinate Transformations (in C++ App):</a:t>
+            <a:endParaRPr sz="1400" dirty="0">
+              <a:latin typeface="Times New Roman" panose="02020603050405020304" pitchFamily="18" charset="0"/>
+              <a:cs typeface="Times New Roman" panose="02020603050405020304" pitchFamily="18" charset="0"/>
+            </a:endParaRPr>
+          </a:p>
+          <a:p>
+            <a:pPr>
+              <a:defRPr sz="1300">
+                <a:solidFill>
+                  <a:srgbClr val="1E1E1E"/>
+                </a:solidFill>
+                <a:latin typeface="Arial"/>
+              </a:defRPr>
+            </a:pPr>
+            <a:r>
+              <a:rPr sz="1400" dirty="0">
+                <a:latin typeface="Times New Roman" panose="02020603050405020304" pitchFamily="18" charset="0"/>
+                <a:cs typeface="Times New Roman" panose="02020603050405020304" pitchFamily="18" charset="0"/>
+              </a:rPr>
+              <a:t>• FAIR Principles for Drone Data:</a:t>
             </a:r>
           </a:p>
           <a:p>
@@ -3703,7 +4080,25 @@
               </a:defRPr>
             </a:pPr>
             <a:r>
-              <a:t>   - Translates UTM 15N to standard spherical GPS coordinates for GeoJSON export.</a:t>
+              <a:rPr sz="1400" dirty="0">
+                <a:latin typeface="Times New Roman" panose="02020603050405020304" pitchFamily="18" charset="0"/>
+                <a:cs typeface="Times New Roman" panose="02020603050405020304" pitchFamily="18" charset="0"/>
+              </a:rPr>
+              <a:t>   - </a:t>
+            </a:r>
+            <a:r>
+              <a:rPr sz="1400" b="1" dirty="0">
+                <a:latin typeface="Times New Roman" panose="02020603050405020304" pitchFamily="18" charset="0"/>
+                <a:cs typeface="Times New Roman" panose="02020603050405020304" pitchFamily="18" charset="0"/>
+              </a:rPr>
+              <a:t>Findable: </a:t>
+            </a:r>
+            <a:r>
+              <a:rPr sz="1400" dirty="0">
+                <a:latin typeface="Times New Roman" panose="02020603050405020304" pitchFamily="18" charset="0"/>
+                <a:cs typeface="Times New Roman" panose="02020603050405020304" pitchFamily="18" charset="0"/>
+              </a:rPr>
+              <a:t>Standard search terms and unique IDs.</a:t>
             </a:r>
           </a:p>
           <a:p>
@@ -3716,8 +4111,120 @@
               </a:defRPr>
             </a:pPr>
             <a:r>
-              <a:t>   - Translates UTM 15N to UTM 10N (EPSG:32610) to query the dsm.tif GeoTIFF elevation raster.</a:t>
-            </a:r>
+              <a:rPr sz="1400" dirty="0">
+                <a:latin typeface="Times New Roman" panose="02020603050405020304" pitchFamily="18" charset="0"/>
+                <a:cs typeface="Times New Roman" panose="02020603050405020304" pitchFamily="18" charset="0"/>
+              </a:rPr>
+              <a:t>   - </a:t>
+            </a:r>
+            <a:r>
+              <a:rPr sz="1400" b="1" dirty="0">
+                <a:latin typeface="Times New Roman" panose="02020603050405020304" pitchFamily="18" charset="0"/>
+                <a:cs typeface="Times New Roman" panose="02020603050405020304" pitchFamily="18" charset="0"/>
+              </a:rPr>
+              <a:t>Accessible: </a:t>
+            </a:r>
+            <a:r>
+              <a:rPr sz="1400" dirty="0">
+                <a:latin typeface="Times New Roman" panose="02020603050405020304" pitchFamily="18" charset="0"/>
+                <a:cs typeface="Times New Roman" panose="02020603050405020304" pitchFamily="18" charset="0"/>
+              </a:rPr>
+              <a:t>Files are open and </a:t>
+            </a:r>
+            <a:r>
+              <a:rPr sz="1400" dirty="0" err="1">
+                <a:latin typeface="Times New Roman" panose="02020603050405020304" pitchFamily="18" charset="0"/>
+                <a:cs typeface="Times New Roman" panose="02020603050405020304" pitchFamily="18" charset="0"/>
+              </a:rPr>
+              <a:t>queryable</a:t>
+            </a:r>
+            <a:r>
+              <a:rPr sz="1400" dirty="0">
+                <a:latin typeface="Times New Roman" panose="02020603050405020304" pitchFamily="18" charset="0"/>
+                <a:cs typeface="Times New Roman" panose="02020603050405020304" pitchFamily="18" charset="0"/>
+              </a:rPr>
+              <a:t> through API catalogs.</a:t>
+            </a:r>
+          </a:p>
+          <a:p>
+            <a:pPr lvl="1">
+              <a:defRPr sz="1100">
+                <a:solidFill>
+                  <a:srgbClr val="1E1E1E"/>
+                </a:solidFill>
+                <a:latin typeface="Arial"/>
+              </a:defRPr>
+            </a:pPr>
+            <a:r>
+              <a:rPr sz="1400" dirty="0">
+                <a:latin typeface="Times New Roman" panose="02020603050405020304" pitchFamily="18" charset="0"/>
+                <a:cs typeface="Times New Roman" panose="02020603050405020304" pitchFamily="18" charset="0"/>
+              </a:rPr>
+              <a:t>   - </a:t>
+            </a:r>
+            <a:r>
+              <a:rPr sz="1400" b="1" dirty="0">
+                <a:latin typeface="Times New Roman" panose="02020603050405020304" pitchFamily="18" charset="0"/>
+                <a:cs typeface="Times New Roman" panose="02020603050405020304" pitchFamily="18" charset="0"/>
+              </a:rPr>
+              <a:t>Interoperable: </a:t>
+            </a:r>
+            <a:r>
+              <a:rPr sz="1400" dirty="0">
+                <a:latin typeface="Times New Roman" panose="02020603050405020304" pitchFamily="18" charset="0"/>
+                <a:cs typeface="Times New Roman" panose="02020603050405020304" pitchFamily="18" charset="0"/>
+              </a:rPr>
+              <a:t>Common schemas allow direct import into QGIS, ArcGIS, or Python.</a:t>
+            </a:r>
+          </a:p>
+          <a:p>
+            <a:pPr lvl="1">
+              <a:defRPr sz="1100">
+                <a:solidFill>
+                  <a:srgbClr val="1E1E1E"/>
+                </a:solidFill>
+                <a:latin typeface="Arial"/>
+              </a:defRPr>
+            </a:pPr>
+            <a:r>
+              <a:rPr sz="1400" dirty="0">
+                <a:latin typeface="Times New Roman" panose="02020603050405020304" pitchFamily="18" charset="0"/>
+                <a:cs typeface="Times New Roman" panose="02020603050405020304" pitchFamily="18" charset="0"/>
+              </a:rPr>
+              <a:t>   - </a:t>
+            </a:r>
+            <a:r>
+              <a:rPr sz="1400" b="1" dirty="0">
+                <a:latin typeface="Times New Roman" panose="02020603050405020304" pitchFamily="18" charset="0"/>
+                <a:cs typeface="Times New Roman" panose="02020603050405020304" pitchFamily="18" charset="0"/>
+              </a:rPr>
+              <a:t>Reusable: </a:t>
+            </a:r>
+            <a:r>
+              <a:rPr sz="1400" dirty="0">
+                <a:latin typeface="Times New Roman" panose="02020603050405020304" pitchFamily="18" charset="0"/>
+                <a:cs typeface="Times New Roman" panose="02020603050405020304" pitchFamily="18" charset="0"/>
+              </a:rPr>
+              <a:t>Complete details on sensor calibration and coordinates.</a:t>
+            </a:r>
+            <a:endParaRPr lang="en-IN" sz="1400" dirty="0">
+              <a:latin typeface="Times New Roman" panose="02020603050405020304" pitchFamily="18" charset="0"/>
+              <a:cs typeface="Times New Roman" panose="02020603050405020304" pitchFamily="18" charset="0"/>
+            </a:endParaRPr>
+          </a:p>
+          <a:p>
+            <a:pPr lvl="1">
+              <a:defRPr sz="1100">
+                <a:solidFill>
+                  <a:srgbClr val="1E1E1E"/>
+                </a:solidFill>
+                <a:latin typeface="Arial"/>
+              </a:defRPr>
+            </a:pPr>
+            <a:endParaRPr sz="1400" dirty="0">
+              <a:latin typeface="Times New Roman" panose="02020603050405020304" pitchFamily="18" charset="0"/>
+              <a:cs typeface="Times New Roman" panose="02020603050405020304" pitchFamily="18" charset="0"/>
+            </a:endParaRPr>
           </a:p>
           <a:p>
             <a:pPr>
@@ -3729,35 +4236,29 @@
               </a:defRPr>
             </a:pPr>
             <a:r>
-              <a:t>• Robust Parsing: Validates numeric data when reading point cloud text blocks and skips text headers (X,Y,Z) to prevent (0,0) coordinate origin drift.</a:t>
-            </a:r>
-          </a:p>
-        </p:txBody>
-      </p:sp>
-      <p:pic>
-        <p:nvPicPr>
-          <p:cNvPr id="4" name="Picture 3" descr="fig_projections.png"/>
-          <p:cNvPicPr>
-            <a:picLocks noChangeAspect="1"/>
-          </p:cNvPicPr>
-          <p:nvPr/>
-        </p:nvPicPr>
-        <p:blipFill>
-          <a:blip r:embed="rId2"/>
-          <a:stretch>
-            <a:fillRect/>
-          </a:stretch>
-        </p:blipFill>
-        <p:spPr>
-          <a:xfrm>
-            <a:off x="5577840" y="1097280"/>
-            <a:ext cx="3108960" cy="2593155"/>
-          </a:xfrm>
-          <a:prstGeom prst="rect">
-            <a:avLst/>
-          </a:prstGeom>
-        </p:spPr>
-      </p:pic>
+              <a:rPr sz="1400" dirty="0">
+                <a:latin typeface="Times New Roman" panose="02020603050405020304" pitchFamily="18" charset="0"/>
+                <a:cs typeface="Times New Roman" panose="02020603050405020304" pitchFamily="18" charset="0"/>
+              </a:rPr>
+              <a:t>• Key Barrier: Traditional XML schemas (ISO) are heavy, while raw vectors (</a:t>
+            </a:r>
+            <a:r>
+              <a:rPr sz="1400" dirty="0" err="1">
+                <a:latin typeface="Times New Roman" panose="02020603050405020304" pitchFamily="18" charset="0"/>
+                <a:cs typeface="Times New Roman" panose="02020603050405020304" pitchFamily="18" charset="0"/>
+              </a:rPr>
+              <a:t>GeoJSON</a:t>
+            </a:r>
+            <a:r>
+              <a:rPr sz="1400" dirty="0">
+                <a:latin typeface="Times New Roman" panose="02020603050405020304" pitchFamily="18" charset="0"/>
+                <a:cs typeface="Times New Roman" panose="02020603050405020304" pitchFamily="18" charset="0"/>
+              </a:rPr>
+              <a:t>) lack rich sensor calibration attributes.</a:t>
+            </a:r>
+          </a:p>
+        </p:txBody>
+      </p:sp>
     </p:spTree>
   </p:cSld>
   <p:clrMapOvr>
@@ -3767,7 +4268,7 @@
 </file>
 
 <file path=ppt/slides/slide4.xml><?xml version="1.0" encoding="utf-8"?>
-<p:sld xmlns:a="http://schemas.openxmlformats.org/drawingml/2006/main" xmlns:p="http://schemas.openxmlformats.org/presentationml/2006/main" xmlns:r="http://schemas.openxmlformats.org/officeDocument/2006/relationships">
+<p:sld xmlns:a="http://schemas.openxmlformats.org/drawingml/2006/main" xmlns:r="http://schemas.openxmlformats.org/officeDocument/2006/relationships" xmlns:p="http://schemas.openxmlformats.org/presentationml/2006/main">
   <p:cSld>
     <p:spTree>
       <p:nvGrpSpPr>
@@ -3775,7 +4276,14 @@
         <p:cNvGrpSpPr/>
         <p:nvPr/>
       </p:nvGrpSpPr>
-      <p:grpSpPr/>
+      <p:grpSpPr>
+        <a:xfrm>
+          <a:off x="0" y="0"/>
+          <a:ext cx="0" cy="0"/>
+          <a:chOff x="0" y="0"/>
+          <a:chExt cx="0" cy="0"/>
+        </a:xfrm>
+      </p:grpSpPr>
       <p:sp>
         <p:nvSpPr>
           <p:cNvPr id="2" name="TextBox 1"/>
@@ -3807,7 +4315,7 @@
               </a:defRPr>
             </a:pPr>
             <a:r>
-              <a:t>INTERACTIVE MAP VISUALIZERS (C++ &amp; PYTHON)</a:t>
+              <a:t>GEOGRAPHIC METADATA: ISO 19115 &amp; ISO 19139</a:t>
             </a:r>
           </a:p>
         </p:txBody>
@@ -3821,7 +4329,7 @@
         <p:spPr>
           <a:xfrm>
             <a:off x="457200" y="1097280"/>
-            <a:ext cx="8229600" cy="3657600"/>
+            <a:ext cx="8229600" cy="2462213"/>
           </a:xfrm>
           <a:prstGeom prst="rect">
             <a:avLst/>
@@ -3843,8 +4351,61 @@
               </a:defRPr>
             </a:pPr>
             <a:r>
-              <a:t>• Interactive 3D Canvas: Renders point cloud (color-coded by height), flight nodes, and footprints.</a:t>
-            </a:r>
+              <a:rPr sz="1400" dirty="0">
+                <a:latin typeface="Times New Roman" panose="02020603050405020304" pitchFamily="18" charset="0"/>
+                <a:cs typeface="Times New Roman" panose="02020603050405020304" pitchFamily="18" charset="0"/>
+              </a:rPr>
+              <a:t>• </a:t>
+            </a:r>
+            <a:r>
+              <a:rPr sz="1400" b="1" dirty="0">
+                <a:latin typeface="Times New Roman" panose="02020603050405020304" pitchFamily="18" charset="0"/>
+                <a:cs typeface="Times New Roman" panose="02020603050405020304" pitchFamily="18" charset="0"/>
+              </a:rPr>
+              <a:t>ISO 19115 (Metadata Schema): </a:t>
+            </a:r>
+            <a:r>
+              <a:rPr sz="1400" dirty="0">
+                <a:latin typeface="Times New Roman" panose="02020603050405020304" pitchFamily="18" charset="0"/>
+                <a:cs typeface="Times New Roman" panose="02020603050405020304" pitchFamily="18" charset="0"/>
+              </a:rPr>
+              <a:t>The cornerstone international standard for geographic metadata.</a:t>
+            </a:r>
+          </a:p>
+          <a:p>
+            <a:pPr lvl="1">
+              <a:defRPr sz="1100">
+                <a:solidFill>
+                  <a:srgbClr val="1E1E1E"/>
+                </a:solidFill>
+                <a:latin typeface="Arial"/>
+              </a:defRPr>
+            </a:pPr>
+            <a:r>
+              <a:rPr sz="1400" dirty="0">
+                <a:latin typeface="Times New Roman" panose="02020603050405020304" pitchFamily="18" charset="0"/>
+                <a:cs typeface="Times New Roman" panose="02020603050405020304" pitchFamily="18" charset="0"/>
+              </a:rPr>
+              <a:t>   - Defines elements describing geographic datasets (spatial range, data quality, lineage, sensor).</a:t>
+            </a:r>
+            <a:endParaRPr lang="en-IN" sz="1400" dirty="0">
+              <a:latin typeface="Times New Roman" panose="02020603050405020304" pitchFamily="18" charset="0"/>
+              <a:cs typeface="Times New Roman" panose="02020603050405020304" pitchFamily="18" charset="0"/>
+            </a:endParaRPr>
+          </a:p>
+          <a:p>
+            <a:pPr lvl="1">
+              <a:defRPr sz="1100">
+                <a:solidFill>
+                  <a:srgbClr val="1E1E1E"/>
+                </a:solidFill>
+                <a:latin typeface="Arial"/>
+              </a:defRPr>
+            </a:pPr>
+            <a:endParaRPr sz="1400" dirty="0">
+              <a:latin typeface="Times New Roman" panose="02020603050405020304" pitchFamily="18" charset="0"/>
+              <a:cs typeface="Times New Roman" panose="02020603050405020304" pitchFamily="18" charset="0"/>
+            </a:endParaRPr>
           </a:p>
           <a:p>
             <a:pPr>
@@ -3856,7 +4417,18 @@
               </a:defRPr>
             </a:pPr>
             <a:r>
-              <a:t>• Dynamic Photo Warping Overlay:</a:t>
+              <a:rPr sz="1400" dirty="0">
+                <a:latin typeface="Times New Roman" panose="02020603050405020304" pitchFamily="18" charset="0"/>
+                <a:cs typeface="Times New Roman" panose="02020603050405020304" pitchFamily="18" charset="0"/>
+              </a:rPr>
+              <a:t>•</a:t>
+            </a:r>
+            <a:r>
+              <a:rPr sz="1400" b="1" dirty="0">
+                <a:latin typeface="Times New Roman" panose="02020603050405020304" pitchFamily="18" charset="0"/>
+                <a:cs typeface="Times New Roman" panose="02020603050405020304" pitchFamily="18" charset="0"/>
+              </a:rPr>
+              <a:t> ISO 19139 (XML Schema Implementation):</a:t>
             </a:r>
           </a:p>
           <a:p>
@@ -3869,8 +4441,30 @@
               </a:defRPr>
             </a:pPr>
             <a:r>
-              <a:t>   - Applies QTransform matrix to translate, rotate, and scale photos over the point cloud.</a:t>
-            </a:r>
+              <a:rPr sz="1400" dirty="0">
+                <a:latin typeface="Times New Roman" panose="02020603050405020304" pitchFamily="18" charset="0"/>
+                <a:cs typeface="Times New Roman" panose="02020603050405020304" pitchFamily="18" charset="0"/>
+              </a:rPr>
+              <a:t>   - Details how ISO 19115 elements must be structured inside XML files for machine exchanges.</a:t>
+            </a:r>
+            <a:endParaRPr lang="en-IN" sz="1400" dirty="0">
+              <a:latin typeface="Times New Roman" panose="02020603050405020304" pitchFamily="18" charset="0"/>
+              <a:cs typeface="Times New Roman" panose="02020603050405020304" pitchFamily="18" charset="0"/>
+            </a:endParaRPr>
+          </a:p>
+          <a:p>
+            <a:pPr lvl="1">
+              <a:defRPr sz="1100">
+                <a:solidFill>
+                  <a:srgbClr val="1E1E1E"/>
+                </a:solidFill>
+                <a:latin typeface="Arial"/>
+              </a:defRPr>
+            </a:pPr>
+            <a:endParaRPr sz="1400" dirty="0">
+              <a:latin typeface="Times New Roman" panose="02020603050405020304" pitchFamily="18" charset="0"/>
+              <a:cs typeface="Times New Roman" panose="02020603050405020304" pitchFamily="18" charset="0"/>
+            </a:endParaRPr>
           </a:p>
           <a:p>
             <a:pPr>
@@ -3882,7 +4476,18 @@
               </a:defRPr>
             </a:pPr>
             <a:r>
-              <a:t>• GDAL Elevation Querying:</a:t>
+              <a:rPr sz="1400" dirty="0">
+                <a:latin typeface="Times New Roman" panose="02020603050405020304" pitchFamily="18" charset="0"/>
+                <a:cs typeface="Times New Roman" panose="02020603050405020304" pitchFamily="18" charset="0"/>
+              </a:rPr>
+              <a:t>• </a:t>
+            </a:r>
+            <a:r>
+              <a:rPr sz="1400" b="1" dirty="0">
+                <a:latin typeface="Times New Roman" panose="02020603050405020304" pitchFamily="18" charset="0"/>
+                <a:cs typeface="Times New Roman" panose="02020603050405020304" pitchFamily="18" charset="0"/>
+              </a:rPr>
+              <a:t>OGC (Open Geospatial Consortium) Standards:</a:t>
             </a:r>
           </a:p>
           <a:p>
@@ -3895,8 +4500,30 @@
               </a:defRPr>
             </a:pPr>
             <a:r>
-              <a:t>   - Queries float32 elevation values from dsm.tif raster in real-time under the mouse cursor.</a:t>
-            </a:r>
+              <a:rPr sz="1400" dirty="0">
+                <a:latin typeface="Times New Roman" panose="02020603050405020304" pitchFamily="18" charset="0"/>
+                <a:cs typeface="Times New Roman" panose="02020603050405020304" pitchFamily="18" charset="0"/>
+              </a:rPr>
+              <a:t>   - Standardizes services like CSW (Catalog Service for Web) to publish and search ISO XML documents.</a:t>
+            </a:r>
+            <a:endParaRPr lang="en-IN" sz="1400" dirty="0">
+              <a:latin typeface="Times New Roman" panose="02020603050405020304" pitchFamily="18" charset="0"/>
+              <a:cs typeface="Times New Roman" panose="02020603050405020304" pitchFamily="18" charset="0"/>
+            </a:endParaRPr>
+          </a:p>
+          <a:p>
+            <a:pPr lvl="1">
+              <a:defRPr sz="1100">
+                <a:solidFill>
+                  <a:srgbClr val="1E1E1E"/>
+                </a:solidFill>
+                <a:latin typeface="Arial"/>
+              </a:defRPr>
+            </a:pPr>
+            <a:endParaRPr sz="1400" dirty="0">
+              <a:latin typeface="Times New Roman" panose="02020603050405020304" pitchFamily="18" charset="0"/>
+              <a:cs typeface="Times New Roman" panose="02020603050405020304" pitchFamily="18" charset="0"/>
+            </a:endParaRPr>
           </a:p>
           <a:p>
             <a:pPr>
@@ -3908,46 +4535,25 @@
               </a:defRPr>
             </a:pPr>
             <a:r>
-              <a:t>• Dynamic UI sidebar layout (Qt6 Widget structures):</a:t>
-            </a:r>
-          </a:p>
-          <a:p>
-            <a:pPr lvl="1">
-              <a:defRPr sz="1100">
-                <a:solidFill>
-                  <a:srgbClr val="1E1E1E"/>
-                </a:solidFill>
-                <a:latin typeface="Arial"/>
-              </a:defRPr>
-            </a:pPr>
-            <a:r>
-              <a:t>   - Dynamic list selection connects photo markers directly to metadata table.</a:t>
-            </a:r>
-          </a:p>
-          <a:p>
-            <a:pPr lvl="1">
-              <a:defRPr sz="1100">
-                <a:solidFill>
-                  <a:srgbClr val="1E1E1E"/>
-                </a:solidFill>
-                <a:latin typeface="Arial"/>
-              </a:defRPr>
-            </a:pPr>
-            <a:r>
-              <a:t>   - ScrollArea wrapper prevents layout clipping on small monitors.</a:t>
-            </a:r>
-          </a:p>
-          <a:p>
-            <a:pPr lvl="1">
-              <a:defRPr sz="1100">
-                <a:solidFill>
-                  <a:srgbClr val="1E1E1E"/>
-                </a:solidFill>
-                <a:latin typeface="Arial"/>
-              </a:defRPr>
-            </a:pPr>
-            <a:r>
-              <a:t>   - QTableWidget details every EXIF metadata tag (copyable via Ctrl+C).</a:t>
+              <a:rPr sz="1400" dirty="0">
+                <a:latin typeface="Times New Roman" panose="02020603050405020304" pitchFamily="18" charset="0"/>
+                <a:cs typeface="Times New Roman" panose="02020603050405020304" pitchFamily="18" charset="0"/>
+              </a:rPr>
+              <a:t>• </a:t>
+            </a:r>
+            <a:r>
+              <a:rPr sz="1400" u="sng" dirty="0">
+                <a:latin typeface="Times New Roman" panose="02020603050405020304" pitchFamily="18" charset="0"/>
+                <a:cs typeface="Times New Roman" panose="02020603050405020304" pitchFamily="18" charset="0"/>
+              </a:rPr>
+              <a:t>Main Limitation: </a:t>
+            </a:r>
+            <a:r>
+              <a:rPr sz="1400" dirty="0">
+                <a:latin typeface="Times New Roman" panose="02020603050405020304" pitchFamily="18" charset="0"/>
+                <a:cs typeface="Times New Roman" panose="02020603050405020304" pitchFamily="18" charset="0"/>
+              </a:rPr>
+              <a:t>Complex XML encoding makes them difficult for cloud software and web APIs to read rapidly.</a:t>
             </a:r>
           </a:p>
         </p:txBody>
@@ -3961,7 +4567,7 @@
 </file>
 
 <file path=ppt/slides/slide5.xml><?xml version="1.0" encoding="utf-8"?>
-<p:sld xmlns:a="http://schemas.openxmlformats.org/drawingml/2006/main" xmlns:p="http://schemas.openxmlformats.org/presentationml/2006/main" xmlns:r="http://schemas.openxmlformats.org/officeDocument/2006/relationships">
+<p:sld xmlns:a="http://schemas.openxmlformats.org/drawingml/2006/main" xmlns:r="http://schemas.openxmlformats.org/officeDocument/2006/relationships" xmlns:p="http://schemas.openxmlformats.org/presentationml/2006/main">
   <p:cSld>
     <p:spTree>
       <p:nvGrpSpPr>
@@ -3969,7 +4575,14 @@
         <p:cNvGrpSpPr/>
         <p:nvPr/>
       </p:nvGrpSpPr>
-      <p:grpSpPr/>
+      <p:grpSpPr>
+        <a:xfrm>
+          <a:off x="0" y="0"/>
+          <a:ext cx="0" cy="0"/>
+          <a:chOff x="0" y="0"/>
+          <a:chExt cx="0" cy="0"/>
+        </a:xfrm>
+      </p:grpSpPr>
       <p:sp>
         <p:nvSpPr>
           <p:cNvPr id="2" name="TextBox 1"/>
@@ -4001,7 +4614,7 @@
               </a:defRPr>
             </a:pPr>
             <a:r>
-              <a:t>UAV METADATA STANDARDS &amp; FAIR PRINCIPLES</a:t>
+              <a:t>CLOUD-OPTIMIZED FORMATS (COG &amp; COPC)</a:t>
             </a:r>
           </a:p>
         </p:txBody>
@@ -4015,7 +4628,7 @@
         <p:spPr>
           <a:xfrm>
             <a:off x="457200" y="1097280"/>
-            <a:ext cx="8229600" cy="3657600"/>
+            <a:ext cx="8229600" cy="2246769"/>
           </a:xfrm>
           <a:prstGeom prst="rect">
             <a:avLst/>
@@ -4037,8 +4650,123 @@
               </a:defRPr>
             </a:pPr>
             <a:r>
-              <a:t>• Research Objective: Compare metadata schemas to ensure UAV data interoperability.</a:t>
-            </a:r>
+              <a:rPr sz="1400" dirty="0">
+                <a:latin typeface="Times New Roman" panose="02020603050405020304" pitchFamily="18" charset="0"/>
+                <a:cs typeface="Times New Roman" panose="02020603050405020304" pitchFamily="18" charset="0"/>
+              </a:rPr>
+              <a:t>• </a:t>
+            </a:r>
+            <a:r>
+              <a:rPr sz="1400" b="1" dirty="0" err="1">
+                <a:latin typeface="Times New Roman" panose="02020603050405020304" pitchFamily="18" charset="0"/>
+                <a:cs typeface="Times New Roman" panose="02020603050405020304" pitchFamily="18" charset="0"/>
+              </a:rPr>
+              <a:t>GeoTIFF</a:t>
+            </a:r>
+            <a:r>
+              <a:rPr sz="1400" b="1" dirty="0">
+                <a:latin typeface="Times New Roman" panose="02020603050405020304" pitchFamily="18" charset="0"/>
+                <a:cs typeface="Times New Roman" panose="02020603050405020304" pitchFamily="18" charset="0"/>
+              </a:rPr>
+              <a:t> vs. Cloud Optimized </a:t>
+            </a:r>
+            <a:r>
+              <a:rPr sz="1400" b="1" dirty="0" err="1">
+                <a:latin typeface="Times New Roman" panose="02020603050405020304" pitchFamily="18" charset="0"/>
+                <a:cs typeface="Times New Roman" panose="02020603050405020304" pitchFamily="18" charset="0"/>
+              </a:rPr>
+              <a:t>GeoTIFF</a:t>
+            </a:r>
+            <a:r>
+              <a:rPr sz="1400" b="1" dirty="0">
+                <a:latin typeface="Times New Roman" panose="02020603050405020304" pitchFamily="18" charset="0"/>
+                <a:cs typeface="Times New Roman" panose="02020603050405020304" pitchFamily="18" charset="0"/>
+              </a:rPr>
+              <a:t> (COG):</a:t>
+            </a:r>
+          </a:p>
+          <a:p>
+            <a:pPr lvl="1">
+              <a:defRPr sz="1100">
+                <a:solidFill>
+                  <a:srgbClr val="1E1E1E"/>
+                </a:solidFill>
+                <a:latin typeface="Arial"/>
+              </a:defRPr>
+            </a:pPr>
+            <a:r>
+              <a:rPr sz="1400" dirty="0">
+                <a:latin typeface="Times New Roman" panose="02020603050405020304" pitchFamily="18" charset="0"/>
+                <a:cs typeface="Times New Roman" panose="02020603050405020304" pitchFamily="18" charset="0"/>
+              </a:rPr>
+              <a:t>   - Standard </a:t>
+            </a:r>
+            <a:r>
+              <a:rPr sz="1400" dirty="0" err="1">
+                <a:latin typeface="Times New Roman" panose="02020603050405020304" pitchFamily="18" charset="0"/>
+                <a:cs typeface="Times New Roman" panose="02020603050405020304" pitchFamily="18" charset="0"/>
+              </a:rPr>
+              <a:t>GeoTIFF</a:t>
+            </a:r>
+            <a:r>
+              <a:rPr sz="1400" dirty="0">
+                <a:latin typeface="Times New Roman" panose="02020603050405020304" pitchFamily="18" charset="0"/>
+                <a:cs typeface="Times New Roman" panose="02020603050405020304" pitchFamily="18" charset="0"/>
+              </a:rPr>
+              <a:t> has to be read entirely to query an elevation point.</a:t>
+            </a:r>
+          </a:p>
+          <a:p>
+            <a:pPr lvl="1">
+              <a:defRPr sz="1100">
+                <a:solidFill>
+                  <a:srgbClr val="1E1E1E"/>
+                </a:solidFill>
+                <a:latin typeface="Arial"/>
+              </a:defRPr>
+            </a:pPr>
+            <a:r>
+              <a:rPr sz="1400" dirty="0">
+                <a:latin typeface="Times New Roman" panose="02020603050405020304" pitchFamily="18" charset="0"/>
+                <a:cs typeface="Times New Roman" panose="02020603050405020304" pitchFamily="18" charset="0"/>
+              </a:rPr>
+              <a:t>   - COG organizes elevation cells into HTTP range request tiles.</a:t>
+            </a:r>
+          </a:p>
+          <a:p>
+            <a:pPr lvl="1">
+              <a:defRPr sz="1100">
+                <a:solidFill>
+                  <a:srgbClr val="1E1E1E"/>
+                </a:solidFill>
+                <a:latin typeface="Arial"/>
+              </a:defRPr>
+            </a:pPr>
+            <a:r>
+              <a:rPr sz="1400" dirty="0">
+                <a:latin typeface="Times New Roman" panose="02020603050405020304" pitchFamily="18" charset="0"/>
+                <a:cs typeface="Times New Roman" panose="02020603050405020304" pitchFamily="18" charset="0"/>
+              </a:rPr>
+              <a:t>   - Allows GIS apps to query terrain elevation in milliseconds over a network without downloading the full gigabyte file.</a:t>
+            </a:r>
+            <a:endParaRPr lang="en-IN" sz="1400" dirty="0">
+              <a:latin typeface="Times New Roman" panose="02020603050405020304" pitchFamily="18" charset="0"/>
+              <a:cs typeface="Times New Roman" panose="02020603050405020304" pitchFamily="18" charset="0"/>
+            </a:endParaRPr>
+          </a:p>
+          <a:p>
+            <a:pPr lvl="1">
+              <a:defRPr sz="1100">
+                <a:solidFill>
+                  <a:srgbClr val="1E1E1E"/>
+                </a:solidFill>
+                <a:latin typeface="Arial"/>
+              </a:defRPr>
+            </a:pPr>
+            <a:endParaRPr sz="1400" dirty="0">
+              <a:latin typeface="Times New Roman" panose="02020603050405020304" pitchFamily="18" charset="0"/>
+              <a:cs typeface="Times New Roman" panose="02020603050405020304" pitchFamily="18" charset="0"/>
+            </a:endParaRPr>
           </a:p>
           <a:p>
             <a:pPr>
@@ -4050,20 +4778,18 @@
               </a:defRPr>
             </a:pPr>
             <a:r>
-              <a:t>• Why Metadata Standards Matter: Drone missions produce heterogeneous formats. Standardized tags ensure files are easily discovered and loaded.</a:t>
-            </a:r>
-          </a:p>
-          <a:p>
-            <a:pPr>
-              <a:defRPr sz="1300">
-                <a:solidFill>
-                  <a:srgbClr val="1E1E1E"/>
-                </a:solidFill>
-                <a:latin typeface="Arial"/>
-              </a:defRPr>
-            </a:pPr>
-            <a:r>
-              <a:t>• FAIR Principles for Drone Data:</a:t>
+              <a:rPr sz="1400" dirty="0">
+                <a:latin typeface="Times New Roman" panose="02020603050405020304" pitchFamily="18" charset="0"/>
+                <a:cs typeface="Times New Roman" panose="02020603050405020304" pitchFamily="18" charset="0"/>
+              </a:rPr>
+              <a:t>• </a:t>
+            </a:r>
+            <a:r>
+              <a:rPr sz="1400" b="1" dirty="0">
+                <a:latin typeface="Times New Roman" panose="02020603050405020304" pitchFamily="18" charset="0"/>
+                <a:cs typeface="Times New Roman" panose="02020603050405020304" pitchFamily="18" charset="0"/>
+              </a:rPr>
+              <a:t>LAS/LAZ vs. Cloud Optimized Point Cloud (COPC):</a:t>
             </a:r>
           </a:p>
           <a:p>
@@ -4076,7 +4802,11 @@
               </a:defRPr>
             </a:pPr>
             <a:r>
-              <a:t>   - Findable: Standard search terms and unique IDs.</a:t>
+              <a:rPr sz="1400" dirty="0">
+                <a:latin typeface="Times New Roman" panose="02020603050405020304" pitchFamily="18" charset="0"/>
+                <a:cs typeface="Times New Roman" panose="02020603050405020304" pitchFamily="18" charset="0"/>
+              </a:rPr>
+              <a:t>   - LAZ files are compressed point clouds but lack spatial indexes.</a:t>
             </a:r>
           </a:p>
           <a:p>
@@ -4089,7 +4819,11 @@
               </a:defRPr>
             </a:pPr>
             <a:r>
-              <a:t>   - Accessible: Files are open and queryable through API catalogs.</a:t>
+              <a:rPr sz="1400" dirty="0">
+                <a:latin typeface="Times New Roman" panose="02020603050405020304" pitchFamily="18" charset="0"/>
+                <a:cs typeface="Times New Roman" panose="02020603050405020304" pitchFamily="18" charset="0"/>
+              </a:rPr>
+              <a:t>   - COPC structures point clouds as an octree layout inside a LAZ file.</a:t>
             </a:r>
           </a:p>
           <a:p>
@@ -4102,33 +4836,11 @@
               </a:defRPr>
             </a:pPr>
             <a:r>
-              <a:t>   - Interoperable: Common schemas allow direct import into QGIS, ArcGIS, or Python.</a:t>
-            </a:r>
-          </a:p>
-          <a:p>
-            <a:pPr lvl="1">
-              <a:defRPr sz="1100">
-                <a:solidFill>
-                  <a:srgbClr val="1E1E1E"/>
-                </a:solidFill>
-                <a:latin typeface="Arial"/>
-              </a:defRPr>
-            </a:pPr>
-            <a:r>
-              <a:t>   - Reusable: Complete details on sensor calibration and coordinates.</a:t>
-            </a:r>
-          </a:p>
-          <a:p>
-            <a:pPr>
-              <a:defRPr sz="1300">
-                <a:solidFill>
-                  <a:srgbClr val="1E1E1E"/>
-                </a:solidFill>
-                <a:latin typeface="Arial"/>
-              </a:defRPr>
-            </a:pPr>
-            <a:r>
-              <a:t>• Key Barrier: Traditional XML schemas (ISO) are heavy, while raw vectors (GeoJSON) lack rich sensor calibration attributes.</a:t>
+              <a:rPr sz="1400" dirty="0">
+                <a:latin typeface="Times New Roman" panose="02020603050405020304" pitchFamily="18" charset="0"/>
+                <a:cs typeface="Times New Roman" panose="02020603050405020304" pitchFamily="18" charset="0"/>
+              </a:rPr>
+              <a:t>   - Enables streaming of points based on resolution and bounding boxes.</a:t>
             </a:r>
           </a:p>
         </p:txBody>
@@ -4142,7 +4854,7 @@
 </file>
 
 <file path=ppt/slides/slide6.xml><?xml version="1.0" encoding="utf-8"?>
-<p:sld xmlns:a="http://schemas.openxmlformats.org/drawingml/2006/main" xmlns:p="http://schemas.openxmlformats.org/presentationml/2006/main" xmlns:r="http://schemas.openxmlformats.org/officeDocument/2006/relationships">
+<p:sld xmlns:a="http://schemas.openxmlformats.org/drawingml/2006/main" xmlns:r="http://schemas.openxmlformats.org/officeDocument/2006/relationships" xmlns:p="http://schemas.openxmlformats.org/presentationml/2006/main">
   <p:cSld>
     <p:spTree>
       <p:nvGrpSpPr>
@@ -4150,7 +4862,14 @@
         <p:cNvGrpSpPr/>
         <p:nvPr/>
       </p:nvGrpSpPr>
-      <p:grpSpPr/>
+      <p:grpSpPr>
+        <a:xfrm>
+          <a:off x="0" y="0"/>
+          <a:ext cx="0" cy="0"/>
+          <a:chOff x="0" y="0"/>
+          <a:chExt cx="0" cy="0"/>
+        </a:xfrm>
+      </p:grpSpPr>
       <p:sp>
         <p:nvSpPr>
           <p:cNvPr id="2" name="TextBox 1"/>
@@ -4182,7 +4901,7 @@
               </a:defRPr>
             </a:pPr>
             <a:r>
-              <a:t>GEOGRAPHIC METADATA: ISO 19115 &amp; ISO 19139</a:t>
+              <a:t>SPATIOTEMPORAL ASSET CATALOG (STAC)</a:t>
             </a:r>
           </a:p>
         </p:txBody>
@@ -4196,7 +4915,7 @@
         <p:spPr>
           <a:xfrm>
             <a:off x="457200" y="1097280"/>
-            <a:ext cx="8229600" cy="3657600"/>
+            <a:ext cx="7724274" cy="2677656"/>
           </a:xfrm>
           <a:prstGeom prst="rect">
             <a:avLst/>
@@ -4218,7 +4937,60 @@
               </a:defRPr>
             </a:pPr>
             <a:r>
-              <a:t>• ISO 19115 (Metadata Schema): The cornerstone international standard for geographic metadata.</a:t>
+              <a:rPr sz="1400" dirty="0">
+                <a:latin typeface="Times New Roman" panose="02020603050405020304" pitchFamily="18" charset="0"/>
+                <a:cs typeface="Times New Roman" panose="02020603050405020304" pitchFamily="18" charset="0"/>
+              </a:rPr>
+              <a:t>• </a:t>
+            </a:r>
+            <a:r>
+              <a:rPr sz="1400" b="1" dirty="0">
+                <a:latin typeface="Times New Roman" panose="02020603050405020304" pitchFamily="18" charset="0"/>
+                <a:cs typeface="Times New Roman" panose="02020603050405020304" pitchFamily="18" charset="0"/>
+              </a:rPr>
+              <a:t>STAC Specification: </a:t>
+            </a:r>
+            <a:r>
+              <a:rPr sz="1400" dirty="0">
+                <a:latin typeface="Times New Roman" panose="02020603050405020304" pitchFamily="18" charset="0"/>
+                <a:cs typeface="Times New Roman" panose="02020603050405020304" pitchFamily="18" charset="0"/>
+              </a:rPr>
+              <a:t>A modern JSON-LD metadata standard built to catalog geospatial assets (photos, DEMs, point clouds).</a:t>
+            </a:r>
+            <a:endParaRPr lang="en-IN" sz="1400" dirty="0">
+              <a:latin typeface="Times New Roman" panose="02020603050405020304" pitchFamily="18" charset="0"/>
+              <a:cs typeface="Times New Roman" panose="02020603050405020304" pitchFamily="18" charset="0"/>
+            </a:endParaRPr>
+          </a:p>
+          <a:p>
+            <a:pPr>
+              <a:defRPr sz="1300">
+                <a:solidFill>
+                  <a:srgbClr val="1E1E1E"/>
+                </a:solidFill>
+                <a:latin typeface="Arial"/>
+              </a:defRPr>
+            </a:pPr>
+            <a:endParaRPr sz="1400" dirty="0">
+              <a:latin typeface="Times New Roman" panose="02020603050405020304" pitchFamily="18" charset="0"/>
+              <a:cs typeface="Times New Roman" panose="02020603050405020304" pitchFamily="18" charset="0"/>
+            </a:endParaRPr>
+          </a:p>
+          <a:p>
+            <a:pPr>
+              <a:defRPr sz="1300">
+                <a:solidFill>
+                  <a:srgbClr val="1E1E1E"/>
+                </a:solidFill>
+                <a:latin typeface="Arial"/>
+              </a:defRPr>
+            </a:pPr>
+            <a:r>
+              <a:rPr sz="1400" dirty="0">
+                <a:latin typeface="Times New Roman" panose="02020603050405020304" pitchFamily="18" charset="0"/>
+                <a:cs typeface="Times New Roman" panose="02020603050405020304" pitchFamily="18" charset="0"/>
+              </a:rPr>
+              <a:t>• Three core components in the STAC hierarchy:</a:t>
             </a:r>
           </a:p>
           <a:p>
@@ -4231,8 +5003,120 @@
               </a:defRPr>
             </a:pPr>
             <a:r>
-              <a:t>   - Defines elements describing geographic datasets (spatial range, data quality, lineage, sensor).</a:t>
-            </a:r>
+              <a:rPr sz="1400" dirty="0">
+                <a:latin typeface="Times New Roman" panose="02020603050405020304" pitchFamily="18" charset="0"/>
+                <a:cs typeface="Times New Roman" panose="02020603050405020304" pitchFamily="18" charset="0"/>
+              </a:rPr>
+              <a:t>   - </a:t>
+            </a:r>
+            <a:r>
+              <a:rPr sz="1400" b="1" dirty="0">
+                <a:latin typeface="Times New Roman" panose="02020603050405020304" pitchFamily="18" charset="0"/>
+                <a:cs typeface="Times New Roman" panose="02020603050405020304" pitchFamily="18" charset="0"/>
+              </a:rPr>
+              <a:t>STAC Catalog</a:t>
+            </a:r>
+            <a:r>
+              <a:rPr sz="1400" dirty="0">
+                <a:latin typeface="Times New Roman" panose="02020603050405020304" pitchFamily="18" charset="0"/>
+                <a:cs typeface="Times New Roman" panose="02020603050405020304" pitchFamily="18" charset="0"/>
+              </a:rPr>
+              <a:t>: The root JSON file indexing the structure.</a:t>
+            </a:r>
+          </a:p>
+          <a:p>
+            <a:pPr lvl="1">
+              <a:defRPr sz="1100">
+                <a:solidFill>
+                  <a:srgbClr val="1E1E1E"/>
+                </a:solidFill>
+                <a:latin typeface="Arial"/>
+              </a:defRPr>
+            </a:pPr>
+            <a:r>
+              <a:rPr sz="1400" dirty="0">
+                <a:latin typeface="Times New Roman" panose="02020603050405020304" pitchFamily="18" charset="0"/>
+                <a:cs typeface="Times New Roman" panose="02020603050405020304" pitchFamily="18" charset="0"/>
+              </a:rPr>
+              <a:t>   - </a:t>
+            </a:r>
+            <a:r>
+              <a:rPr sz="1400" b="1" dirty="0">
+                <a:latin typeface="Times New Roman" panose="02020603050405020304" pitchFamily="18" charset="0"/>
+                <a:cs typeface="Times New Roman" panose="02020603050405020304" pitchFamily="18" charset="0"/>
+              </a:rPr>
+              <a:t>STAC Collection: </a:t>
+            </a:r>
+            <a:r>
+              <a:rPr sz="1400" dirty="0">
+                <a:latin typeface="Times New Roman" panose="02020603050405020304" pitchFamily="18" charset="0"/>
+                <a:cs typeface="Times New Roman" panose="02020603050405020304" pitchFamily="18" charset="0"/>
+              </a:rPr>
+              <a:t>Groups related UAV images, documenting camera specs, focal length, and spatial boundaries.</a:t>
+            </a:r>
+          </a:p>
+          <a:p>
+            <a:pPr lvl="1">
+              <a:defRPr sz="1100">
+                <a:solidFill>
+                  <a:srgbClr val="1E1E1E"/>
+                </a:solidFill>
+                <a:latin typeface="Arial"/>
+              </a:defRPr>
+            </a:pPr>
+            <a:r>
+              <a:rPr sz="1400" dirty="0">
+                <a:latin typeface="Times New Roman" panose="02020603050405020304" pitchFamily="18" charset="0"/>
+                <a:cs typeface="Times New Roman" panose="02020603050405020304" pitchFamily="18" charset="0"/>
+              </a:rPr>
+              <a:t>   - </a:t>
+            </a:r>
+            <a:r>
+              <a:rPr sz="1400" b="1" dirty="0">
+                <a:latin typeface="Times New Roman" panose="02020603050405020304" pitchFamily="18" charset="0"/>
+                <a:cs typeface="Times New Roman" panose="02020603050405020304" pitchFamily="18" charset="0"/>
+              </a:rPr>
+              <a:t>STAC Item</a:t>
+            </a:r>
+            <a:r>
+              <a:rPr sz="1400" dirty="0">
+                <a:latin typeface="Times New Roman" panose="02020603050405020304" pitchFamily="18" charset="0"/>
+                <a:cs typeface="Times New Roman" panose="02020603050405020304" pitchFamily="18" charset="0"/>
+              </a:rPr>
+              <a:t>: </a:t>
+            </a:r>
+            <a:r>
+              <a:rPr sz="1400" dirty="0" err="1">
+                <a:latin typeface="Times New Roman" panose="02020603050405020304" pitchFamily="18" charset="0"/>
+                <a:cs typeface="Times New Roman" panose="02020603050405020304" pitchFamily="18" charset="0"/>
+              </a:rPr>
+              <a:t>GeoJSON</a:t>
+            </a:r>
+            <a:r>
+              <a:rPr sz="1400" dirty="0">
+                <a:latin typeface="Times New Roman" panose="02020603050405020304" pitchFamily="18" charset="0"/>
+                <a:cs typeface="Times New Roman" panose="02020603050405020304" pitchFamily="18" charset="0"/>
+              </a:rPr>
+              <a:t>-based metadata document describing a single image, linked to the raw JPG asset.</a:t>
+            </a:r>
+            <a:endParaRPr lang="en-IN" sz="1400" dirty="0">
+              <a:latin typeface="Times New Roman" panose="02020603050405020304" pitchFamily="18" charset="0"/>
+              <a:cs typeface="Times New Roman" panose="02020603050405020304" pitchFamily="18" charset="0"/>
+            </a:endParaRPr>
+          </a:p>
+          <a:p>
+            <a:pPr lvl="1">
+              <a:defRPr sz="1100">
+                <a:solidFill>
+                  <a:srgbClr val="1E1E1E"/>
+                </a:solidFill>
+                <a:latin typeface="Arial"/>
+              </a:defRPr>
+            </a:pPr>
+            <a:endParaRPr sz="1400" dirty="0">
+              <a:latin typeface="Times New Roman" panose="02020603050405020304" pitchFamily="18" charset="0"/>
+              <a:cs typeface="Times New Roman" panose="02020603050405020304" pitchFamily="18" charset="0"/>
+            </a:endParaRPr>
           </a:p>
           <a:p>
             <a:pPr>
@@ -4244,59 +5128,25 @@
               </a:defRPr>
             </a:pPr>
             <a:r>
-              <a:t>• ISO 19139 (XML Schema Implementation):</a:t>
-            </a:r>
-          </a:p>
-          <a:p>
-            <a:pPr lvl="1">
-              <a:defRPr sz="1100">
-                <a:solidFill>
-                  <a:srgbClr val="1E1E1E"/>
-                </a:solidFill>
-                <a:latin typeface="Arial"/>
-              </a:defRPr>
-            </a:pPr>
-            <a:r>
-              <a:t>   - Details how ISO 19115 elements must be structured inside XML files for machine exchanges.</a:t>
-            </a:r>
-          </a:p>
-          <a:p>
-            <a:pPr>
-              <a:defRPr sz="1300">
-                <a:solidFill>
-                  <a:srgbClr val="1E1E1E"/>
-                </a:solidFill>
-                <a:latin typeface="Arial"/>
-              </a:defRPr>
-            </a:pPr>
-            <a:r>
-              <a:t>• OGC (Open Geospatial Consortium) Standards:</a:t>
-            </a:r>
-          </a:p>
-          <a:p>
-            <a:pPr lvl="1">
-              <a:defRPr sz="1100">
-                <a:solidFill>
-                  <a:srgbClr val="1E1E1E"/>
-                </a:solidFill>
-                <a:latin typeface="Arial"/>
-              </a:defRPr>
-            </a:pPr>
-            <a:r>
-              <a:t>   - Standardizes services like CSW (Catalog Service for Web) to publish and search ISO XML documents.</a:t>
-            </a:r>
-          </a:p>
-          <a:p>
-            <a:pPr>
-              <a:defRPr sz="1300">
-                <a:solidFill>
-                  <a:srgbClr val="1E1E1E"/>
-                </a:solidFill>
-                <a:latin typeface="Arial"/>
-              </a:defRPr>
-            </a:pPr>
-            <a:r>
-              <a:t>• Main Limitation: Complex XML encoding makes them difficult for cloud software and web APIs to read rapidly.</a:t>
+              <a:rPr sz="1400" dirty="0">
+                <a:latin typeface="Times New Roman" panose="02020603050405020304" pitchFamily="18" charset="0"/>
+                <a:cs typeface="Times New Roman" panose="02020603050405020304" pitchFamily="18" charset="0"/>
+              </a:rPr>
+              <a:t>• </a:t>
+            </a:r>
+            <a:r>
+              <a:rPr sz="1400" b="1" dirty="0">
+                <a:latin typeface="Times New Roman" panose="02020603050405020304" pitchFamily="18" charset="0"/>
+                <a:cs typeface="Times New Roman" panose="02020603050405020304" pitchFamily="18" charset="0"/>
+              </a:rPr>
+              <a:t>STAC API: </a:t>
+            </a:r>
+            <a:r>
+              <a:rPr sz="1400" dirty="0">
+                <a:latin typeface="Times New Roman" panose="02020603050405020304" pitchFamily="18" charset="0"/>
+                <a:cs typeface="Times New Roman" panose="02020603050405020304" pitchFamily="18" charset="0"/>
+              </a:rPr>
+              <a:t>Defines a standard RESTful query API to search drone photos by time ranges and footprint bounding boxes.</a:t>
             </a:r>
           </a:p>
         </p:txBody>
@@ -4310,7 +5160,7 @@
 </file>
 
 <file path=ppt/slides/slide7.xml><?xml version="1.0" encoding="utf-8"?>
-<p:sld xmlns:a="http://schemas.openxmlformats.org/drawingml/2006/main" xmlns:p="http://schemas.openxmlformats.org/presentationml/2006/main" xmlns:r="http://schemas.openxmlformats.org/officeDocument/2006/relationships">
+<p:sld xmlns:a="http://schemas.openxmlformats.org/drawingml/2006/main" xmlns:r="http://schemas.openxmlformats.org/officeDocument/2006/relationships" xmlns:p="http://schemas.openxmlformats.org/presentationml/2006/main">
   <p:cSld>
     <p:spTree>
       <p:nvGrpSpPr>
@@ -4318,7 +5168,14 @@
         <p:cNvGrpSpPr/>
         <p:nvPr/>
       </p:nvGrpSpPr>
-      <p:grpSpPr/>
+      <p:grpSpPr>
+        <a:xfrm>
+          <a:off x="0" y="0"/>
+          <a:ext cx="0" cy="0"/>
+          <a:chOff x="0" y="0"/>
+          <a:chExt cx="0" cy="0"/>
+        </a:xfrm>
+      </p:grpSpPr>
       <p:sp>
         <p:nvSpPr>
           <p:cNvPr id="2" name="TextBox 1"/>
@@ -4350,7 +5207,7 @@
               </a:defRPr>
             </a:pPr>
             <a:r>
-              <a:t>CLOUD-OPTIMIZED FORMATS (COG &amp; COPC)</a:t>
+              <a:t>COMPARATIVE ANALYSIS FOR UAV INTEROPERABILITY</a:t>
             </a:r>
           </a:p>
         </p:txBody>
@@ -4363,8 +5220,8 @@
         </p:nvSpPr>
         <p:spPr>
           <a:xfrm>
-            <a:off x="457200" y="1097280"/>
-            <a:ext cx="8229600" cy="3657600"/>
+            <a:off x="457199" y="1097279"/>
+            <a:ext cx="5048451" cy="3108543"/>
           </a:xfrm>
           <a:prstGeom prst="rect">
             <a:avLst/>
@@ -4386,7 +5243,193 @@
               </a:defRPr>
             </a:pPr>
             <a:r>
-              <a:t>• GeoTIFF vs. Cloud Optimized GeoTIFF (COG):</a:t>
+              <a:rPr sz="1400" dirty="0">
+                <a:latin typeface="Times New Roman" panose="02020603050405020304" pitchFamily="18" charset="0"/>
+                <a:cs typeface="Times New Roman" panose="02020603050405020304" pitchFamily="18" charset="0"/>
+              </a:rPr>
+              <a:t>• </a:t>
+            </a:r>
+            <a:r>
+              <a:rPr sz="1400" b="1" dirty="0">
+                <a:latin typeface="Times New Roman" panose="02020603050405020304" pitchFamily="18" charset="0"/>
+                <a:cs typeface="Times New Roman" panose="02020603050405020304" pitchFamily="18" charset="0"/>
+              </a:rPr>
+              <a:t>ISO Standards: </a:t>
+            </a:r>
+            <a:r>
+              <a:rPr sz="1400" dirty="0">
+                <a:latin typeface="Times New Roman" panose="02020603050405020304" pitchFamily="18" charset="0"/>
+                <a:cs typeface="Times New Roman" panose="02020603050405020304" pitchFamily="18" charset="0"/>
+              </a:rPr>
+              <a:t>Heavyweight, structured for formal catalogs, but difficult to implement for single </a:t>
+            </a:r>
+            <a:r>
+              <a:rPr sz="1400" dirty="0" err="1">
+                <a:latin typeface="Times New Roman" panose="02020603050405020304" pitchFamily="18" charset="0"/>
+                <a:cs typeface="Times New Roman" panose="02020603050405020304" pitchFamily="18" charset="0"/>
+              </a:rPr>
+              <a:t>uav</a:t>
+            </a:r>
+            <a:r>
+              <a:rPr sz="1400" dirty="0">
+                <a:latin typeface="Times New Roman" panose="02020603050405020304" pitchFamily="18" charset="0"/>
+                <a:cs typeface="Times New Roman" panose="02020603050405020304" pitchFamily="18" charset="0"/>
+              </a:rPr>
+              <a:t> frames.</a:t>
+            </a:r>
+            <a:endParaRPr lang="en-IN" sz="1400" dirty="0">
+              <a:latin typeface="Times New Roman" panose="02020603050405020304" pitchFamily="18" charset="0"/>
+              <a:cs typeface="Times New Roman" panose="02020603050405020304" pitchFamily="18" charset="0"/>
+            </a:endParaRPr>
+          </a:p>
+          <a:p>
+            <a:pPr>
+              <a:defRPr sz="1300">
+                <a:solidFill>
+                  <a:srgbClr val="1E1E1E"/>
+                </a:solidFill>
+                <a:latin typeface="Arial"/>
+              </a:defRPr>
+            </a:pPr>
+            <a:endParaRPr sz="1400" dirty="0">
+              <a:latin typeface="Times New Roman" panose="02020603050405020304" pitchFamily="18" charset="0"/>
+              <a:cs typeface="Times New Roman" panose="02020603050405020304" pitchFamily="18" charset="0"/>
+            </a:endParaRPr>
+          </a:p>
+          <a:p>
+            <a:pPr>
+              <a:defRPr sz="1300">
+                <a:solidFill>
+                  <a:srgbClr val="1E1E1E"/>
+                </a:solidFill>
+                <a:latin typeface="Arial"/>
+              </a:defRPr>
+            </a:pPr>
+            <a:r>
+              <a:rPr sz="1400" dirty="0">
+                <a:latin typeface="Times New Roman" panose="02020603050405020304" pitchFamily="18" charset="0"/>
+                <a:cs typeface="Times New Roman" panose="02020603050405020304" pitchFamily="18" charset="0"/>
+              </a:rPr>
+              <a:t>• </a:t>
+            </a:r>
+            <a:r>
+              <a:rPr sz="1400" b="1" dirty="0" err="1">
+                <a:latin typeface="Times New Roman" panose="02020603050405020304" pitchFamily="18" charset="0"/>
+                <a:cs typeface="Times New Roman" panose="02020603050405020304" pitchFamily="18" charset="0"/>
+              </a:rPr>
+              <a:t>GeoJSON</a:t>
+            </a:r>
+            <a:r>
+              <a:rPr sz="1400" b="1" dirty="0">
+                <a:latin typeface="Times New Roman" panose="02020603050405020304" pitchFamily="18" charset="0"/>
+                <a:cs typeface="Times New Roman" panose="02020603050405020304" pitchFamily="18" charset="0"/>
+              </a:rPr>
+              <a:t>: </a:t>
+            </a:r>
+            <a:r>
+              <a:rPr sz="1400" dirty="0">
+                <a:latin typeface="Times New Roman" panose="02020603050405020304" pitchFamily="18" charset="0"/>
+                <a:cs typeface="Times New Roman" panose="02020603050405020304" pitchFamily="18" charset="0"/>
+              </a:rPr>
+              <a:t>Excellent vector format for footprints, but lacks metadata tags for camera calibration and gimbal angles.</a:t>
+            </a:r>
+            <a:endParaRPr lang="en-IN" sz="1400" dirty="0">
+              <a:latin typeface="Times New Roman" panose="02020603050405020304" pitchFamily="18" charset="0"/>
+              <a:cs typeface="Times New Roman" panose="02020603050405020304" pitchFamily="18" charset="0"/>
+            </a:endParaRPr>
+          </a:p>
+          <a:p>
+            <a:pPr>
+              <a:defRPr sz="1300">
+                <a:solidFill>
+                  <a:srgbClr val="1E1E1E"/>
+                </a:solidFill>
+                <a:latin typeface="Arial"/>
+              </a:defRPr>
+            </a:pPr>
+            <a:endParaRPr sz="1400" dirty="0">
+              <a:latin typeface="Times New Roman" panose="02020603050405020304" pitchFamily="18" charset="0"/>
+              <a:cs typeface="Times New Roman" panose="02020603050405020304" pitchFamily="18" charset="0"/>
+            </a:endParaRPr>
+          </a:p>
+          <a:p>
+            <a:pPr>
+              <a:defRPr sz="1300">
+                <a:solidFill>
+                  <a:srgbClr val="1E1E1E"/>
+                </a:solidFill>
+                <a:latin typeface="Arial"/>
+              </a:defRPr>
+            </a:pPr>
+            <a:r>
+              <a:rPr sz="1400" dirty="0">
+                <a:latin typeface="Times New Roman" panose="02020603050405020304" pitchFamily="18" charset="0"/>
+                <a:cs typeface="Times New Roman" panose="02020603050405020304" pitchFamily="18" charset="0"/>
+              </a:rPr>
+              <a:t>• </a:t>
+            </a:r>
+            <a:r>
+              <a:rPr sz="1400" b="1" dirty="0">
+                <a:latin typeface="Times New Roman" panose="02020603050405020304" pitchFamily="18" charset="0"/>
+                <a:cs typeface="Times New Roman" panose="02020603050405020304" pitchFamily="18" charset="0"/>
+              </a:rPr>
+              <a:t>STAC: </a:t>
+            </a:r>
+            <a:r>
+              <a:rPr sz="1400" dirty="0">
+                <a:latin typeface="Times New Roman" panose="02020603050405020304" pitchFamily="18" charset="0"/>
+                <a:cs typeface="Times New Roman" panose="02020603050405020304" pitchFamily="18" charset="0"/>
+              </a:rPr>
+              <a:t>Combines the best of both worlds. Represents footprints in </a:t>
+            </a:r>
+            <a:r>
+              <a:rPr sz="1400" dirty="0" err="1">
+                <a:latin typeface="Times New Roman" panose="02020603050405020304" pitchFamily="18" charset="0"/>
+                <a:cs typeface="Times New Roman" panose="02020603050405020304" pitchFamily="18" charset="0"/>
+              </a:rPr>
+              <a:t>GeoJSON</a:t>
+            </a:r>
+            <a:r>
+              <a:rPr sz="1400" dirty="0">
+                <a:latin typeface="Times New Roman" panose="02020603050405020304" pitchFamily="18" charset="0"/>
+                <a:cs typeface="Times New Roman" panose="02020603050405020304" pitchFamily="18" charset="0"/>
+              </a:rPr>
+              <a:t> while storing rich camera assets and flight telemetry in structured JSON-LD properties.</a:t>
+            </a:r>
+            <a:endParaRPr lang="en-IN" sz="1400" dirty="0">
+              <a:latin typeface="Times New Roman" panose="02020603050405020304" pitchFamily="18" charset="0"/>
+              <a:cs typeface="Times New Roman" panose="02020603050405020304" pitchFamily="18" charset="0"/>
+            </a:endParaRPr>
+          </a:p>
+          <a:p>
+            <a:pPr>
+              <a:defRPr sz="1300">
+                <a:solidFill>
+                  <a:srgbClr val="1E1E1E"/>
+                </a:solidFill>
+                <a:latin typeface="Arial"/>
+              </a:defRPr>
+            </a:pPr>
+            <a:endParaRPr sz="1400" dirty="0">
+              <a:latin typeface="Times New Roman" panose="02020603050405020304" pitchFamily="18" charset="0"/>
+              <a:cs typeface="Times New Roman" panose="02020603050405020304" pitchFamily="18" charset="0"/>
+            </a:endParaRPr>
+          </a:p>
+          <a:p>
+            <a:pPr>
+              <a:defRPr sz="1300">
+                <a:solidFill>
+                  <a:srgbClr val="1E1E1E"/>
+                </a:solidFill>
+                <a:latin typeface="Arial"/>
+              </a:defRPr>
+            </a:pPr>
+            <a:r>
+              <a:rPr sz="1400" dirty="0">
+                <a:latin typeface="Times New Roman" panose="02020603050405020304" pitchFamily="18" charset="0"/>
+                <a:cs typeface="Times New Roman" panose="02020603050405020304" pitchFamily="18" charset="0"/>
+              </a:rPr>
+              <a:t>• Recommendation for UAV GIS Workflows:</a:t>
             </a:r>
           </a:p>
           <a:p>
@@ -4399,7 +5442,11 @@
               </a:defRPr>
             </a:pPr>
             <a:r>
-              <a:t>   - Standard GeoTIFF has to be read entirely to query an elevation point.</a:t>
+              <a:rPr sz="1400" dirty="0">
+                <a:latin typeface="Times New Roman" panose="02020603050405020304" pitchFamily="18" charset="0"/>
+                <a:cs typeface="Times New Roman" panose="02020603050405020304" pitchFamily="18" charset="0"/>
+              </a:rPr>
+              <a:t>   - Store raw telemetry in STAC Items.</a:t>
             </a:r>
           </a:p>
           <a:p>
@@ -4412,7 +5459,25 @@
               </a:defRPr>
             </a:pPr>
             <a:r>
-              <a:t>   - COG organizes elevation cells into HTTP range request tiles.</a:t>
+              <a:rPr sz="1400" dirty="0">
+                <a:latin typeface="Times New Roman" panose="02020603050405020304" pitchFamily="18" charset="0"/>
+                <a:cs typeface="Times New Roman" panose="02020603050405020304" pitchFamily="18" charset="0"/>
+              </a:rPr>
+              <a:t>   - Export footprint boundaries as </a:t>
+            </a:r>
+            <a:r>
+              <a:rPr sz="1400" dirty="0" err="1">
+                <a:latin typeface="Times New Roman" panose="02020603050405020304" pitchFamily="18" charset="0"/>
+                <a:cs typeface="Times New Roman" panose="02020603050405020304" pitchFamily="18" charset="0"/>
+              </a:rPr>
+              <a:t>GeoJSON</a:t>
+            </a:r>
+            <a:r>
+              <a:rPr sz="1400" dirty="0">
+                <a:latin typeface="Times New Roman" panose="02020603050405020304" pitchFamily="18" charset="0"/>
+                <a:cs typeface="Times New Roman" panose="02020603050405020304" pitchFamily="18" charset="0"/>
+              </a:rPr>
+              <a:t> features.</a:t>
             </a:r>
           </a:p>
           <a:p>
@@ -4425,405 +5490,10 @@
               </a:defRPr>
             </a:pPr>
             <a:r>
-              <a:t>   - Allows GIS apps to query terrain elevation in milliseconds over a network without downloading the full gigabyte file.</a:t>
-            </a:r>
-          </a:p>
-          <a:p>
-            <a:pPr>
-              <a:defRPr sz="1300">
-                <a:solidFill>
-                  <a:srgbClr val="1E1E1E"/>
-                </a:solidFill>
-                <a:latin typeface="Arial"/>
-              </a:defRPr>
-            </a:pPr>
-            <a:r>
-              <a:t>• LAS/LAZ vs. Cloud Optimized Point Cloud (COPC):</a:t>
-            </a:r>
-          </a:p>
-          <a:p>
-            <a:pPr lvl="1">
-              <a:defRPr sz="1100">
-                <a:solidFill>
-                  <a:srgbClr val="1E1E1E"/>
-                </a:solidFill>
-                <a:latin typeface="Arial"/>
-              </a:defRPr>
-            </a:pPr>
-            <a:r>
-              <a:t>   - LAZ files are compressed point clouds but lack spatial indexes.</a:t>
-            </a:r>
-          </a:p>
-          <a:p>
-            <a:pPr lvl="1">
-              <a:defRPr sz="1100">
-                <a:solidFill>
-                  <a:srgbClr val="1E1E1E"/>
-                </a:solidFill>
-                <a:latin typeface="Arial"/>
-              </a:defRPr>
-            </a:pPr>
-            <a:r>
-              <a:t>   - COPC structures point clouds as an octree layout inside a LAZ file.</a:t>
-            </a:r>
-          </a:p>
-          <a:p>
-            <a:pPr lvl="1">
-              <a:defRPr sz="1100">
-                <a:solidFill>
-                  <a:srgbClr val="1E1E1E"/>
-                </a:solidFill>
-                <a:latin typeface="Arial"/>
-              </a:defRPr>
-            </a:pPr>
-            <a:r>
-              <a:t>   - Enables streaming of points based on resolution and bounding boxes.</a:t>
-            </a:r>
-          </a:p>
-        </p:txBody>
-      </p:sp>
-    </p:spTree>
-  </p:cSld>
-  <p:clrMapOvr>
-    <a:masterClrMapping/>
-  </p:clrMapOvr>
-</p:sld>
-</file>
-
-<file path=ppt/slides/slide8.xml><?xml version="1.0" encoding="utf-8"?>
-<p:sld xmlns:a="http://schemas.openxmlformats.org/drawingml/2006/main" xmlns:p="http://schemas.openxmlformats.org/presentationml/2006/main" xmlns:r="http://schemas.openxmlformats.org/officeDocument/2006/relationships">
-  <p:cSld>
-    <p:spTree>
-      <p:nvGrpSpPr>
-        <p:cNvPr id="1" name=""/>
-        <p:cNvGrpSpPr/>
-        <p:nvPr/>
-      </p:nvGrpSpPr>
-      <p:grpSpPr/>
-      <p:sp>
-        <p:nvSpPr>
-          <p:cNvPr id="2" name="TextBox 1"/>
-          <p:cNvSpPr txBox="1"/>
-          <p:nvPr/>
-        </p:nvSpPr>
-        <p:spPr>
-          <a:xfrm>
-            <a:off x="457200" y="182880"/>
-            <a:ext cx="8229600" cy="731520"/>
-          </a:xfrm>
-          <a:prstGeom prst="rect">
-            <a:avLst/>
-          </a:prstGeom>
-          <a:noFill/>
-        </p:spPr>
-        <p:txBody>
-          <a:bodyPr wrap="square">
-            <a:spAutoFit/>
-          </a:bodyPr>
-          <a:lstStyle/>
-          <a:p>
-            <a:pPr algn="ctr">
-              <a:defRPr sz="2400" b="1" u="sng">
-                <a:solidFill>
-                  <a:srgbClr val="33B3FF"/>
-                </a:solidFill>
-                <a:latin typeface="Arial"/>
-              </a:defRPr>
-            </a:pPr>
-            <a:r>
-              <a:t>SPATIOTEMPORAL ASSET CATALOG (STAC)</a:t>
-            </a:r>
-          </a:p>
-        </p:txBody>
-      </p:sp>
-      <p:sp>
-        <p:nvSpPr>
-          <p:cNvPr id="3" name="TextBox 2"/>
-          <p:cNvSpPr txBox="1"/>
-          <p:nvPr/>
-        </p:nvSpPr>
-        <p:spPr>
-          <a:xfrm>
-            <a:off x="457200" y="1097280"/>
-            <a:ext cx="4937760" cy="3657600"/>
-          </a:xfrm>
-          <a:prstGeom prst="rect">
-            <a:avLst/>
-          </a:prstGeom>
-          <a:noFill/>
-        </p:spPr>
-        <p:txBody>
-          <a:bodyPr wrap="square">
-            <a:spAutoFit/>
-          </a:bodyPr>
-          <a:lstStyle/>
-          <a:p>
-            <a:pPr>
-              <a:defRPr sz="1300">
-                <a:solidFill>
-                  <a:srgbClr val="1E1E1E"/>
-                </a:solidFill>
-                <a:latin typeface="Arial"/>
-              </a:defRPr>
-            </a:pPr>
-            <a:r>
-              <a:t>• STAC Specification: A modern JSON-LD metadata standard built to catalog geospatial assets (photos, DEMs, point clouds).</a:t>
-            </a:r>
-          </a:p>
-          <a:p>
-            <a:pPr>
-              <a:defRPr sz="1300">
-                <a:solidFill>
-                  <a:srgbClr val="1E1E1E"/>
-                </a:solidFill>
-                <a:latin typeface="Arial"/>
-              </a:defRPr>
-            </a:pPr>
-            <a:r>
-              <a:t>• Three core components in the STAC hierarchy:</a:t>
-            </a:r>
-          </a:p>
-          <a:p>
-            <a:pPr lvl="1">
-              <a:defRPr sz="1100">
-                <a:solidFill>
-                  <a:srgbClr val="1E1E1E"/>
-                </a:solidFill>
-                <a:latin typeface="Arial"/>
-              </a:defRPr>
-            </a:pPr>
-            <a:r>
-              <a:t>   - STAC Catalog: The root JSON file indexing the structure.</a:t>
-            </a:r>
-          </a:p>
-          <a:p>
-            <a:pPr lvl="1">
-              <a:defRPr sz="1100">
-                <a:solidFill>
-                  <a:srgbClr val="1E1E1E"/>
-                </a:solidFill>
-                <a:latin typeface="Arial"/>
-              </a:defRPr>
-            </a:pPr>
-            <a:r>
-              <a:t>   - STAC Collection: Groups related UAV images, documenting camera specs, focal length, and spatial boundaries.</a:t>
-            </a:r>
-          </a:p>
-          <a:p>
-            <a:pPr lvl="1">
-              <a:defRPr sz="1100">
-                <a:solidFill>
-                  <a:srgbClr val="1E1E1E"/>
-                </a:solidFill>
-                <a:latin typeface="Arial"/>
-              </a:defRPr>
-            </a:pPr>
-            <a:r>
-              <a:t>   - STAC Item: GeoJSON-based metadata document describing a single image, linked to the raw JPG asset.</a:t>
-            </a:r>
-          </a:p>
-          <a:p>
-            <a:pPr>
-              <a:defRPr sz="1300">
-                <a:solidFill>
-                  <a:srgbClr val="1E1E1E"/>
-                </a:solidFill>
-                <a:latin typeface="Arial"/>
-              </a:defRPr>
-            </a:pPr>
-            <a:r>
-              <a:t>• STAC API: Defines a standard RESTful query API to search drone photos by time ranges and footprint bounding boxes.</a:t>
-            </a:r>
-          </a:p>
-        </p:txBody>
-      </p:sp>
-      <p:pic>
-        <p:nvPicPr>
-          <p:cNvPr id="4" name="Picture 3" descr="fig_stac.png"/>
-          <p:cNvPicPr>
-            <a:picLocks noChangeAspect="1"/>
-          </p:cNvPicPr>
-          <p:nvPr/>
-        </p:nvPicPr>
-        <p:blipFill>
-          <a:blip r:embed="rId2"/>
-          <a:stretch>
-            <a:fillRect/>
-          </a:stretch>
-        </p:blipFill>
-        <p:spPr>
-          <a:xfrm>
-            <a:off x="5577840" y="1097280"/>
-            <a:ext cx="3108960" cy="2872185"/>
-          </a:xfrm>
-          <a:prstGeom prst="rect">
-            <a:avLst/>
-          </a:prstGeom>
-        </p:spPr>
-      </p:pic>
-    </p:spTree>
-  </p:cSld>
-  <p:clrMapOvr>
-    <a:masterClrMapping/>
-  </p:clrMapOvr>
-</p:sld>
-</file>
-
-<file path=ppt/slides/slide9.xml><?xml version="1.0" encoding="utf-8"?>
-<p:sld xmlns:a="http://schemas.openxmlformats.org/drawingml/2006/main" xmlns:p="http://schemas.openxmlformats.org/presentationml/2006/main" xmlns:r="http://schemas.openxmlformats.org/officeDocument/2006/relationships">
-  <p:cSld>
-    <p:spTree>
-      <p:nvGrpSpPr>
-        <p:cNvPr id="1" name=""/>
-        <p:cNvGrpSpPr/>
-        <p:nvPr/>
-      </p:nvGrpSpPr>
-      <p:grpSpPr/>
-      <p:sp>
-        <p:nvSpPr>
-          <p:cNvPr id="2" name="TextBox 1"/>
-          <p:cNvSpPr txBox="1"/>
-          <p:nvPr/>
-        </p:nvSpPr>
-        <p:spPr>
-          <a:xfrm>
-            <a:off x="457200" y="182880"/>
-            <a:ext cx="8229600" cy="731520"/>
-          </a:xfrm>
-          <a:prstGeom prst="rect">
-            <a:avLst/>
-          </a:prstGeom>
-          <a:noFill/>
-        </p:spPr>
-        <p:txBody>
-          <a:bodyPr wrap="square">
-            <a:spAutoFit/>
-          </a:bodyPr>
-          <a:lstStyle/>
-          <a:p>
-            <a:pPr algn="ctr">
-              <a:defRPr sz="2400" b="1" u="sng">
-                <a:solidFill>
-                  <a:srgbClr val="33B3FF"/>
-                </a:solidFill>
-                <a:latin typeface="Arial"/>
-              </a:defRPr>
-            </a:pPr>
-            <a:r>
-              <a:t>COMPARATIVE ANALYSIS FOR UAV INTEROPERABILITY</a:t>
-            </a:r>
-          </a:p>
-        </p:txBody>
-      </p:sp>
-      <p:sp>
-        <p:nvSpPr>
-          <p:cNvPr id="3" name="TextBox 2"/>
-          <p:cNvSpPr txBox="1"/>
-          <p:nvPr/>
-        </p:nvSpPr>
-        <p:spPr>
-          <a:xfrm>
-            <a:off x="457200" y="1097280"/>
-            <a:ext cx="4937760" cy="3657600"/>
-          </a:xfrm>
-          <a:prstGeom prst="rect">
-            <a:avLst/>
-          </a:prstGeom>
-          <a:noFill/>
-        </p:spPr>
-        <p:txBody>
-          <a:bodyPr wrap="square">
-            <a:spAutoFit/>
-          </a:bodyPr>
-          <a:lstStyle/>
-          <a:p>
-            <a:pPr>
-              <a:defRPr sz="1300">
-                <a:solidFill>
-                  <a:srgbClr val="1E1E1E"/>
-                </a:solidFill>
-                <a:latin typeface="Arial"/>
-              </a:defRPr>
-            </a:pPr>
-            <a:r>
-              <a:t>• ISO Standards: Heavyweight, structured for formal catalogs, but difficult to implement for single uav frames.</a:t>
-            </a:r>
-          </a:p>
-          <a:p>
-            <a:pPr>
-              <a:defRPr sz="1300">
-                <a:solidFill>
-                  <a:srgbClr val="1E1E1E"/>
-                </a:solidFill>
-                <a:latin typeface="Arial"/>
-              </a:defRPr>
-            </a:pPr>
-            <a:r>
-              <a:t>• GeoJSON: Excellent vector format for footprints, but lacks metadata tags for camera calibration and gimbal angles.</a:t>
-            </a:r>
-          </a:p>
-          <a:p>
-            <a:pPr>
-              <a:defRPr sz="1300">
-                <a:solidFill>
-                  <a:srgbClr val="1E1E1E"/>
-                </a:solidFill>
-                <a:latin typeface="Arial"/>
-              </a:defRPr>
-            </a:pPr>
-            <a:r>
-              <a:t>• STAC: Combines the best of both worlds. Represents footprints in GeoJSON while storing rich camera assets and flight telemetry in structured JSON-LD properties.</a:t>
-            </a:r>
-          </a:p>
-          <a:p>
-            <a:pPr>
-              <a:defRPr sz="1300">
-                <a:solidFill>
-                  <a:srgbClr val="1E1E1E"/>
-                </a:solidFill>
-                <a:latin typeface="Arial"/>
-              </a:defRPr>
-            </a:pPr>
-            <a:r>
-              <a:t>• Recommendation for UAV GIS Workflows:</a:t>
-            </a:r>
-          </a:p>
-          <a:p>
-            <a:pPr lvl="1">
-              <a:defRPr sz="1100">
-                <a:solidFill>
-                  <a:srgbClr val="1E1E1E"/>
-                </a:solidFill>
-                <a:latin typeface="Arial"/>
-              </a:defRPr>
-            </a:pPr>
-            <a:r>
-              <a:t>   - Store raw telemetry in STAC Items.</a:t>
-            </a:r>
-          </a:p>
-          <a:p>
-            <a:pPr lvl="1">
-              <a:defRPr sz="1100">
-                <a:solidFill>
-                  <a:srgbClr val="1E1E1E"/>
-                </a:solidFill>
-                <a:latin typeface="Arial"/>
-              </a:defRPr>
-            </a:pPr>
-            <a:r>
-              <a:t>   - Export footprint boundaries as GeoJSON features.</a:t>
-            </a:r>
-          </a:p>
-          <a:p>
-            <a:pPr lvl="1">
-              <a:defRPr sz="1100">
-                <a:solidFill>
-                  <a:srgbClr val="1E1E1E"/>
-                </a:solidFill>
-                <a:latin typeface="Arial"/>
-              </a:defRPr>
-            </a:pPr>
-            <a:r>
+              <a:rPr sz="1400" dirty="0">
+                <a:latin typeface="Times New Roman" panose="02020603050405020304" pitchFamily="18" charset="0"/>
+                <a:cs typeface="Times New Roman" panose="02020603050405020304" pitchFamily="18" charset="0"/>
+              </a:rPr>
               <a:t>   - Stream elevation and point clouds via COG and COPC.</a:t>
             </a:r>
           </a:p>
@@ -4839,14 +5509,13 @@
         </p:nvPicPr>
         <p:blipFill>
           <a:blip r:embed="rId2"/>
-          <a:stretch>
-            <a:fillRect/>
-          </a:stretch>
+          <a:srcRect t="26553" b="24676"/>
+          <a:stretch/>
         </p:blipFill>
         <p:spPr>
           <a:xfrm>
-            <a:off x="5577840" y="1097280"/>
-            <a:ext cx="3108960" cy="1957493"/>
+            <a:off x="5577839" y="1617045"/>
+            <a:ext cx="3421781" cy="1790298"/>
           </a:xfrm>
           <a:prstGeom prst="rect">
             <a:avLst/>

</xml_diff>

<commit_message>
Update PowerPoint slides with corrected vertical FOV and footprint coverage math for 16:9 crop
</commit_message>
<xml_diff>
--- a/Drone_Footprint_Mapping_and_Metadata_Standards.pptx
+++ b/Drone_Footprint_Mapping_and_Metadata_Standards.pptx
@@ -5,15 +5,17 @@
     <p:sldMasterId id="2147483648" r:id="rId1"/>
   </p:sldMasterIdLst>
   <p:sldIdLst>
-    <p:sldId id="256" r:id="rId2"/>
-    <p:sldId id="257" r:id="rId3"/>
-    <p:sldId id="260" r:id="rId4"/>
-    <p:sldId id="261" r:id="rId5"/>
-    <p:sldId id="262" r:id="rId6"/>
-    <p:sldId id="263" r:id="rId7"/>
-    <p:sldId id="264" r:id="rId8"/>
+    <p:sldId id="256" r:id="rId7"/>
+    <p:sldId id="257" r:id="rId8"/>
+    <p:sldId id="258" r:id="rId9"/>
+    <p:sldId id="259" r:id="rId10"/>
+    <p:sldId id="260" r:id="rId11"/>
+    <p:sldId id="261" r:id="rId12"/>
+    <p:sldId id="262" r:id="rId13"/>
+    <p:sldId id="263" r:id="rId14"/>
+    <p:sldId id="264" r:id="rId15"/>
   </p:sldIdLst>
-  <p:sldSz cx="9144000" cy="5143500" type="screen16x9"/>
+  <p:sldSz cx="9144000" cy="5143500" type="screen4x3"/>
   <p:notesSz cx="6858000" cy="9144000"/>
   <p:defaultTextStyle>
     <a:defPPr>
@@ -110,22 +112,6 @@
       </a:defRPr>
     </a:lvl9pPr>
   </p:defaultTextStyle>
-  <p:extLst>
-    <p:ext uri="{EFAFB233-063F-42B5-8137-9DF3F51BA10A}">
-      <p15:sldGuideLst xmlns:p15="http://schemas.microsoft.com/office/powerpoint/2012/main">
-        <p15:guide id="1" orient="horz" pos="2160">
-          <p15:clr>
-            <a:srgbClr val="A4A3A4"/>
-          </p15:clr>
-        </p15:guide>
-        <p15:guide id="2" pos="2880">
-          <p15:clr>
-            <a:srgbClr val="A4A3A4"/>
-          </p15:clr>
-        </p15:guide>
-      </p15:sldGuideLst>
-    </p:ext>
-  </p:extLst>
 </p:presentation>
 </file>
 
@@ -167,9 +153,10 @@
           <a:lstStyle/>
           <a:p>
             <a:r>
-              <a:rPr lang="en-US"/>
+              <a:rPr lang="en-US" smtClean="0"/>
               <a:t>Click to edit Master title style</a:t>
             </a:r>
+            <a:endParaRPr lang="en-US"/>
           </a:p>
         </p:txBody>
       </p:sp>
@@ -285,9 +272,10 @@
           </a:lstStyle>
           <a:p>
             <a:r>
-              <a:rPr lang="en-US"/>
+              <a:rPr lang="en-US" smtClean="0"/>
               <a:t>Click to edit Master subtitle style</a:t>
             </a:r>
+            <a:endParaRPr lang="en-US"/>
           </a:p>
         </p:txBody>
       </p:sp>
@@ -308,7 +296,7 @@
           <a:p>
             <a:fld id="{5BCAD085-E8A6-8845-BD4E-CB4CCA059FC4}" type="datetimeFigureOut">
               <a:rPr lang="en-US" smtClean="0"/>
-              <a:t>8/10/2026</a:t>
+              <a:t>1/27/13</a:t>
             </a:fld>
             <a:endParaRPr lang="en-US"/>
           </a:p>
@@ -402,9 +390,10 @@
           <a:lstStyle/>
           <a:p>
             <a:r>
-              <a:rPr lang="en-US"/>
+              <a:rPr lang="en-US" smtClean="0"/>
               <a:t>Click to edit Master title style</a:t>
             </a:r>
+            <a:endParaRPr lang="en-US"/>
           </a:p>
         </p:txBody>
       </p:sp>
@@ -425,37 +414,38 @@
           <a:p>
             <a:pPr lvl="0"/>
             <a:r>
-              <a:rPr lang="en-US"/>
+              <a:rPr lang="en-US" smtClean="0"/>
               <a:t>Click to edit Master text styles</a:t>
             </a:r>
           </a:p>
           <a:p>
             <a:pPr lvl="1"/>
             <a:r>
-              <a:rPr lang="en-US"/>
+              <a:rPr lang="en-US" smtClean="0"/>
               <a:t>Second level</a:t>
             </a:r>
           </a:p>
           <a:p>
             <a:pPr lvl="2"/>
             <a:r>
-              <a:rPr lang="en-US"/>
+              <a:rPr lang="en-US" smtClean="0"/>
               <a:t>Third level</a:t>
             </a:r>
           </a:p>
           <a:p>
             <a:pPr lvl="3"/>
             <a:r>
-              <a:rPr lang="en-US"/>
+              <a:rPr lang="en-US" smtClean="0"/>
               <a:t>Fourth level</a:t>
             </a:r>
           </a:p>
           <a:p>
             <a:pPr lvl="4"/>
             <a:r>
-              <a:rPr lang="en-US"/>
+              <a:rPr lang="en-US" smtClean="0"/>
               <a:t>Fifth level</a:t>
             </a:r>
+            <a:endParaRPr lang="en-US"/>
           </a:p>
         </p:txBody>
       </p:sp>
@@ -476,7 +466,7 @@
           <a:p>
             <a:fld id="{5BCAD085-E8A6-8845-BD4E-CB4CCA059FC4}" type="datetimeFigureOut">
               <a:rPr lang="en-US" smtClean="0"/>
-              <a:t>8/10/2026</a:t>
+              <a:t>1/27/13</a:t>
             </a:fld>
             <a:endParaRPr lang="en-US"/>
           </a:p>
@@ -575,9 +565,10 @@
           <a:lstStyle/>
           <a:p>
             <a:r>
-              <a:rPr lang="en-US"/>
+              <a:rPr lang="en-US" smtClean="0"/>
               <a:t>Click to edit Master title style</a:t>
             </a:r>
+            <a:endParaRPr lang="en-US"/>
           </a:p>
         </p:txBody>
       </p:sp>
@@ -603,37 +594,38 @@
           <a:p>
             <a:pPr lvl="0"/>
             <a:r>
-              <a:rPr lang="en-US"/>
+              <a:rPr lang="en-US" smtClean="0"/>
               <a:t>Click to edit Master text styles</a:t>
             </a:r>
           </a:p>
           <a:p>
             <a:pPr lvl="1"/>
             <a:r>
-              <a:rPr lang="en-US"/>
+              <a:rPr lang="en-US" smtClean="0"/>
               <a:t>Second level</a:t>
             </a:r>
           </a:p>
           <a:p>
             <a:pPr lvl="2"/>
             <a:r>
-              <a:rPr lang="en-US"/>
+              <a:rPr lang="en-US" smtClean="0"/>
               <a:t>Third level</a:t>
             </a:r>
           </a:p>
           <a:p>
             <a:pPr lvl="3"/>
             <a:r>
-              <a:rPr lang="en-US"/>
+              <a:rPr lang="en-US" smtClean="0"/>
               <a:t>Fourth level</a:t>
             </a:r>
           </a:p>
           <a:p>
             <a:pPr lvl="4"/>
             <a:r>
-              <a:rPr lang="en-US"/>
+              <a:rPr lang="en-US" smtClean="0"/>
               <a:t>Fifth level</a:t>
             </a:r>
+            <a:endParaRPr lang="en-US"/>
           </a:p>
         </p:txBody>
       </p:sp>
@@ -654,7 +646,7 @@
           <a:p>
             <a:fld id="{5BCAD085-E8A6-8845-BD4E-CB4CCA059FC4}" type="datetimeFigureOut">
               <a:rPr lang="en-US" smtClean="0"/>
-              <a:t>8/10/2026</a:t>
+              <a:t>1/27/13</a:t>
             </a:fld>
             <a:endParaRPr lang="en-US"/>
           </a:p>
@@ -748,9 +740,10 @@
           <a:lstStyle/>
           <a:p>
             <a:r>
-              <a:rPr lang="en-US"/>
+              <a:rPr lang="en-US" smtClean="0"/>
               <a:t>Click to edit Master title style</a:t>
             </a:r>
+            <a:endParaRPr lang="en-US"/>
           </a:p>
         </p:txBody>
       </p:sp>
@@ -771,37 +764,38 @@
           <a:p>
             <a:pPr lvl="0"/>
             <a:r>
-              <a:rPr lang="en-US"/>
+              <a:rPr lang="en-US" smtClean="0"/>
               <a:t>Click to edit Master text styles</a:t>
             </a:r>
           </a:p>
           <a:p>
             <a:pPr lvl="1"/>
             <a:r>
-              <a:rPr lang="en-US"/>
+              <a:rPr lang="en-US" smtClean="0"/>
               <a:t>Second level</a:t>
             </a:r>
           </a:p>
           <a:p>
             <a:pPr lvl="2"/>
             <a:r>
-              <a:rPr lang="en-US"/>
+              <a:rPr lang="en-US" smtClean="0"/>
               <a:t>Third level</a:t>
             </a:r>
           </a:p>
           <a:p>
             <a:pPr lvl="3"/>
             <a:r>
-              <a:rPr lang="en-US"/>
+              <a:rPr lang="en-US" smtClean="0"/>
               <a:t>Fourth level</a:t>
             </a:r>
           </a:p>
           <a:p>
             <a:pPr lvl="4"/>
             <a:r>
-              <a:rPr lang="en-US"/>
+              <a:rPr lang="en-US" smtClean="0"/>
               <a:t>Fifth level</a:t>
             </a:r>
+            <a:endParaRPr lang="en-US"/>
           </a:p>
         </p:txBody>
       </p:sp>
@@ -822,7 +816,7 @@
           <a:p>
             <a:fld id="{5BCAD085-E8A6-8845-BD4E-CB4CCA059FC4}" type="datetimeFigureOut">
               <a:rPr lang="en-US" smtClean="0"/>
-              <a:t>8/10/2026</a:t>
+              <a:t>1/27/13</a:t>
             </a:fld>
             <a:endParaRPr lang="en-US"/>
           </a:p>
@@ -925,9 +919,10 @@
           </a:lstStyle>
           <a:p>
             <a:r>
-              <a:rPr lang="en-US"/>
+              <a:rPr lang="en-US" smtClean="0"/>
               <a:t>Click to edit Master title style</a:t>
             </a:r>
+            <a:endParaRPr lang="en-US"/>
           </a:p>
         </p:txBody>
       </p:sp>
@@ -1044,7 +1039,7 @@
           <a:p>
             <a:pPr lvl="0"/>
             <a:r>
-              <a:rPr lang="en-US"/>
+              <a:rPr lang="en-US" smtClean="0"/>
               <a:t>Click to edit Master text styles</a:t>
             </a:r>
           </a:p>
@@ -1067,7 +1062,7 @@
           <a:p>
             <a:fld id="{5BCAD085-E8A6-8845-BD4E-CB4CCA059FC4}" type="datetimeFigureOut">
               <a:rPr lang="en-US" smtClean="0"/>
-              <a:t>8/10/2026</a:t>
+              <a:t>1/27/13</a:t>
             </a:fld>
             <a:endParaRPr lang="en-US"/>
           </a:p>
@@ -1161,9 +1156,10 @@
           <a:lstStyle/>
           <a:p>
             <a:r>
-              <a:rPr lang="en-US"/>
+              <a:rPr lang="en-US" smtClean="0"/>
               <a:t>Click to edit Master title style</a:t>
             </a:r>
+            <a:endParaRPr lang="en-US"/>
           </a:p>
         </p:txBody>
       </p:sp>
@@ -1217,37 +1213,38 @@
           <a:p>
             <a:pPr lvl="0"/>
             <a:r>
-              <a:rPr lang="en-US"/>
+              <a:rPr lang="en-US" smtClean="0"/>
               <a:t>Click to edit Master text styles</a:t>
             </a:r>
           </a:p>
           <a:p>
             <a:pPr lvl="1"/>
             <a:r>
-              <a:rPr lang="en-US"/>
+              <a:rPr lang="en-US" smtClean="0"/>
               <a:t>Second level</a:t>
             </a:r>
           </a:p>
           <a:p>
             <a:pPr lvl="2"/>
             <a:r>
-              <a:rPr lang="en-US"/>
+              <a:rPr lang="en-US" smtClean="0"/>
               <a:t>Third level</a:t>
             </a:r>
           </a:p>
           <a:p>
             <a:pPr lvl="3"/>
             <a:r>
-              <a:rPr lang="en-US"/>
+              <a:rPr lang="en-US" smtClean="0"/>
               <a:t>Fourth level</a:t>
             </a:r>
           </a:p>
           <a:p>
             <a:pPr lvl="4"/>
             <a:r>
-              <a:rPr lang="en-US"/>
+              <a:rPr lang="en-US" smtClean="0"/>
               <a:t>Fifth level</a:t>
             </a:r>
+            <a:endParaRPr lang="en-US"/>
           </a:p>
         </p:txBody>
       </p:sp>
@@ -1301,37 +1298,38 @@
           <a:p>
             <a:pPr lvl="0"/>
             <a:r>
-              <a:rPr lang="en-US"/>
+              <a:rPr lang="en-US" smtClean="0"/>
               <a:t>Click to edit Master text styles</a:t>
             </a:r>
           </a:p>
           <a:p>
             <a:pPr lvl="1"/>
             <a:r>
-              <a:rPr lang="en-US"/>
+              <a:rPr lang="en-US" smtClean="0"/>
               <a:t>Second level</a:t>
             </a:r>
           </a:p>
           <a:p>
             <a:pPr lvl="2"/>
             <a:r>
-              <a:rPr lang="en-US"/>
+              <a:rPr lang="en-US" smtClean="0"/>
               <a:t>Third level</a:t>
             </a:r>
           </a:p>
           <a:p>
             <a:pPr lvl="3"/>
             <a:r>
-              <a:rPr lang="en-US"/>
+              <a:rPr lang="en-US" smtClean="0"/>
               <a:t>Fourth level</a:t>
             </a:r>
           </a:p>
           <a:p>
             <a:pPr lvl="4"/>
             <a:r>
-              <a:rPr lang="en-US"/>
+              <a:rPr lang="en-US" smtClean="0"/>
               <a:t>Fifth level</a:t>
             </a:r>
+            <a:endParaRPr lang="en-US"/>
           </a:p>
         </p:txBody>
       </p:sp>
@@ -1352,7 +1350,7 @@
           <a:p>
             <a:fld id="{5BCAD085-E8A6-8845-BD4E-CB4CCA059FC4}" type="datetimeFigureOut">
               <a:rPr lang="en-US" smtClean="0"/>
-              <a:t>8/10/2026</a:t>
+              <a:t>1/27/13</a:t>
             </a:fld>
             <a:endParaRPr lang="en-US"/>
           </a:p>
@@ -1450,9 +1448,10 @@
           </a:lstStyle>
           <a:p>
             <a:r>
-              <a:rPr lang="en-US"/>
+              <a:rPr lang="en-US" smtClean="0"/>
               <a:t>Click to edit Master title style</a:t>
             </a:r>
+            <a:endParaRPr lang="en-US"/>
           </a:p>
         </p:txBody>
       </p:sp>
@@ -1515,7 +1514,7 @@
           <a:p>
             <a:pPr lvl="0"/>
             <a:r>
-              <a:rPr lang="en-US"/>
+              <a:rPr lang="en-US" smtClean="0"/>
               <a:t>Click to edit Master text styles</a:t>
             </a:r>
           </a:p>
@@ -1571,37 +1570,38 @@
           <a:p>
             <a:pPr lvl="0"/>
             <a:r>
-              <a:rPr lang="en-US"/>
+              <a:rPr lang="en-US" smtClean="0"/>
               <a:t>Click to edit Master text styles</a:t>
             </a:r>
           </a:p>
           <a:p>
             <a:pPr lvl="1"/>
             <a:r>
-              <a:rPr lang="en-US"/>
+              <a:rPr lang="en-US" smtClean="0"/>
               <a:t>Second level</a:t>
             </a:r>
           </a:p>
           <a:p>
             <a:pPr lvl="2"/>
             <a:r>
-              <a:rPr lang="en-US"/>
+              <a:rPr lang="en-US" smtClean="0"/>
               <a:t>Third level</a:t>
             </a:r>
           </a:p>
           <a:p>
             <a:pPr lvl="3"/>
             <a:r>
-              <a:rPr lang="en-US"/>
+              <a:rPr lang="en-US" smtClean="0"/>
               <a:t>Fourth level</a:t>
             </a:r>
           </a:p>
           <a:p>
             <a:pPr lvl="4"/>
             <a:r>
-              <a:rPr lang="en-US"/>
+              <a:rPr lang="en-US" smtClean="0"/>
               <a:t>Fifth level</a:t>
             </a:r>
+            <a:endParaRPr lang="en-US"/>
           </a:p>
         </p:txBody>
       </p:sp>
@@ -1664,7 +1664,7 @@
           <a:p>
             <a:pPr lvl="0"/>
             <a:r>
-              <a:rPr lang="en-US"/>
+              <a:rPr lang="en-US" smtClean="0"/>
               <a:t>Click to edit Master text styles</a:t>
             </a:r>
           </a:p>
@@ -1720,37 +1720,38 @@
           <a:p>
             <a:pPr lvl="0"/>
             <a:r>
-              <a:rPr lang="en-US"/>
+              <a:rPr lang="en-US" smtClean="0"/>
               <a:t>Click to edit Master text styles</a:t>
             </a:r>
           </a:p>
           <a:p>
             <a:pPr lvl="1"/>
             <a:r>
-              <a:rPr lang="en-US"/>
+              <a:rPr lang="en-US" smtClean="0"/>
               <a:t>Second level</a:t>
             </a:r>
           </a:p>
           <a:p>
             <a:pPr lvl="2"/>
             <a:r>
-              <a:rPr lang="en-US"/>
+              <a:rPr lang="en-US" smtClean="0"/>
               <a:t>Third level</a:t>
             </a:r>
           </a:p>
           <a:p>
             <a:pPr lvl="3"/>
             <a:r>
-              <a:rPr lang="en-US"/>
+              <a:rPr lang="en-US" smtClean="0"/>
               <a:t>Fourth level</a:t>
             </a:r>
           </a:p>
           <a:p>
             <a:pPr lvl="4"/>
             <a:r>
-              <a:rPr lang="en-US"/>
+              <a:rPr lang="en-US" smtClean="0"/>
               <a:t>Fifth level</a:t>
             </a:r>
+            <a:endParaRPr lang="en-US"/>
           </a:p>
         </p:txBody>
       </p:sp>
@@ -1771,7 +1772,7 @@
           <a:p>
             <a:fld id="{5BCAD085-E8A6-8845-BD4E-CB4CCA059FC4}" type="datetimeFigureOut">
               <a:rPr lang="en-US" smtClean="0"/>
-              <a:t>8/10/2026</a:t>
+              <a:t>1/27/13</a:t>
             </a:fld>
             <a:endParaRPr lang="en-US"/>
           </a:p>
@@ -1865,9 +1866,10 @@
           <a:lstStyle/>
           <a:p>
             <a:r>
-              <a:rPr lang="en-US"/>
+              <a:rPr lang="en-US" smtClean="0"/>
               <a:t>Click to edit Master title style</a:t>
             </a:r>
+            <a:endParaRPr lang="en-US"/>
           </a:p>
         </p:txBody>
       </p:sp>
@@ -1888,7 +1890,7 @@
           <a:p>
             <a:fld id="{5BCAD085-E8A6-8845-BD4E-CB4CCA059FC4}" type="datetimeFigureOut">
               <a:rPr lang="en-US" smtClean="0"/>
-              <a:t>8/10/2026</a:t>
+              <a:t>1/27/13</a:t>
             </a:fld>
             <a:endParaRPr lang="en-US"/>
           </a:p>
@@ -1983,7 +1985,7 @@
           <a:p>
             <a:fld id="{5BCAD085-E8A6-8845-BD4E-CB4CCA059FC4}" type="datetimeFigureOut">
               <a:rPr lang="en-US" smtClean="0"/>
-              <a:t>8/10/2026</a:t>
+              <a:t>1/27/13</a:t>
             </a:fld>
             <a:endParaRPr lang="en-US"/>
           </a:p>
@@ -2086,9 +2088,10 @@
           </a:lstStyle>
           <a:p>
             <a:r>
-              <a:rPr lang="en-US"/>
+              <a:rPr lang="en-US" smtClean="0"/>
               <a:t>Click to edit Master title style</a:t>
             </a:r>
+            <a:endParaRPr lang="en-US"/>
           </a:p>
         </p:txBody>
       </p:sp>
@@ -2142,37 +2145,38 @@
           <a:p>
             <a:pPr lvl="0"/>
             <a:r>
-              <a:rPr lang="en-US"/>
+              <a:rPr lang="en-US" smtClean="0"/>
               <a:t>Click to edit Master text styles</a:t>
             </a:r>
           </a:p>
           <a:p>
             <a:pPr lvl="1"/>
             <a:r>
-              <a:rPr lang="en-US"/>
+              <a:rPr lang="en-US" smtClean="0"/>
               <a:t>Second level</a:t>
             </a:r>
           </a:p>
           <a:p>
             <a:pPr lvl="2"/>
             <a:r>
-              <a:rPr lang="en-US"/>
+              <a:rPr lang="en-US" smtClean="0"/>
               <a:t>Third level</a:t>
             </a:r>
           </a:p>
           <a:p>
             <a:pPr lvl="3"/>
             <a:r>
-              <a:rPr lang="en-US"/>
+              <a:rPr lang="en-US" smtClean="0"/>
               <a:t>Fourth level</a:t>
             </a:r>
           </a:p>
           <a:p>
             <a:pPr lvl="4"/>
             <a:r>
-              <a:rPr lang="en-US"/>
+              <a:rPr lang="en-US" smtClean="0"/>
               <a:t>Fifth level</a:t>
             </a:r>
+            <a:endParaRPr lang="en-US"/>
           </a:p>
         </p:txBody>
       </p:sp>
@@ -2235,7 +2239,7 @@
           <a:p>
             <a:pPr lvl="0"/>
             <a:r>
-              <a:rPr lang="en-US"/>
+              <a:rPr lang="en-US" smtClean="0"/>
               <a:t>Click to edit Master text styles</a:t>
             </a:r>
           </a:p>
@@ -2258,7 +2262,7 @@
           <a:p>
             <a:fld id="{5BCAD085-E8A6-8845-BD4E-CB4CCA059FC4}" type="datetimeFigureOut">
               <a:rPr lang="en-US" smtClean="0"/>
-              <a:t>8/10/2026</a:t>
+              <a:t>1/27/13</a:t>
             </a:fld>
             <a:endParaRPr lang="en-US"/>
           </a:p>
@@ -2361,9 +2365,10 @@
           </a:lstStyle>
           <a:p>
             <a:r>
-              <a:rPr lang="en-US"/>
+              <a:rPr lang="en-US" smtClean="0"/>
               <a:t>Click to edit Master title style</a:t>
             </a:r>
+            <a:endParaRPr lang="en-US"/>
           </a:p>
         </p:txBody>
       </p:sp>
@@ -2487,7 +2492,7 @@
           <a:p>
             <a:pPr lvl="0"/>
             <a:r>
-              <a:rPr lang="en-US"/>
+              <a:rPr lang="en-US" smtClean="0"/>
               <a:t>Click to edit Master text styles</a:t>
             </a:r>
           </a:p>
@@ -2510,7 +2515,7 @@
           <a:p>
             <a:fld id="{5BCAD085-E8A6-8845-BD4E-CB4CCA059FC4}" type="datetimeFigureOut">
               <a:rPr lang="en-US" smtClean="0"/>
-              <a:t>8/10/2026</a:t>
+              <a:t>1/27/13</a:t>
             </a:fld>
             <a:endParaRPr lang="en-US"/>
           </a:p>
@@ -2619,9 +2624,10 @@
           <a:lstStyle/>
           <a:p>
             <a:r>
-              <a:rPr lang="en-US"/>
+              <a:rPr lang="en-US" smtClean="0"/>
               <a:t>Click to edit Master title style</a:t>
             </a:r>
+            <a:endParaRPr lang="en-US"/>
           </a:p>
         </p:txBody>
       </p:sp>
@@ -2652,37 +2658,38 @@
           <a:p>
             <a:pPr lvl="0"/>
             <a:r>
-              <a:rPr lang="en-US"/>
+              <a:rPr lang="en-US" smtClean="0"/>
               <a:t>Click to edit Master text styles</a:t>
             </a:r>
           </a:p>
           <a:p>
             <a:pPr lvl="1"/>
             <a:r>
-              <a:rPr lang="en-US"/>
+              <a:rPr lang="en-US" smtClean="0"/>
               <a:t>Second level</a:t>
             </a:r>
           </a:p>
           <a:p>
             <a:pPr lvl="2"/>
             <a:r>
-              <a:rPr lang="en-US"/>
+              <a:rPr lang="en-US" smtClean="0"/>
               <a:t>Third level</a:t>
             </a:r>
           </a:p>
           <a:p>
             <a:pPr lvl="3"/>
             <a:r>
-              <a:rPr lang="en-US"/>
+              <a:rPr lang="en-US" smtClean="0"/>
               <a:t>Fourth level</a:t>
             </a:r>
           </a:p>
           <a:p>
             <a:pPr lvl="4"/>
             <a:r>
-              <a:rPr lang="en-US"/>
+              <a:rPr lang="en-US" smtClean="0"/>
               <a:t>Fifth level</a:t>
             </a:r>
+            <a:endParaRPr lang="en-US"/>
           </a:p>
         </p:txBody>
       </p:sp>
@@ -2721,7 +2728,7 @@
           <a:p>
             <a:fld id="{5BCAD085-E8A6-8845-BD4E-CB4CCA059FC4}" type="datetimeFigureOut">
               <a:rPr lang="en-US" smtClean="0"/>
-              <a:t>8/10/2026</a:t>
+              <a:t>1/27/13</a:t>
             </a:fld>
             <a:endParaRPr lang="en-US"/>
           </a:p>
@@ -3080,7 +3087,7 @@
 </file>
 
 <file path=ppt/slides/slide1.xml><?xml version="1.0" encoding="utf-8"?>
-<p:sld xmlns:a="http://schemas.openxmlformats.org/drawingml/2006/main" xmlns:r="http://schemas.openxmlformats.org/officeDocument/2006/relationships" xmlns:p="http://schemas.openxmlformats.org/presentationml/2006/main">
+<p:sld xmlns:a="http://schemas.openxmlformats.org/drawingml/2006/main" xmlns:p="http://schemas.openxmlformats.org/presentationml/2006/main" xmlns:r="http://schemas.openxmlformats.org/officeDocument/2006/relationships">
   <p:cSld>
     <p:spTree>
       <p:nvGrpSpPr>
@@ -3088,14 +3095,7 @@
         <p:cNvGrpSpPr/>
         <p:nvPr/>
       </p:nvGrpSpPr>
-      <p:grpSpPr>
-        <a:xfrm>
-          <a:off x="0" y="0"/>
-          <a:ext cx="0" cy="0"/>
-          <a:chOff x="0" y="0"/>
-          <a:chExt cx="0" cy="0"/>
-        </a:xfrm>
-      </p:grpSpPr>
+      <p:grpSpPr/>
       <p:sp>
         <p:nvSpPr>
           <p:cNvPr id="2" name="TextBox 1"/>
@@ -3140,8 +3140,8 @@
         </p:nvSpPr>
         <p:spPr>
           <a:xfrm>
-            <a:off x="457199" y="1212782"/>
-            <a:ext cx="5577842" cy="3323987"/>
+            <a:off x="457200" y="1097280"/>
+            <a:ext cx="4937760" cy="3657600"/>
           </a:xfrm>
           <a:prstGeom prst="rect">
             <a:avLst/>
@@ -3163,11 +3163,7 @@
               </a:defRPr>
             </a:pPr>
             <a:r>
-              <a:rPr sz="1400" dirty="0">
-                <a:latin typeface="Times New Roman" panose="02020603050405020304" pitchFamily="18" charset="0"/>
-                <a:cs typeface="Times New Roman" panose="02020603050405020304" pitchFamily="18" charset="0"/>
-              </a:rPr>
-              <a:t>Project Phase 1: Automated image telemetry processing.</a:t>
+              <a:t>• Project Phase 1: Automated image telemetry processing.</a:t>
             </a:r>
           </a:p>
           <a:p>
@@ -3180,46 +3176,7 @@
               </a:defRPr>
             </a:pPr>
             <a:r>
-              <a:rPr sz="1400" dirty="0">
-                <a:latin typeface="Times New Roman" panose="02020603050405020304" pitchFamily="18" charset="0"/>
-                <a:cs typeface="Times New Roman" panose="02020603050405020304" pitchFamily="18" charset="0"/>
-              </a:rPr>
-              <a:t>• </a:t>
-            </a:r>
-            <a:r>
-              <a:rPr sz="1400" b="1" dirty="0">
-                <a:latin typeface="Times New Roman" panose="02020603050405020304" pitchFamily="18" charset="0"/>
-                <a:cs typeface="Times New Roman" panose="02020603050405020304" pitchFamily="18" charset="0"/>
-              </a:rPr>
-              <a:t>Step</a:t>
-            </a:r>
-            <a:r>
-              <a:rPr lang="en-IN" sz="1400" b="1" dirty="0">
-                <a:latin typeface="Times New Roman" panose="02020603050405020304" pitchFamily="18" charset="0"/>
-                <a:cs typeface="Times New Roman" panose="02020603050405020304" pitchFamily="18" charset="0"/>
-              </a:rPr>
-              <a:t>: </a:t>
-            </a:r>
-            <a:r>
-              <a:rPr sz="1400" b="1" dirty="0">
-                <a:latin typeface="Times New Roman" panose="02020603050405020304" pitchFamily="18" charset="0"/>
-                <a:cs typeface="Times New Roman" panose="02020603050405020304" pitchFamily="18" charset="0"/>
-              </a:rPr>
-              <a:t>Collection &amp; Extraction</a:t>
-            </a:r>
-            <a:r>
-              <a:rPr lang="en-IN" sz="1400" b="1" dirty="0">
-                <a:latin typeface="Times New Roman" panose="02020603050405020304" pitchFamily="18" charset="0"/>
-                <a:cs typeface="Times New Roman" panose="02020603050405020304" pitchFamily="18" charset="0"/>
-              </a:rPr>
-              <a:t> </a:t>
-            </a:r>
-            <a:r>
-              <a:rPr sz="1400" b="1" dirty="0">
-                <a:latin typeface="Times New Roman" panose="02020603050405020304" pitchFamily="18" charset="0"/>
-                <a:cs typeface="Times New Roman" panose="02020603050405020304" pitchFamily="18" charset="0"/>
-              </a:rPr>
-              <a:t>:</a:t>
+              <a:t>• Steps 1-4 (Collection &amp; Extraction):</a:t>
             </a:r>
           </a:p>
           <a:p>
@@ -3232,16 +3189,8 @@
               </a:defRPr>
             </a:pPr>
             <a:r>
-              <a:rPr sz="1400" dirty="0">
-                <a:latin typeface="Times New Roman" panose="02020603050405020304" pitchFamily="18" charset="0"/>
-                <a:cs typeface="Times New Roman" panose="02020603050405020304" pitchFamily="18" charset="0"/>
-              </a:rPr>
-              <a:t>   - Raw images from DJI drone flight are collected </a:t>
-            </a:r>
-            <a:endParaRPr lang="en-IN" sz="1400" dirty="0">
-              <a:latin typeface="Times New Roman" panose="02020603050405020304" pitchFamily="18" charset="0"/>
-              <a:cs typeface="Times New Roman" panose="02020603050405020304" pitchFamily="18" charset="0"/>
-            </a:endParaRPr>
+              <a:t>   - Raw images from DJI drone flight are collected (Step 1).</a:t>
+            </a:r>
           </a:p>
           <a:p>
             <a:pPr lvl="1">
@@ -3253,32 +3202,7 @@
               </a:defRPr>
             </a:pPr>
             <a:r>
-              <a:rPr lang="en-IN" sz="1400" dirty="0">
-                <a:latin typeface="Times New Roman" panose="02020603050405020304" pitchFamily="18" charset="0"/>
-                <a:cs typeface="Times New Roman" panose="02020603050405020304" pitchFamily="18" charset="0"/>
-              </a:rPr>
-              <a:t>   </a:t>
-            </a:r>
-            <a:r>
-              <a:rPr sz="1400" dirty="0">
-                <a:latin typeface="Times New Roman" panose="02020603050405020304" pitchFamily="18" charset="0"/>
-                <a:cs typeface="Times New Roman" panose="02020603050405020304" pitchFamily="18" charset="0"/>
-              </a:rPr>
-              <a:t>- </a:t>
-            </a:r>
-            <a:r>
-              <a:rPr sz="1400" dirty="0" err="1">
-                <a:latin typeface="Times New Roman" panose="02020603050405020304" pitchFamily="18" charset="0"/>
-                <a:cs typeface="Times New Roman" panose="02020603050405020304" pitchFamily="18" charset="0"/>
-              </a:rPr>
-              <a:t>ExifTool</a:t>
-            </a:r>
-            <a:r>
-              <a:rPr sz="1400" dirty="0">
-                <a:latin typeface="Times New Roman" panose="02020603050405020304" pitchFamily="18" charset="0"/>
-                <a:cs typeface="Times New Roman" panose="02020603050405020304" pitchFamily="18" charset="0"/>
-              </a:rPr>
-              <a:t> parses binary EXIF metadata automatically</a:t>
+              <a:t>   - ExifTool parses binary EXIF metadata automatically (Step 2-4).</a:t>
             </a:r>
           </a:p>
           <a:p>
@@ -3291,10 +3215,6 @@
               </a:defRPr>
             </a:pPr>
             <a:r>
-              <a:rPr sz="1400" dirty="0">
-                <a:latin typeface="Times New Roman" panose="02020603050405020304" pitchFamily="18" charset="0"/>
-                <a:cs typeface="Times New Roman" panose="02020603050405020304" pitchFamily="18" charset="0"/>
-              </a:rPr>
               <a:t>   - Extracts: GPS location (Lat/Lon/Alt), flight height, and yaw/pitch orientation.</a:t>
             </a:r>
           </a:p>
@@ -3308,32 +3228,7 @@
               </a:defRPr>
             </a:pPr>
             <a:r>
-              <a:rPr sz="1400" dirty="0">
-                <a:latin typeface="Times New Roman" panose="02020603050405020304" pitchFamily="18" charset="0"/>
-                <a:cs typeface="Times New Roman" panose="02020603050405020304" pitchFamily="18" charset="0"/>
-              </a:rPr>
-              <a:t>• </a:t>
-            </a:r>
-            <a:r>
-              <a:rPr sz="1400" b="1" dirty="0">
-                <a:latin typeface="Times New Roman" panose="02020603050405020304" pitchFamily="18" charset="0"/>
-                <a:cs typeface="Times New Roman" panose="02020603050405020304" pitchFamily="18" charset="0"/>
-              </a:rPr>
-              <a:t>Step</a:t>
-            </a:r>
-            <a:r>
-              <a:rPr lang="en-IN" sz="1400" b="1" dirty="0">
-                <a:latin typeface="Times New Roman" panose="02020603050405020304" pitchFamily="18" charset="0"/>
-                <a:cs typeface="Times New Roman" panose="02020603050405020304" pitchFamily="18" charset="0"/>
-              </a:rPr>
-              <a:t>: </a:t>
-            </a:r>
-            <a:r>
-              <a:rPr sz="1400" b="1" dirty="0">
-                <a:latin typeface="Times New Roman" panose="02020603050405020304" pitchFamily="18" charset="0"/>
-                <a:cs typeface="Times New Roman" panose="02020603050405020304" pitchFamily="18" charset="0"/>
-              </a:rPr>
-              <a:t>FOV Calculation:</a:t>
+              <a:t>• Steps 5-6 (FOV Calculation):</a:t>
             </a:r>
           </a:p>
           <a:p>
@@ -3346,10 +3241,6 @@
               </a:defRPr>
             </a:pPr>
             <a:r>
-              <a:rPr sz="1400" dirty="0">
-                <a:latin typeface="Times New Roman" panose="02020603050405020304" pitchFamily="18" charset="0"/>
-                <a:cs typeface="Times New Roman" panose="02020603050405020304" pitchFamily="18" charset="0"/>
-              </a:rPr>
               <a:t>   - Physical sensor specifications are mapped to compute horizontal/vertical FOV.</a:t>
             </a:r>
           </a:p>
@@ -3363,32 +3254,7 @@
               </a:defRPr>
             </a:pPr>
             <a:r>
-              <a:rPr sz="1400" dirty="0">
-                <a:latin typeface="Times New Roman" panose="02020603050405020304" pitchFamily="18" charset="0"/>
-                <a:cs typeface="Times New Roman" panose="02020603050405020304" pitchFamily="18" charset="0"/>
-              </a:rPr>
-              <a:t>• </a:t>
-            </a:r>
-            <a:r>
-              <a:rPr sz="1400" b="1" dirty="0">
-                <a:latin typeface="Times New Roman" panose="02020603050405020304" pitchFamily="18" charset="0"/>
-                <a:cs typeface="Times New Roman" panose="02020603050405020304" pitchFamily="18" charset="0"/>
-              </a:rPr>
-              <a:t>Step</a:t>
-            </a:r>
-            <a:r>
-              <a:rPr lang="en-IN" sz="1400" b="1" dirty="0">
-                <a:latin typeface="Times New Roman" panose="02020603050405020304" pitchFamily="18" charset="0"/>
-                <a:cs typeface="Times New Roman" panose="02020603050405020304" pitchFamily="18" charset="0"/>
-              </a:rPr>
-              <a:t>: </a:t>
-            </a:r>
-            <a:r>
-              <a:rPr sz="1400" b="1" dirty="0">
-                <a:latin typeface="Times New Roman" panose="02020603050405020304" pitchFamily="18" charset="0"/>
-                <a:cs typeface="Times New Roman" panose="02020603050405020304" pitchFamily="18" charset="0"/>
-              </a:rPr>
-              <a:t>Ground Footprint Corners Projection:</a:t>
+              <a:t>• Steps 7-8 (Ground Footprint Corners Projection):</a:t>
             </a:r>
           </a:p>
           <a:p>
@@ -3401,10 +3267,6 @@
               </a:defRPr>
             </a:pPr>
             <a:r>
-              <a:rPr sz="1400" dirty="0">
-                <a:latin typeface="Times New Roman" panose="02020603050405020304" pitchFamily="18" charset="0"/>
-                <a:cs typeface="Times New Roman" panose="02020603050405020304" pitchFamily="18" charset="0"/>
-              </a:rPr>
               <a:t>   - Combines camera viewing angles, drone altitude, and yaw rotation coordinates.</a:t>
             </a:r>
           </a:p>
@@ -3418,32 +3280,7 @@
               </a:defRPr>
             </a:pPr>
             <a:r>
-              <a:rPr sz="1400" dirty="0">
-                <a:latin typeface="Times New Roman" panose="02020603050405020304" pitchFamily="18" charset="0"/>
-                <a:cs typeface="Times New Roman" panose="02020603050405020304" pitchFamily="18" charset="0"/>
-              </a:rPr>
-              <a:t>• </a:t>
-            </a:r>
-            <a:r>
-              <a:rPr sz="1400" b="1" dirty="0">
-                <a:latin typeface="Times New Roman" panose="02020603050405020304" pitchFamily="18" charset="0"/>
-                <a:cs typeface="Times New Roman" panose="02020603050405020304" pitchFamily="18" charset="0"/>
-              </a:rPr>
-              <a:t>Step</a:t>
-            </a:r>
-            <a:r>
-              <a:rPr lang="en-IN" sz="1400" b="1" dirty="0">
-                <a:latin typeface="Times New Roman" panose="02020603050405020304" pitchFamily="18" charset="0"/>
-                <a:cs typeface="Times New Roman" panose="02020603050405020304" pitchFamily="18" charset="0"/>
-              </a:rPr>
-              <a:t>: </a:t>
-            </a:r>
-            <a:r>
-              <a:rPr sz="1400" b="1" dirty="0">
-                <a:latin typeface="Times New Roman" panose="02020603050405020304" pitchFamily="18" charset="0"/>
-                <a:cs typeface="Times New Roman" panose="02020603050405020304" pitchFamily="18" charset="0"/>
-              </a:rPr>
-              <a:t>Polygon Building &amp; GIS Export:</a:t>
+              <a:t>• Steps 9-10 (Polygon Building &amp; GIS Export):</a:t>
             </a:r>
           </a:p>
           <a:p>
@@ -3456,25 +3293,7 @@
               </a:defRPr>
             </a:pPr>
             <a:r>
-              <a:rPr sz="1400" dirty="0">
-                <a:latin typeface="Times New Roman" panose="02020603050405020304" pitchFamily="18" charset="0"/>
-                <a:cs typeface="Times New Roman" panose="02020603050405020304" pitchFamily="18" charset="0"/>
-              </a:rPr>
-              <a:t>   - Loops coordinates as a polygon, and exports footprints in WGS 84 </a:t>
-            </a:r>
-            <a:r>
-              <a:rPr sz="1400" dirty="0" err="1">
-                <a:latin typeface="Times New Roman" panose="02020603050405020304" pitchFamily="18" charset="0"/>
-                <a:cs typeface="Times New Roman" panose="02020603050405020304" pitchFamily="18" charset="0"/>
-              </a:rPr>
-              <a:t>GeoJSON</a:t>
-            </a:r>
-            <a:r>
-              <a:rPr sz="1400" dirty="0">
-                <a:latin typeface="Times New Roman" panose="02020603050405020304" pitchFamily="18" charset="0"/>
-                <a:cs typeface="Times New Roman" panose="02020603050405020304" pitchFamily="18" charset="0"/>
-              </a:rPr>
-              <a:t>.</a:t>
+              <a:t>   - Loops coordinates as a polygon, and exports footprints in WGS 84 GeoJSON.</a:t>
             </a:r>
           </a:p>
         </p:txBody>
@@ -3489,13 +3308,14 @@
         </p:nvPicPr>
         <p:blipFill>
           <a:blip r:embed="rId2"/>
-          <a:srcRect l="28098" t="5877" r="26546" b="5412"/>
-          <a:stretch/>
+          <a:stretch>
+            <a:fillRect/>
+          </a:stretch>
         </p:blipFill>
         <p:spPr>
           <a:xfrm>
-            <a:off x="6718434" y="988854"/>
-            <a:ext cx="1443789" cy="3547915"/>
+            <a:off x="5577840" y="1097280"/>
+            <a:ext cx="3108960" cy="3906129"/>
           </a:xfrm>
           <a:prstGeom prst="rect">
             <a:avLst/>
@@ -3511,7 +3331,7 @@
 </file>
 
 <file path=ppt/slides/slide2.xml><?xml version="1.0" encoding="utf-8"?>
-<p:sld xmlns:a="http://schemas.openxmlformats.org/drawingml/2006/main" xmlns:r="http://schemas.openxmlformats.org/officeDocument/2006/relationships" xmlns:p="http://schemas.openxmlformats.org/presentationml/2006/main">
+<p:sld xmlns:a="http://schemas.openxmlformats.org/drawingml/2006/main" xmlns:p="http://schemas.openxmlformats.org/presentationml/2006/main" xmlns:r="http://schemas.openxmlformats.org/officeDocument/2006/relationships">
   <p:cSld>
     <p:spTree>
       <p:nvGrpSpPr>
@@ -3519,14 +3339,7 @@
         <p:cNvGrpSpPr/>
         <p:nvPr/>
       </p:nvGrpSpPr>
-      <p:grpSpPr>
-        <a:xfrm>
-          <a:off x="0" y="0"/>
-          <a:ext cx="0" cy="0"/>
-          <a:chOff x="0" y="0"/>
-          <a:chExt cx="0" cy="0"/>
-        </a:xfrm>
-      </p:grpSpPr>
+      <p:grpSpPr/>
       <p:sp>
         <p:nvSpPr>
           <p:cNvPr id="2" name="TextBox 1"/>
@@ -3558,7 +3371,6 @@
               </a:defRPr>
             </a:pPr>
             <a:r>
-              <a:rPr dirty="0"/>
               <a:t>CAMERA FIELD OF VIEW &amp; COVERAGE MATH</a:t>
             </a:r>
           </a:p>
@@ -3572,8 +3384,8 @@
         </p:nvSpPr>
         <p:spPr>
           <a:xfrm>
-            <a:off x="457200" y="774859"/>
-            <a:ext cx="4937760" cy="4185761"/>
+            <a:off x="457200" y="1097280"/>
+            <a:ext cx="4937760" cy="3657600"/>
           </a:xfrm>
           <a:prstGeom prst="rect">
             <a:avLst/>
@@ -3595,34 +3407,8 @@
               </a:defRPr>
             </a:pPr>
             <a:r>
-              <a:rPr sz="1400" dirty="0"/>
-              <a:t>• </a:t>
-            </a:r>
-            <a:r>
-              <a:rPr sz="1400" b="1" dirty="0"/>
-              <a:t>Key Parameters: </a:t>
-            </a:r>
-            <a:r>
-              <a:rPr sz="1400" dirty="0"/>
-              <a:t>Focal length (f = 3.61 mm), Sensor size (</a:t>
-            </a:r>
-            <a:r>
-              <a:rPr sz="1400" dirty="0" err="1"/>
-              <a:t>Sw</a:t>
-            </a:r>
-            <a:r>
-              <a:rPr sz="1400" dirty="0"/>
-              <a:t> = 6.17 mm, </a:t>
-            </a:r>
-            <a:r>
-              <a:rPr sz="1400" dirty="0" err="1"/>
-              <a:t>Sh</a:t>
-            </a:r>
-            <a:r>
-              <a:rPr sz="1400" dirty="0"/>
-              <a:t> = 4.55 mm).</a:t>
-            </a:r>
-            <a:endParaRPr lang="en-IN" sz="1400" dirty="0"/>
+              <a:t>• Camera parameters: Focal length (f = 3.61 mm), Sensor width (Sw = 6.17 mm).</a:t>
+            </a:r>
           </a:p>
           <a:p>
             <a:pPr>
@@ -3633,7 +3419,35 @@
                 <a:latin typeface="Arial"/>
               </a:defRPr>
             </a:pPr>
-            <a:endParaRPr sz="1400" dirty="0"/>
+            <a:r>
+              <a:t>• Sensor Height aspect crop adjustment:</a:t>
+            </a:r>
+          </a:p>
+          <a:p>
+            <a:pPr lvl="1">
+              <a:defRPr sz="1100">
+                <a:solidFill>
+                  <a:srgbClr val="1E1E1E"/>
+                </a:solidFill>
+                <a:latin typeface="Arial"/>
+              </a:defRPr>
+            </a:pPr>
+            <a:r>
+              <a:t>   - Widescreen 16:9 images (4000x2250) crop the physical 4:3 sensor (4.55 mm).</a:t>
+            </a:r>
+          </a:p>
+          <a:p>
+            <a:pPr lvl="1">
+              <a:defRPr sz="1100">
+                <a:solidFill>
+                  <a:srgbClr val="1E1E1E"/>
+                </a:solidFill>
+                <a:latin typeface="Arial"/>
+              </a:defRPr>
+            </a:pPr>
+            <a:r>
+              <a:t>   - Effective sensor height: Sh = 6.17 * (2250 / 4000) = 3.47 mm.</a:t>
+            </a:r>
           </a:p>
           <a:p>
             <a:pPr>
@@ -3645,12 +3459,7 @@
               </a:defRPr>
             </a:pPr>
             <a:r>
-              <a:rPr sz="1400" dirty="0"/>
-              <a:t>• </a:t>
-            </a:r>
-            <a:r>
-              <a:rPr sz="1400" b="1" dirty="0"/>
-              <a:t>Step: Calculating viewing angles (FOV):</a:t>
+              <a:t>• Step 6: Calculating viewing angles (FOV):</a:t>
             </a:r>
           </a:p>
           <a:p>
@@ -3663,16 +3472,7 @@
               </a:defRPr>
             </a:pPr>
             <a:r>
-              <a:rPr sz="1400" dirty="0"/>
-              <a:t>   - Horizontal FOV = 2 * arctan(</a:t>
-            </a:r>
-            <a:r>
-              <a:rPr sz="1400" dirty="0" err="1"/>
-              <a:t>Sw</a:t>
-            </a:r>
-            <a:r>
-              <a:rPr sz="1400" dirty="0"/>
-              <a:t> / (2 * f)) = 81.03°</a:t>
+              <a:t>   - Horizontal FOV = 2 * arctan(Sw / (2 * f)) = 81.03°</a:t>
             </a:r>
           </a:p>
           <a:p>
@@ -3685,18 +3485,21 @@
               </a:defRPr>
             </a:pPr>
             <a:r>
-              <a:rPr sz="1400" dirty="0"/>
-              <a:t>   - Vertical FOV = 2 * arctan(</a:t>
-            </a:r>
-            <a:r>
-              <a:rPr sz="1400" dirty="0" err="1"/>
-              <a:t>Sh</a:t>
-            </a:r>
-            <a:r>
-              <a:rPr sz="1400" dirty="0"/>
-              <a:t> / (2 * f)) = 64.44°</a:t>
-            </a:r>
-            <a:endParaRPr lang="en-IN" sz="1400" dirty="0"/>
+              <a:t>   - Corrected Vertical FOV = 2 * arctan(Sh / (2 * f)) = 50.64° (instead of 64.44°)</a:t>
+            </a:r>
+          </a:p>
+          <a:p>
+            <a:pPr>
+              <a:defRPr sz="1300">
+                <a:solidFill>
+                  <a:srgbClr val="1E1E1E"/>
+                </a:solidFill>
+                <a:latin typeface="Arial"/>
+              </a:defRPr>
+            </a:pPr>
+            <a:r>
+              <a:t>• Step 7: Ground footprint dimensions (at nadir/straight-down):</a:t>
+            </a:r>
           </a:p>
           <a:p>
             <a:pPr lvl="1">
@@ -3707,7 +3510,22 @@
                 <a:latin typeface="Arial"/>
               </a:defRPr>
             </a:pPr>
-            <a:endParaRPr sz="1400" dirty="0"/>
+            <a:r>
+              <a:t>   - Width = 2 * Altitude * tan(Horizontal FOV / 2) ≈ 1.71 * Altitude</a:t>
+            </a:r>
+          </a:p>
+          <a:p>
+            <a:pPr lvl="1">
+              <a:defRPr sz="1100">
+                <a:solidFill>
+                  <a:srgbClr val="1E1E1E"/>
+                </a:solidFill>
+                <a:latin typeface="Arial"/>
+              </a:defRPr>
+            </a:pPr>
+            <a:r>
+              <a:t>   - Corrected Height = 2 * Altitude * tan(Vertical FOV / 2) ≈ 0.96 * Altitude (instead of 1.28)</a:t>
+            </a:r>
           </a:p>
           <a:p>
             <a:pPr>
@@ -3719,12 +3537,7 @@
               </a:defRPr>
             </a:pPr>
             <a:r>
-              <a:rPr sz="1400" dirty="0"/>
-              <a:t>• </a:t>
-            </a:r>
-            <a:r>
-              <a:rPr sz="1400" b="1" dirty="0"/>
-              <a:t>Step: Ground footprint dimensions (at nadir/straight-down):</a:t>
+              <a:t>• Step 8: 2D Rotation using Yaw Orientation:</a:t>
             </a:r>
           </a:p>
           <a:p>
@@ -3737,8 +3550,7 @@
               </a:defRPr>
             </a:pPr>
             <a:r>
-              <a:rPr sz="1400" dirty="0"/>
-              <a:t>   - Width = 2 * Altitude * tan(Horizontal FOV / 2) ≈ 1.71 * Altitude</a:t>
+              <a:t>   - X_rot = X_local * cos(yaw) + Y_local * sin(yaw)</a:t>
             </a:r>
           </a:p>
           <a:p>
@@ -3751,128 +3563,7 @@
               </a:defRPr>
             </a:pPr>
             <a:r>
-              <a:rPr sz="1400" dirty="0"/>
-              <a:t>   - Height = 2 * Altitude * tan(Vertical FOV / 2) ≈ 1.28 * Altitude</a:t>
-            </a:r>
-          </a:p>
-          <a:p>
-            <a:pPr lvl="1">
-              <a:defRPr sz="1100">
-                <a:solidFill>
-                  <a:srgbClr val="1E1E1E"/>
-                </a:solidFill>
-                <a:latin typeface="Arial"/>
-              </a:defRPr>
-            </a:pPr>
-            <a:r>
-              <a:rPr sz="1400" dirty="0"/>
-              <a:t>   - Oblique imagery (camera tilt/pitch) distorts rectangles into quadrilaterals.</a:t>
-            </a:r>
-            <a:endParaRPr lang="en-IN" sz="1400" dirty="0"/>
-          </a:p>
-          <a:p>
-            <a:pPr lvl="1">
-              <a:defRPr sz="1100">
-                <a:solidFill>
-                  <a:srgbClr val="1E1E1E"/>
-                </a:solidFill>
-                <a:latin typeface="Arial"/>
-              </a:defRPr>
-            </a:pPr>
-            <a:endParaRPr sz="1400" dirty="0"/>
-          </a:p>
-          <a:p>
-            <a:pPr>
-              <a:defRPr sz="1300">
-                <a:solidFill>
-                  <a:srgbClr val="1E1E1E"/>
-                </a:solidFill>
-                <a:latin typeface="Arial"/>
-              </a:defRPr>
-            </a:pPr>
-            <a:r>
-              <a:rPr sz="1400" dirty="0"/>
-              <a:t>• </a:t>
-            </a:r>
-            <a:r>
-              <a:rPr sz="1400" b="1" dirty="0"/>
-              <a:t>Step: 2D Rotation using Yaw Orientation:</a:t>
-            </a:r>
-          </a:p>
-          <a:p>
-            <a:pPr lvl="1">
-              <a:defRPr sz="1100">
-                <a:solidFill>
-                  <a:srgbClr val="1E1E1E"/>
-                </a:solidFill>
-                <a:latin typeface="Arial"/>
-              </a:defRPr>
-            </a:pPr>
-            <a:r>
-              <a:rPr sz="1400" dirty="0"/>
-              <a:t>   - </a:t>
-            </a:r>
-            <a:r>
-              <a:rPr sz="1400" dirty="0" err="1"/>
-              <a:t>X_rot</a:t>
-            </a:r>
-            <a:r>
-              <a:rPr sz="1400" dirty="0"/>
-              <a:t> = </a:t>
-            </a:r>
-            <a:r>
-              <a:rPr sz="1400" dirty="0" err="1"/>
-              <a:t>X_local</a:t>
-            </a:r>
-            <a:r>
-              <a:rPr sz="1400" dirty="0"/>
-              <a:t> * cos(yaw) + </a:t>
-            </a:r>
-            <a:r>
-              <a:rPr sz="1400" dirty="0" err="1"/>
-              <a:t>Y_local</a:t>
-            </a:r>
-            <a:r>
-              <a:rPr sz="1400" dirty="0"/>
-              <a:t> * sin(yaw)</a:t>
-            </a:r>
-          </a:p>
-          <a:p>
-            <a:pPr lvl="1">
-              <a:defRPr sz="1100">
-                <a:solidFill>
-                  <a:srgbClr val="1E1E1E"/>
-                </a:solidFill>
-                <a:latin typeface="Arial"/>
-              </a:defRPr>
-            </a:pPr>
-            <a:r>
-              <a:rPr sz="1400" dirty="0"/>
-              <a:t>   - </a:t>
-            </a:r>
-            <a:r>
-              <a:rPr sz="1400" dirty="0" err="1"/>
-              <a:t>Y_rot</a:t>
-            </a:r>
-            <a:r>
-              <a:rPr sz="1400" dirty="0"/>
-              <a:t> = -</a:t>
-            </a:r>
-            <a:r>
-              <a:rPr sz="1400" dirty="0" err="1"/>
-              <a:t>X_local</a:t>
-            </a:r>
-            <a:r>
-              <a:rPr sz="1400" dirty="0"/>
-              <a:t> * sin(yaw) + </a:t>
-            </a:r>
-            <a:r>
-              <a:rPr sz="1400" dirty="0" err="1"/>
-              <a:t>Y_local</a:t>
-            </a:r>
-            <a:r>
-              <a:rPr sz="1400" dirty="0"/>
-              <a:t> * cos(yaw)</a:t>
+              <a:t>   - Y_rot = -X_local * sin(yaw) + Y_local * cos(yaw)</a:t>
             </a:r>
           </a:p>
         </p:txBody>
@@ -3910,7 +3601,7 @@
 </file>
 
 <file path=ppt/slides/slide3.xml><?xml version="1.0" encoding="utf-8"?>
-<p:sld xmlns:a="http://schemas.openxmlformats.org/drawingml/2006/main" xmlns:r="http://schemas.openxmlformats.org/officeDocument/2006/relationships" xmlns:p="http://schemas.openxmlformats.org/presentationml/2006/main">
+<p:sld xmlns:a="http://schemas.openxmlformats.org/drawingml/2006/main" xmlns:p="http://schemas.openxmlformats.org/presentationml/2006/main" xmlns:r="http://schemas.openxmlformats.org/officeDocument/2006/relationships">
   <p:cSld>
     <p:spTree>
       <p:nvGrpSpPr>
@@ -3918,14 +3609,7 @@
         <p:cNvGrpSpPr/>
         <p:nvPr/>
       </p:nvGrpSpPr>
-      <p:grpSpPr>
-        <a:xfrm>
-          <a:off x="0" y="0"/>
-          <a:ext cx="0" cy="0"/>
-          <a:chOff x="0" y="0"/>
-          <a:chExt cx="0" cy="0"/>
-        </a:xfrm>
-      </p:grpSpPr>
+      <p:grpSpPr/>
       <p:sp>
         <p:nvSpPr>
           <p:cNvPr id="2" name="TextBox 1"/>
@@ -3957,7 +3641,7 @@
               </a:defRPr>
             </a:pPr>
             <a:r>
-              <a:t>UAV METADATA STANDARDS &amp; FAIR PRINCIPLES</a:t>
+              <a:t>COORDINATE REFERENCE SYSTEMS &amp; PROJECTIONS</a:t>
             </a:r>
           </a:p>
         </p:txBody>
@@ -3971,7 +3655,7 @@
         <p:spPr>
           <a:xfrm>
             <a:off x="457200" y="1097280"/>
-            <a:ext cx="8229600" cy="2893100"/>
+            <a:ext cx="4937760" cy="3657600"/>
           </a:xfrm>
           <a:prstGeom prst="rect">
             <a:avLst/>
@@ -3993,16 +3677,8 @@
               </a:defRPr>
             </a:pPr>
             <a:r>
-              <a:rPr sz="1400" dirty="0">
-                <a:latin typeface="Times New Roman" panose="02020603050405020304" pitchFamily="18" charset="0"/>
-                <a:cs typeface="Times New Roman" panose="02020603050405020304" pitchFamily="18" charset="0"/>
-              </a:rPr>
-              <a:t>• Objective: Compare metadata schemas to ensure UAV data interoperability.</a:t>
-            </a:r>
-            <a:endParaRPr lang="en-IN" sz="1400" dirty="0">
-              <a:latin typeface="Times New Roman" panose="02020603050405020304" pitchFamily="18" charset="0"/>
-              <a:cs typeface="Times New Roman" panose="02020603050405020304" pitchFamily="18" charset="0"/>
-            </a:endParaRPr>
+              <a:t>• Global Reference System: Drone images log coordinates in WGS 84 (EPSG:4326) degrees.</a:t>
+            </a:r>
           </a:p>
           <a:p>
             <a:pPr>
@@ -4013,10 +3689,9 @@
                 <a:latin typeface="Arial"/>
               </a:defRPr>
             </a:pPr>
-            <a:endParaRPr sz="1400" dirty="0">
-              <a:latin typeface="Times New Roman" panose="02020603050405020304" pitchFamily="18" charset="0"/>
-              <a:cs typeface="Times New Roman" panose="02020603050405020304" pitchFamily="18" charset="0"/>
-            </a:endParaRPr>
+            <a:r>
+              <a:t>• Flattening Map System: Calculations (meters) require projecting to UTM grid.</a:t>
+            </a:r>
           </a:p>
           <a:p>
             <a:pPr>
@@ -4028,16 +3703,8 @@
               </a:defRPr>
             </a:pPr>
             <a:r>
-              <a:rPr sz="1400" dirty="0">
-                <a:latin typeface="Times New Roman" panose="02020603050405020304" pitchFamily="18" charset="0"/>
-                <a:cs typeface="Times New Roman" panose="02020603050405020304" pitchFamily="18" charset="0"/>
-              </a:rPr>
-              <a:t>• Why Metadata Standards Matter: Drone missions produce heterogeneous formats. Standardized tags ensure files are easily discovered and loaded.</a:t>
-            </a:r>
-            <a:endParaRPr lang="en-IN" sz="1400" dirty="0">
-              <a:latin typeface="Times New Roman" panose="02020603050405020304" pitchFamily="18" charset="0"/>
-              <a:cs typeface="Times New Roman" panose="02020603050405020304" pitchFamily="18" charset="0"/>
-            </a:endParaRPr>
+              <a:t>• UTM Zone 15N (EPSG:32615) covers Duluth, Minnesota area.</a:t>
+            </a:r>
           </a:p>
           <a:p>
             <a:pPr>
@@ -4048,10 +3715,35 @@
                 <a:latin typeface="Arial"/>
               </a:defRPr>
             </a:pPr>
-            <a:endParaRPr sz="1400" dirty="0">
-              <a:latin typeface="Times New Roman" panose="02020603050405020304" pitchFamily="18" charset="0"/>
-              <a:cs typeface="Times New Roman" panose="02020603050405020304" pitchFamily="18" charset="0"/>
-            </a:endParaRPr>
+            <a:r>
+              <a:t>• OGR Coordinate Transformations (in C++ App):</a:t>
+            </a:r>
+          </a:p>
+          <a:p>
+            <a:pPr lvl="1">
+              <a:defRPr sz="1100">
+                <a:solidFill>
+                  <a:srgbClr val="1E1E1E"/>
+                </a:solidFill>
+                <a:latin typeface="Arial"/>
+              </a:defRPr>
+            </a:pPr>
+            <a:r>
+              <a:t>   - Translates UTM 15N to standard spherical GPS coordinates for GeoJSON export.</a:t>
+            </a:r>
+          </a:p>
+          <a:p>
+            <a:pPr lvl="1">
+              <a:defRPr sz="1100">
+                <a:solidFill>
+                  <a:srgbClr val="1E1E1E"/>
+                </a:solidFill>
+                <a:latin typeface="Arial"/>
+              </a:defRPr>
+            </a:pPr>
+            <a:r>
+              <a:t>   - Translates UTM 15N to UTM 10N (EPSG:32610) to query the dsm.tif GeoTIFF elevation raster.</a:t>
+            </a:r>
           </a:p>
           <a:p>
             <a:pPr>
@@ -4063,202 +3755,35 @@
               </a:defRPr>
             </a:pPr>
             <a:r>
-              <a:rPr sz="1400" dirty="0">
-                <a:latin typeface="Times New Roman" panose="02020603050405020304" pitchFamily="18" charset="0"/>
-                <a:cs typeface="Times New Roman" panose="02020603050405020304" pitchFamily="18" charset="0"/>
-              </a:rPr>
-              <a:t>• FAIR Principles for Drone Data:</a:t>
-            </a:r>
-          </a:p>
-          <a:p>
-            <a:pPr lvl="1">
-              <a:defRPr sz="1100">
-                <a:solidFill>
-                  <a:srgbClr val="1E1E1E"/>
-                </a:solidFill>
-                <a:latin typeface="Arial"/>
-              </a:defRPr>
-            </a:pPr>
-            <a:r>
-              <a:rPr sz="1400" dirty="0">
-                <a:latin typeface="Times New Roman" panose="02020603050405020304" pitchFamily="18" charset="0"/>
-                <a:cs typeface="Times New Roman" panose="02020603050405020304" pitchFamily="18" charset="0"/>
-              </a:rPr>
-              <a:t>   - </a:t>
-            </a:r>
-            <a:r>
-              <a:rPr sz="1400" b="1" dirty="0">
-                <a:latin typeface="Times New Roman" panose="02020603050405020304" pitchFamily="18" charset="0"/>
-                <a:cs typeface="Times New Roman" panose="02020603050405020304" pitchFamily="18" charset="0"/>
-              </a:rPr>
-              <a:t>Findable: </a:t>
-            </a:r>
-            <a:r>
-              <a:rPr sz="1400" dirty="0">
-                <a:latin typeface="Times New Roman" panose="02020603050405020304" pitchFamily="18" charset="0"/>
-                <a:cs typeface="Times New Roman" panose="02020603050405020304" pitchFamily="18" charset="0"/>
-              </a:rPr>
-              <a:t>Standard search terms and unique IDs.</a:t>
-            </a:r>
-          </a:p>
-          <a:p>
-            <a:pPr lvl="1">
-              <a:defRPr sz="1100">
-                <a:solidFill>
-                  <a:srgbClr val="1E1E1E"/>
-                </a:solidFill>
-                <a:latin typeface="Arial"/>
-              </a:defRPr>
-            </a:pPr>
-            <a:r>
-              <a:rPr sz="1400" dirty="0">
-                <a:latin typeface="Times New Roman" panose="02020603050405020304" pitchFamily="18" charset="0"/>
-                <a:cs typeface="Times New Roman" panose="02020603050405020304" pitchFamily="18" charset="0"/>
-              </a:rPr>
-              <a:t>   - </a:t>
-            </a:r>
-            <a:r>
-              <a:rPr sz="1400" b="1" dirty="0">
-                <a:latin typeface="Times New Roman" panose="02020603050405020304" pitchFamily="18" charset="0"/>
-                <a:cs typeface="Times New Roman" panose="02020603050405020304" pitchFamily="18" charset="0"/>
-              </a:rPr>
-              <a:t>Accessible: </a:t>
-            </a:r>
-            <a:r>
-              <a:rPr sz="1400" dirty="0">
-                <a:latin typeface="Times New Roman" panose="02020603050405020304" pitchFamily="18" charset="0"/>
-                <a:cs typeface="Times New Roman" panose="02020603050405020304" pitchFamily="18" charset="0"/>
-              </a:rPr>
-              <a:t>Files are open and </a:t>
-            </a:r>
-            <a:r>
-              <a:rPr sz="1400" dirty="0" err="1">
-                <a:latin typeface="Times New Roman" panose="02020603050405020304" pitchFamily="18" charset="0"/>
-                <a:cs typeface="Times New Roman" panose="02020603050405020304" pitchFamily="18" charset="0"/>
-              </a:rPr>
-              <a:t>queryable</a:t>
-            </a:r>
-            <a:r>
-              <a:rPr sz="1400" dirty="0">
-                <a:latin typeface="Times New Roman" panose="02020603050405020304" pitchFamily="18" charset="0"/>
-                <a:cs typeface="Times New Roman" panose="02020603050405020304" pitchFamily="18" charset="0"/>
-              </a:rPr>
-              <a:t> through API catalogs.</a:t>
-            </a:r>
-          </a:p>
-          <a:p>
-            <a:pPr lvl="1">
-              <a:defRPr sz="1100">
-                <a:solidFill>
-                  <a:srgbClr val="1E1E1E"/>
-                </a:solidFill>
-                <a:latin typeface="Arial"/>
-              </a:defRPr>
-            </a:pPr>
-            <a:r>
-              <a:rPr sz="1400" dirty="0">
-                <a:latin typeface="Times New Roman" panose="02020603050405020304" pitchFamily="18" charset="0"/>
-                <a:cs typeface="Times New Roman" panose="02020603050405020304" pitchFamily="18" charset="0"/>
-              </a:rPr>
-              <a:t>   - </a:t>
-            </a:r>
-            <a:r>
-              <a:rPr sz="1400" b="1" dirty="0">
-                <a:latin typeface="Times New Roman" panose="02020603050405020304" pitchFamily="18" charset="0"/>
-                <a:cs typeface="Times New Roman" panose="02020603050405020304" pitchFamily="18" charset="0"/>
-              </a:rPr>
-              <a:t>Interoperable: </a:t>
-            </a:r>
-            <a:r>
-              <a:rPr sz="1400" dirty="0">
-                <a:latin typeface="Times New Roman" panose="02020603050405020304" pitchFamily="18" charset="0"/>
-                <a:cs typeface="Times New Roman" panose="02020603050405020304" pitchFamily="18" charset="0"/>
-              </a:rPr>
-              <a:t>Common schemas allow direct import into QGIS, ArcGIS, or Python.</a:t>
-            </a:r>
-          </a:p>
-          <a:p>
-            <a:pPr lvl="1">
-              <a:defRPr sz="1100">
-                <a:solidFill>
-                  <a:srgbClr val="1E1E1E"/>
-                </a:solidFill>
-                <a:latin typeface="Arial"/>
-              </a:defRPr>
-            </a:pPr>
-            <a:r>
-              <a:rPr sz="1400" dirty="0">
-                <a:latin typeface="Times New Roman" panose="02020603050405020304" pitchFamily="18" charset="0"/>
-                <a:cs typeface="Times New Roman" panose="02020603050405020304" pitchFamily="18" charset="0"/>
-              </a:rPr>
-              <a:t>   - </a:t>
-            </a:r>
-            <a:r>
-              <a:rPr sz="1400" b="1" dirty="0">
-                <a:latin typeface="Times New Roman" panose="02020603050405020304" pitchFamily="18" charset="0"/>
-                <a:cs typeface="Times New Roman" panose="02020603050405020304" pitchFamily="18" charset="0"/>
-              </a:rPr>
-              <a:t>Reusable: </a:t>
-            </a:r>
-            <a:r>
-              <a:rPr sz="1400" dirty="0">
-                <a:latin typeface="Times New Roman" panose="02020603050405020304" pitchFamily="18" charset="0"/>
-                <a:cs typeface="Times New Roman" panose="02020603050405020304" pitchFamily="18" charset="0"/>
-              </a:rPr>
-              <a:t>Complete details on sensor calibration and coordinates.</a:t>
-            </a:r>
-            <a:endParaRPr lang="en-IN" sz="1400" dirty="0">
-              <a:latin typeface="Times New Roman" panose="02020603050405020304" pitchFamily="18" charset="0"/>
-              <a:cs typeface="Times New Roman" panose="02020603050405020304" pitchFamily="18" charset="0"/>
-            </a:endParaRPr>
-          </a:p>
-          <a:p>
-            <a:pPr lvl="1">
-              <a:defRPr sz="1100">
-                <a:solidFill>
-                  <a:srgbClr val="1E1E1E"/>
-                </a:solidFill>
-                <a:latin typeface="Arial"/>
-              </a:defRPr>
-            </a:pPr>
-            <a:endParaRPr sz="1400" dirty="0">
-              <a:latin typeface="Times New Roman" panose="02020603050405020304" pitchFamily="18" charset="0"/>
-              <a:cs typeface="Times New Roman" panose="02020603050405020304" pitchFamily="18" charset="0"/>
-            </a:endParaRPr>
-          </a:p>
-          <a:p>
-            <a:pPr>
-              <a:defRPr sz="1300">
-                <a:solidFill>
-                  <a:srgbClr val="1E1E1E"/>
-                </a:solidFill>
-                <a:latin typeface="Arial"/>
-              </a:defRPr>
-            </a:pPr>
-            <a:r>
-              <a:rPr sz="1400" dirty="0">
-                <a:latin typeface="Times New Roman" panose="02020603050405020304" pitchFamily="18" charset="0"/>
-                <a:cs typeface="Times New Roman" panose="02020603050405020304" pitchFamily="18" charset="0"/>
-              </a:rPr>
-              <a:t>• Key Barrier: Traditional XML schemas (ISO) are heavy, while raw vectors (</a:t>
-            </a:r>
-            <a:r>
-              <a:rPr sz="1400" dirty="0" err="1">
-                <a:latin typeface="Times New Roman" panose="02020603050405020304" pitchFamily="18" charset="0"/>
-                <a:cs typeface="Times New Roman" panose="02020603050405020304" pitchFamily="18" charset="0"/>
-              </a:rPr>
-              <a:t>GeoJSON</a:t>
-            </a:r>
-            <a:r>
-              <a:rPr sz="1400" dirty="0">
-                <a:latin typeface="Times New Roman" panose="02020603050405020304" pitchFamily="18" charset="0"/>
-                <a:cs typeface="Times New Roman" panose="02020603050405020304" pitchFamily="18" charset="0"/>
-              </a:rPr>
-              <a:t>) lack rich sensor calibration attributes.</a:t>
-            </a:r>
-          </a:p>
-        </p:txBody>
-      </p:sp>
+              <a:t>• Robust Parsing: Validates numeric data when reading point cloud text blocks and skips text headers (X,Y,Z) to prevent (0,0) coordinate origin drift.</a:t>
+            </a:r>
+          </a:p>
+        </p:txBody>
+      </p:sp>
+      <p:pic>
+        <p:nvPicPr>
+          <p:cNvPr id="4" name="Picture 3" descr="fig_projections.png"/>
+          <p:cNvPicPr>
+            <a:picLocks noChangeAspect="1"/>
+          </p:cNvPicPr>
+          <p:nvPr/>
+        </p:nvPicPr>
+        <p:blipFill>
+          <a:blip r:embed="rId2"/>
+          <a:stretch>
+            <a:fillRect/>
+          </a:stretch>
+        </p:blipFill>
+        <p:spPr>
+          <a:xfrm>
+            <a:off x="5577840" y="1097280"/>
+            <a:ext cx="3108960" cy="2593155"/>
+          </a:xfrm>
+          <a:prstGeom prst="rect">
+            <a:avLst/>
+          </a:prstGeom>
+        </p:spPr>
+      </p:pic>
     </p:spTree>
   </p:cSld>
   <p:clrMapOvr>
@@ -4268,7 +3793,7 @@
 </file>
 
 <file path=ppt/slides/slide4.xml><?xml version="1.0" encoding="utf-8"?>
-<p:sld xmlns:a="http://schemas.openxmlformats.org/drawingml/2006/main" xmlns:r="http://schemas.openxmlformats.org/officeDocument/2006/relationships" xmlns:p="http://schemas.openxmlformats.org/presentationml/2006/main">
+<p:sld xmlns:a="http://schemas.openxmlformats.org/drawingml/2006/main" xmlns:p="http://schemas.openxmlformats.org/presentationml/2006/main" xmlns:r="http://schemas.openxmlformats.org/officeDocument/2006/relationships">
   <p:cSld>
     <p:spTree>
       <p:nvGrpSpPr>
@@ -4276,14 +3801,7 @@
         <p:cNvGrpSpPr/>
         <p:nvPr/>
       </p:nvGrpSpPr>
-      <p:grpSpPr>
-        <a:xfrm>
-          <a:off x="0" y="0"/>
-          <a:ext cx="0" cy="0"/>
-          <a:chOff x="0" y="0"/>
-          <a:chExt cx="0" cy="0"/>
-        </a:xfrm>
-      </p:grpSpPr>
+      <p:grpSpPr/>
       <p:sp>
         <p:nvSpPr>
           <p:cNvPr id="2" name="TextBox 1"/>
@@ -4315,7 +3833,7 @@
               </a:defRPr>
             </a:pPr>
             <a:r>
-              <a:t>GEOGRAPHIC METADATA: ISO 19115 &amp; ISO 19139</a:t>
+              <a:t>INTERACTIVE MAP VISUALIZERS (C++ &amp; PYTHON)</a:t>
             </a:r>
           </a:p>
         </p:txBody>
@@ -4329,7 +3847,7 @@
         <p:spPr>
           <a:xfrm>
             <a:off x="457200" y="1097280"/>
-            <a:ext cx="8229600" cy="2462213"/>
+            <a:ext cx="8229600" cy="3657600"/>
           </a:xfrm>
           <a:prstGeom prst="rect">
             <a:avLst/>
@@ -4351,25 +3869,20 @@
               </a:defRPr>
             </a:pPr>
             <a:r>
-              <a:rPr sz="1400" dirty="0">
-                <a:latin typeface="Times New Roman" panose="02020603050405020304" pitchFamily="18" charset="0"/>
-                <a:cs typeface="Times New Roman" panose="02020603050405020304" pitchFamily="18" charset="0"/>
-              </a:rPr>
-              <a:t>• </a:t>
-            </a:r>
-            <a:r>
-              <a:rPr sz="1400" b="1" dirty="0">
-                <a:latin typeface="Times New Roman" panose="02020603050405020304" pitchFamily="18" charset="0"/>
-                <a:cs typeface="Times New Roman" panose="02020603050405020304" pitchFamily="18" charset="0"/>
-              </a:rPr>
-              <a:t>ISO 19115 (Metadata Schema): </a:t>
-            </a:r>
-            <a:r>
-              <a:rPr sz="1400" dirty="0">
-                <a:latin typeface="Times New Roman" panose="02020603050405020304" pitchFamily="18" charset="0"/>
-                <a:cs typeface="Times New Roman" panose="02020603050405020304" pitchFamily="18" charset="0"/>
-              </a:rPr>
-              <a:t>The cornerstone international standard for geographic metadata.</a:t>
+              <a:t>• Interactive 3D Canvas: Renders point cloud (color-coded by height), flight nodes, and footprints.</a:t>
+            </a:r>
+          </a:p>
+          <a:p>
+            <a:pPr>
+              <a:defRPr sz="1300">
+                <a:solidFill>
+                  <a:srgbClr val="1E1E1E"/>
+                </a:solidFill>
+                <a:latin typeface="Arial"/>
+              </a:defRPr>
+            </a:pPr>
+            <a:r>
+              <a:t>• Dynamic Photo Warping Overlay:</a:t>
             </a:r>
           </a:p>
           <a:p>
@@ -4382,16 +3895,21 @@
               </a:defRPr>
             </a:pPr>
             <a:r>
-              <a:rPr sz="1400" dirty="0">
-                <a:latin typeface="Times New Roman" panose="02020603050405020304" pitchFamily="18" charset="0"/>
-                <a:cs typeface="Times New Roman" panose="02020603050405020304" pitchFamily="18" charset="0"/>
-              </a:rPr>
-              <a:t>   - Defines elements describing geographic datasets (spatial range, data quality, lineage, sensor).</a:t>
-            </a:r>
-            <a:endParaRPr lang="en-IN" sz="1400" dirty="0">
-              <a:latin typeface="Times New Roman" panose="02020603050405020304" pitchFamily="18" charset="0"/>
-              <a:cs typeface="Times New Roman" panose="02020603050405020304" pitchFamily="18" charset="0"/>
-            </a:endParaRPr>
+              <a:t>   - Applies QTransform matrix to translate, rotate, and scale photos over the point cloud.</a:t>
+            </a:r>
+          </a:p>
+          <a:p>
+            <a:pPr>
+              <a:defRPr sz="1300">
+                <a:solidFill>
+                  <a:srgbClr val="1E1E1E"/>
+                </a:solidFill>
+                <a:latin typeface="Arial"/>
+              </a:defRPr>
+            </a:pPr>
+            <a:r>
+              <a:t>• GDAL Elevation Querying:</a:t>
+            </a:r>
           </a:p>
           <a:p>
             <a:pPr lvl="1">
@@ -4402,10 +3920,9 @@
                 <a:latin typeface="Arial"/>
               </a:defRPr>
             </a:pPr>
-            <a:endParaRPr sz="1400" dirty="0">
-              <a:latin typeface="Times New Roman" panose="02020603050405020304" pitchFamily="18" charset="0"/>
-              <a:cs typeface="Times New Roman" panose="02020603050405020304" pitchFamily="18" charset="0"/>
-            </a:endParaRPr>
+            <a:r>
+              <a:t>   - Queries float32 elevation values from dsm.tif raster in real-time under the mouse cursor.</a:t>
+            </a:r>
           </a:p>
           <a:p>
             <a:pPr>
@@ -4417,18 +3934,7 @@
               </a:defRPr>
             </a:pPr>
             <a:r>
-              <a:rPr sz="1400" dirty="0">
-                <a:latin typeface="Times New Roman" panose="02020603050405020304" pitchFamily="18" charset="0"/>
-                <a:cs typeface="Times New Roman" panose="02020603050405020304" pitchFamily="18" charset="0"/>
-              </a:rPr>
-              <a:t>•</a:t>
-            </a:r>
-            <a:r>
-              <a:rPr sz="1400" b="1" dirty="0">
-                <a:latin typeface="Times New Roman" panose="02020603050405020304" pitchFamily="18" charset="0"/>
-                <a:cs typeface="Times New Roman" panose="02020603050405020304" pitchFamily="18" charset="0"/>
-              </a:rPr>
-              <a:t> ISO 19139 (XML Schema Implementation):</a:t>
+              <a:t>• Dynamic UI sidebar layout (Qt6 Widget structures):</a:t>
             </a:r>
           </a:p>
           <a:p>
@@ -4441,16 +3947,8 @@
               </a:defRPr>
             </a:pPr>
             <a:r>
-              <a:rPr sz="1400" dirty="0">
-                <a:latin typeface="Times New Roman" panose="02020603050405020304" pitchFamily="18" charset="0"/>
-                <a:cs typeface="Times New Roman" panose="02020603050405020304" pitchFamily="18" charset="0"/>
-              </a:rPr>
-              <a:t>   - Details how ISO 19115 elements must be structured inside XML files for machine exchanges.</a:t>
-            </a:r>
-            <a:endParaRPr lang="en-IN" sz="1400" dirty="0">
-              <a:latin typeface="Times New Roman" panose="02020603050405020304" pitchFamily="18" charset="0"/>
-              <a:cs typeface="Times New Roman" panose="02020603050405020304" pitchFamily="18" charset="0"/>
-            </a:endParaRPr>
+              <a:t>   - Dynamic list selection connects photo markers directly to metadata table.</a:t>
+            </a:r>
           </a:p>
           <a:p>
             <a:pPr lvl="1">
@@ -4461,33 +3959,8 @@
                 <a:latin typeface="Arial"/>
               </a:defRPr>
             </a:pPr>
-            <a:endParaRPr sz="1400" dirty="0">
-              <a:latin typeface="Times New Roman" panose="02020603050405020304" pitchFamily="18" charset="0"/>
-              <a:cs typeface="Times New Roman" panose="02020603050405020304" pitchFamily="18" charset="0"/>
-            </a:endParaRPr>
-          </a:p>
-          <a:p>
-            <a:pPr>
-              <a:defRPr sz="1300">
-                <a:solidFill>
-                  <a:srgbClr val="1E1E1E"/>
-                </a:solidFill>
-                <a:latin typeface="Arial"/>
-              </a:defRPr>
-            </a:pPr>
-            <a:r>
-              <a:rPr sz="1400" dirty="0">
-                <a:latin typeface="Times New Roman" panose="02020603050405020304" pitchFamily="18" charset="0"/>
-                <a:cs typeface="Times New Roman" panose="02020603050405020304" pitchFamily="18" charset="0"/>
-              </a:rPr>
-              <a:t>• </a:t>
-            </a:r>
-            <a:r>
-              <a:rPr sz="1400" b="1" dirty="0">
-                <a:latin typeface="Times New Roman" panose="02020603050405020304" pitchFamily="18" charset="0"/>
-                <a:cs typeface="Times New Roman" panose="02020603050405020304" pitchFamily="18" charset="0"/>
-              </a:rPr>
-              <a:t>OGC (Open Geospatial Consortium) Standards:</a:t>
+            <a:r>
+              <a:t>   - ScrollArea wrapper prevents layout clipping on small monitors.</a:t>
             </a:r>
           </a:p>
           <a:p>
@@ -4500,60 +3973,7 @@
               </a:defRPr>
             </a:pPr>
             <a:r>
-              <a:rPr sz="1400" dirty="0">
-                <a:latin typeface="Times New Roman" panose="02020603050405020304" pitchFamily="18" charset="0"/>
-                <a:cs typeface="Times New Roman" panose="02020603050405020304" pitchFamily="18" charset="0"/>
-              </a:rPr>
-              <a:t>   - Standardizes services like CSW (Catalog Service for Web) to publish and search ISO XML documents.</a:t>
-            </a:r>
-            <a:endParaRPr lang="en-IN" sz="1400" dirty="0">
-              <a:latin typeface="Times New Roman" panose="02020603050405020304" pitchFamily="18" charset="0"/>
-              <a:cs typeface="Times New Roman" panose="02020603050405020304" pitchFamily="18" charset="0"/>
-            </a:endParaRPr>
-          </a:p>
-          <a:p>
-            <a:pPr lvl="1">
-              <a:defRPr sz="1100">
-                <a:solidFill>
-                  <a:srgbClr val="1E1E1E"/>
-                </a:solidFill>
-                <a:latin typeface="Arial"/>
-              </a:defRPr>
-            </a:pPr>
-            <a:endParaRPr sz="1400" dirty="0">
-              <a:latin typeface="Times New Roman" panose="02020603050405020304" pitchFamily="18" charset="0"/>
-              <a:cs typeface="Times New Roman" panose="02020603050405020304" pitchFamily="18" charset="0"/>
-            </a:endParaRPr>
-          </a:p>
-          <a:p>
-            <a:pPr>
-              <a:defRPr sz="1300">
-                <a:solidFill>
-                  <a:srgbClr val="1E1E1E"/>
-                </a:solidFill>
-                <a:latin typeface="Arial"/>
-              </a:defRPr>
-            </a:pPr>
-            <a:r>
-              <a:rPr sz="1400" dirty="0">
-                <a:latin typeface="Times New Roman" panose="02020603050405020304" pitchFamily="18" charset="0"/>
-                <a:cs typeface="Times New Roman" panose="02020603050405020304" pitchFamily="18" charset="0"/>
-              </a:rPr>
-              <a:t>• </a:t>
-            </a:r>
-            <a:r>
-              <a:rPr sz="1400" u="sng" dirty="0">
-                <a:latin typeface="Times New Roman" panose="02020603050405020304" pitchFamily="18" charset="0"/>
-                <a:cs typeface="Times New Roman" panose="02020603050405020304" pitchFamily="18" charset="0"/>
-              </a:rPr>
-              <a:t>Main Limitation: </a:t>
-            </a:r>
-            <a:r>
-              <a:rPr sz="1400" dirty="0">
-                <a:latin typeface="Times New Roman" panose="02020603050405020304" pitchFamily="18" charset="0"/>
-                <a:cs typeface="Times New Roman" panose="02020603050405020304" pitchFamily="18" charset="0"/>
-              </a:rPr>
-              <a:t>Complex XML encoding makes them difficult for cloud software and web APIs to read rapidly.</a:t>
+              <a:t>   - QTableWidget details every EXIF metadata tag (copyable via Ctrl+C).</a:t>
             </a:r>
           </a:p>
         </p:txBody>
@@ -4567,7 +3987,7 @@
 </file>
 
 <file path=ppt/slides/slide5.xml><?xml version="1.0" encoding="utf-8"?>
-<p:sld xmlns:a="http://schemas.openxmlformats.org/drawingml/2006/main" xmlns:r="http://schemas.openxmlformats.org/officeDocument/2006/relationships" xmlns:p="http://schemas.openxmlformats.org/presentationml/2006/main">
+<p:sld xmlns:a="http://schemas.openxmlformats.org/drawingml/2006/main" xmlns:p="http://schemas.openxmlformats.org/presentationml/2006/main" xmlns:r="http://schemas.openxmlformats.org/officeDocument/2006/relationships">
   <p:cSld>
     <p:spTree>
       <p:nvGrpSpPr>
@@ -4575,14 +3995,7 @@
         <p:cNvGrpSpPr/>
         <p:nvPr/>
       </p:nvGrpSpPr>
-      <p:grpSpPr>
-        <a:xfrm>
-          <a:off x="0" y="0"/>
-          <a:ext cx="0" cy="0"/>
-          <a:chOff x="0" y="0"/>
-          <a:chExt cx="0" cy="0"/>
-        </a:xfrm>
-      </p:grpSpPr>
+      <p:grpSpPr/>
       <p:sp>
         <p:nvSpPr>
           <p:cNvPr id="2" name="TextBox 1"/>
@@ -4614,7 +4027,7 @@
               </a:defRPr>
             </a:pPr>
             <a:r>
-              <a:t>CLOUD-OPTIMIZED FORMATS (COG &amp; COPC)</a:t>
+              <a:t>UAV METADATA STANDARDS &amp; FAIR PRINCIPLES</a:t>
             </a:r>
           </a:p>
         </p:txBody>
@@ -4628,7 +4041,7 @@
         <p:spPr>
           <a:xfrm>
             <a:off x="457200" y="1097280"/>
-            <a:ext cx="8229600" cy="2246769"/>
+            <a:ext cx="8229600" cy="3657600"/>
           </a:xfrm>
           <a:prstGeom prst="rect">
             <a:avLst/>
@@ -4650,39 +4063,33 @@
               </a:defRPr>
             </a:pPr>
             <a:r>
-              <a:rPr sz="1400" dirty="0">
-                <a:latin typeface="Times New Roman" panose="02020603050405020304" pitchFamily="18" charset="0"/>
-                <a:cs typeface="Times New Roman" panose="02020603050405020304" pitchFamily="18" charset="0"/>
-              </a:rPr>
-              <a:t>• </a:t>
-            </a:r>
-            <a:r>
-              <a:rPr sz="1400" b="1" dirty="0" err="1">
-                <a:latin typeface="Times New Roman" panose="02020603050405020304" pitchFamily="18" charset="0"/>
-                <a:cs typeface="Times New Roman" panose="02020603050405020304" pitchFamily="18" charset="0"/>
-              </a:rPr>
-              <a:t>GeoTIFF</a:t>
-            </a:r>
-            <a:r>
-              <a:rPr sz="1400" b="1" dirty="0">
-                <a:latin typeface="Times New Roman" panose="02020603050405020304" pitchFamily="18" charset="0"/>
-                <a:cs typeface="Times New Roman" panose="02020603050405020304" pitchFamily="18" charset="0"/>
-              </a:rPr>
-              <a:t> vs. Cloud Optimized </a:t>
-            </a:r>
-            <a:r>
-              <a:rPr sz="1400" b="1" dirty="0" err="1">
-                <a:latin typeface="Times New Roman" panose="02020603050405020304" pitchFamily="18" charset="0"/>
-                <a:cs typeface="Times New Roman" panose="02020603050405020304" pitchFamily="18" charset="0"/>
-              </a:rPr>
-              <a:t>GeoTIFF</a:t>
-            </a:r>
-            <a:r>
-              <a:rPr sz="1400" b="1" dirty="0">
-                <a:latin typeface="Times New Roman" panose="02020603050405020304" pitchFamily="18" charset="0"/>
-                <a:cs typeface="Times New Roman" panose="02020603050405020304" pitchFamily="18" charset="0"/>
-              </a:rPr>
-              <a:t> (COG):</a:t>
+              <a:t>• Research Objective: Compare metadata schemas to ensure UAV data interoperability.</a:t>
+            </a:r>
+          </a:p>
+          <a:p>
+            <a:pPr>
+              <a:defRPr sz="1300">
+                <a:solidFill>
+                  <a:srgbClr val="1E1E1E"/>
+                </a:solidFill>
+                <a:latin typeface="Arial"/>
+              </a:defRPr>
+            </a:pPr>
+            <a:r>
+              <a:t>• Why Metadata Standards Matter: Drone missions produce heterogeneous formats. Standardized tags ensure files are easily discovered and loaded.</a:t>
+            </a:r>
+          </a:p>
+          <a:p>
+            <a:pPr>
+              <a:defRPr sz="1300">
+                <a:solidFill>
+                  <a:srgbClr val="1E1E1E"/>
+                </a:solidFill>
+                <a:latin typeface="Arial"/>
+              </a:defRPr>
+            </a:pPr>
+            <a:r>
+              <a:t>• FAIR Principles for Drone Data:</a:t>
             </a:r>
           </a:p>
           <a:p>
@@ -4695,25 +4102,7 @@
               </a:defRPr>
             </a:pPr>
             <a:r>
-              <a:rPr sz="1400" dirty="0">
-                <a:latin typeface="Times New Roman" panose="02020603050405020304" pitchFamily="18" charset="0"/>
-                <a:cs typeface="Times New Roman" panose="02020603050405020304" pitchFamily="18" charset="0"/>
-              </a:rPr>
-              <a:t>   - Standard </a:t>
-            </a:r>
-            <a:r>
-              <a:rPr sz="1400" dirty="0" err="1">
-                <a:latin typeface="Times New Roman" panose="02020603050405020304" pitchFamily="18" charset="0"/>
-                <a:cs typeface="Times New Roman" panose="02020603050405020304" pitchFamily="18" charset="0"/>
-              </a:rPr>
-              <a:t>GeoTIFF</a:t>
-            </a:r>
-            <a:r>
-              <a:rPr sz="1400" dirty="0">
-                <a:latin typeface="Times New Roman" panose="02020603050405020304" pitchFamily="18" charset="0"/>
-                <a:cs typeface="Times New Roman" panose="02020603050405020304" pitchFamily="18" charset="0"/>
-              </a:rPr>
-              <a:t> has to be read entirely to query an elevation point.</a:t>
+              <a:t>   - Findable: Standard search terms and unique IDs.</a:t>
             </a:r>
           </a:p>
           <a:p>
@@ -4726,11 +4115,7 @@
               </a:defRPr>
             </a:pPr>
             <a:r>
-              <a:rPr sz="1400" dirty="0">
-                <a:latin typeface="Times New Roman" panose="02020603050405020304" pitchFamily="18" charset="0"/>
-                <a:cs typeface="Times New Roman" panose="02020603050405020304" pitchFamily="18" charset="0"/>
-              </a:rPr>
-              <a:t>   - COG organizes elevation cells into HTTP range request tiles.</a:t>
+              <a:t>   - Accessible: Files are open and queryable through API catalogs.</a:t>
             </a:r>
           </a:p>
           <a:p>
@@ -4743,16 +4128,8 @@
               </a:defRPr>
             </a:pPr>
             <a:r>
-              <a:rPr sz="1400" dirty="0">
-                <a:latin typeface="Times New Roman" panose="02020603050405020304" pitchFamily="18" charset="0"/>
-                <a:cs typeface="Times New Roman" panose="02020603050405020304" pitchFamily="18" charset="0"/>
-              </a:rPr>
-              <a:t>   - Allows GIS apps to query terrain elevation in milliseconds over a network without downloading the full gigabyte file.</a:t>
-            </a:r>
-            <a:endParaRPr lang="en-IN" sz="1400" dirty="0">
-              <a:latin typeface="Times New Roman" panose="02020603050405020304" pitchFamily="18" charset="0"/>
-              <a:cs typeface="Times New Roman" panose="02020603050405020304" pitchFamily="18" charset="0"/>
-            </a:endParaRPr>
+              <a:t>   - Interoperable: Common schemas allow direct import into QGIS, ArcGIS, or Python.</a:t>
+            </a:r>
           </a:p>
           <a:p>
             <a:pPr lvl="1">
@@ -4763,10 +4140,9 @@
                 <a:latin typeface="Arial"/>
               </a:defRPr>
             </a:pPr>
-            <a:endParaRPr sz="1400" dirty="0">
-              <a:latin typeface="Times New Roman" panose="02020603050405020304" pitchFamily="18" charset="0"/>
-              <a:cs typeface="Times New Roman" panose="02020603050405020304" pitchFamily="18" charset="0"/>
-            </a:endParaRPr>
+            <a:r>
+              <a:t>   - Reusable: Complete details on sensor calibration and coordinates.</a:t>
+            </a:r>
           </a:p>
           <a:p>
             <a:pPr>
@@ -4778,69 +4154,7 @@
               </a:defRPr>
             </a:pPr>
             <a:r>
-              <a:rPr sz="1400" dirty="0">
-                <a:latin typeface="Times New Roman" panose="02020603050405020304" pitchFamily="18" charset="0"/>
-                <a:cs typeface="Times New Roman" panose="02020603050405020304" pitchFamily="18" charset="0"/>
-              </a:rPr>
-              <a:t>• </a:t>
-            </a:r>
-            <a:r>
-              <a:rPr sz="1400" b="1" dirty="0">
-                <a:latin typeface="Times New Roman" panose="02020603050405020304" pitchFamily="18" charset="0"/>
-                <a:cs typeface="Times New Roman" panose="02020603050405020304" pitchFamily="18" charset="0"/>
-              </a:rPr>
-              <a:t>LAS/LAZ vs. Cloud Optimized Point Cloud (COPC):</a:t>
-            </a:r>
-          </a:p>
-          <a:p>
-            <a:pPr lvl="1">
-              <a:defRPr sz="1100">
-                <a:solidFill>
-                  <a:srgbClr val="1E1E1E"/>
-                </a:solidFill>
-                <a:latin typeface="Arial"/>
-              </a:defRPr>
-            </a:pPr>
-            <a:r>
-              <a:rPr sz="1400" dirty="0">
-                <a:latin typeface="Times New Roman" panose="02020603050405020304" pitchFamily="18" charset="0"/>
-                <a:cs typeface="Times New Roman" panose="02020603050405020304" pitchFamily="18" charset="0"/>
-              </a:rPr>
-              <a:t>   - LAZ files are compressed point clouds but lack spatial indexes.</a:t>
-            </a:r>
-          </a:p>
-          <a:p>
-            <a:pPr lvl="1">
-              <a:defRPr sz="1100">
-                <a:solidFill>
-                  <a:srgbClr val="1E1E1E"/>
-                </a:solidFill>
-                <a:latin typeface="Arial"/>
-              </a:defRPr>
-            </a:pPr>
-            <a:r>
-              <a:rPr sz="1400" dirty="0">
-                <a:latin typeface="Times New Roman" panose="02020603050405020304" pitchFamily="18" charset="0"/>
-                <a:cs typeface="Times New Roman" panose="02020603050405020304" pitchFamily="18" charset="0"/>
-              </a:rPr>
-              <a:t>   - COPC structures point clouds as an octree layout inside a LAZ file.</a:t>
-            </a:r>
-          </a:p>
-          <a:p>
-            <a:pPr lvl="1">
-              <a:defRPr sz="1100">
-                <a:solidFill>
-                  <a:srgbClr val="1E1E1E"/>
-                </a:solidFill>
-                <a:latin typeface="Arial"/>
-              </a:defRPr>
-            </a:pPr>
-            <a:r>
-              <a:rPr sz="1400" dirty="0">
-                <a:latin typeface="Times New Roman" panose="02020603050405020304" pitchFamily="18" charset="0"/>
-                <a:cs typeface="Times New Roman" panose="02020603050405020304" pitchFamily="18" charset="0"/>
-              </a:rPr>
-              <a:t>   - Enables streaming of points based on resolution and bounding boxes.</a:t>
+              <a:t>• Key Barrier: Traditional XML schemas (ISO) are heavy, while raw vectors (GeoJSON) lack rich sensor calibration attributes.</a:t>
             </a:r>
           </a:p>
         </p:txBody>
@@ -4854,7 +4168,7 @@
 </file>
 
 <file path=ppt/slides/slide6.xml><?xml version="1.0" encoding="utf-8"?>
-<p:sld xmlns:a="http://schemas.openxmlformats.org/drawingml/2006/main" xmlns:r="http://schemas.openxmlformats.org/officeDocument/2006/relationships" xmlns:p="http://schemas.openxmlformats.org/presentationml/2006/main">
+<p:sld xmlns:a="http://schemas.openxmlformats.org/drawingml/2006/main" xmlns:p="http://schemas.openxmlformats.org/presentationml/2006/main" xmlns:r="http://schemas.openxmlformats.org/officeDocument/2006/relationships">
   <p:cSld>
     <p:spTree>
       <p:nvGrpSpPr>
@@ -4862,14 +4176,7 @@
         <p:cNvGrpSpPr/>
         <p:nvPr/>
       </p:nvGrpSpPr>
-      <p:grpSpPr>
-        <a:xfrm>
-          <a:off x="0" y="0"/>
-          <a:ext cx="0" cy="0"/>
-          <a:chOff x="0" y="0"/>
-          <a:chExt cx="0" cy="0"/>
-        </a:xfrm>
-      </p:grpSpPr>
+      <p:grpSpPr/>
       <p:sp>
         <p:nvSpPr>
           <p:cNvPr id="2" name="TextBox 1"/>
@@ -4901,7 +4208,7 @@
               </a:defRPr>
             </a:pPr>
             <a:r>
-              <a:t>SPATIOTEMPORAL ASSET CATALOG (STAC)</a:t>
+              <a:t>GEOGRAPHIC METADATA: ISO 19115 &amp; ISO 19139</a:t>
             </a:r>
           </a:p>
         </p:txBody>
@@ -4915,7 +4222,7 @@
         <p:spPr>
           <a:xfrm>
             <a:off x="457200" y="1097280"/>
-            <a:ext cx="7724274" cy="2677656"/>
+            <a:ext cx="8229600" cy="3657600"/>
           </a:xfrm>
           <a:prstGeom prst="rect">
             <a:avLst/>
@@ -4937,30 +4244,21 @@
               </a:defRPr>
             </a:pPr>
             <a:r>
-              <a:rPr sz="1400" dirty="0">
-                <a:latin typeface="Times New Roman" panose="02020603050405020304" pitchFamily="18" charset="0"/>
-                <a:cs typeface="Times New Roman" panose="02020603050405020304" pitchFamily="18" charset="0"/>
-              </a:rPr>
-              <a:t>• </a:t>
-            </a:r>
-            <a:r>
-              <a:rPr sz="1400" b="1" dirty="0">
-                <a:latin typeface="Times New Roman" panose="02020603050405020304" pitchFamily="18" charset="0"/>
-                <a:cs typeface="Times New Roman" panose="02020603050405020304" pitchFamily="18" charset="0"/>
-              </a:rPr>
-              <a:t>STAC Specification: </a:t>
-            </a:r>
-            <a:r>
-              <a:rPr sz="1400" dirty="0">
-                <a:latin typeface="Times New Roman" panose="02020603050405020304" pitchFamily="18" charset="0"/>
-                <a:cs typeface="Times New Roman" panose="02020603050405020304" pitchFamily="18" charset="0"/>
-              </a:rPr>
-              <a:t>A modern JSON-LD metadata standard built to catalog geospatial assets (photos, DEMs, point clouds).</a:t>
-            </a:r>
-            <a:endParaRPr lang="en-IN" sz="1400" dirty="0">
-              <a:latin typeface="Times New Roman" panose="02020603050405020304" pitchFamily="18" charset="0"/>
-              <a:cs typeface="Times New Roman" panose="02020603050405020304" pitchFamily="18" charset="0"/>
-            </a:endParaRPr>
+              <a:t>• ISO 19115 (Metadata Schema): The cornerstone international standard for geographic metadata.</a:t>
+            </a:r>
+          </a:p>
+          <a:p>
+            <a:pPr lvl="1">
+              <a:defRPr sz="1100">
+                <a:solidFill>
+                  <a:srgbClr val="1E1E1E"/>
+                </a:solidFill>
+                <a:latin typeface="Arial"/>
+              </a:defRPr>
+            </a:pPr>
+            <a:r>
+              <a:t>   - Defines elements describing geographic datasets (spatial range, data quality, lineage, sensor).</a:t>
+            </a:r>
           </a:p>
           <a:p>
             <a:pPr>
@@ -4971,10 +4269,22 @@
                 <a:latin typeface="Arial"/>
               </a:defRPr>
             </a:pPr>
-            <a:endParaRPr sz="1400" dirty="0">
-              <a:latin typeface="Times New Roman" panose="02020603050405020304" pitchFamily="18" charset="0"/>
-              <a:cs typeface="Times New Roman" panose="02020603050405020304" pitchFamily="18" charset="0"/>
-            </a:endParaRPr>
+            <a:r>
+              <a:t>• ISO 19139 (XML Schema Implementation):</a:t>
+            </a:r>
+          </a:p>
+          <a:p>
+            <a:pPr lvl="1">
+              <a:defRPr sz="1100">
+                <a:solidFill>
+                  <a:srgbClr val="1E1E1E"/>
+                </a:solidFill>
+                <a:latin typeface="Arial"/>
+              </a:defRPr>
+            </a:pPr>
+            <a:r>
+              <a:t>   - Details how ISO 19115 elements must be structured inside XML files for machine exchanges.</a:t>
+            </a:r>
           </a:p>
           <a:p>
             <a:pPr>
@@ -4986,11 +4296,7 @@
               </a:defRPr>
             </a:pPr>
             <a:r>
-              <a:rPr sz="1400" dirty="0">
-                <a:latin typeface="Times New Roman" panose="02020603050405020304" pitchFamily="18" charset="0"/>
-                <a:cs typeface="Times New Roman" panose="02020603050405020304" pitchFamily="18" charset="0"/>
-              </a:rPr>
-              <a:t>• Three core components in the STAC hierarchy:</a:t>
+              <a:t>• OGC (Open Geospatial Consortium) Standards:</a:t>
             </a:r>
           </a:p>
           <a:p>
@@ -5003,120 +4309,8 @@
               </a:defRPr>
             </a:pPr>
             <a:r>
-              <a:rPr sz="1400" dirty="0">
-                <a:latin typeface="Times New Roman" panose="02020603050405020304" pitchFamily="18" charset="0"/>
-                <a:cs typeface="Times New Roman" panose="02020603050405020304" pitchFamily="18" charset="0"/>
-              </a:rPr>
-              <a:t>   - </a:t>
-            </a:r>
-            <a:r>
-              <a:rPr sz="1400" b="1" dirty="0">
-                <a:latin typeface="Times New Roman" panose="02020603050405020304" pitchFamily="18" charset="0"/>
-                <a:cs typeface="Times New Roman" panose="02020603050405020304" pitchFamily="18" charset="0"/>
-              </a:rPr>
-              <a:t>STAC Catalog</a:t>
-            </a:r>
-            <a:r>
-              <a:rPr sz="1400" dirty="0">
-                <a:latin typeface="Times New Roman" panose="02020603050405020304" pitchFamily="18" charset="0"/>
-                <a:cs typeface="Times New Roman" panose="02020603050405020304" pitchFamily="18" charset="0"/>
-              </a:rPr>
-              <a:t>: The root JSON file indexing the structure.</a:t>
-            </a:r>
-          </a:p>
-          <a:p>
-            <a:pPr lvl="1">
-              <a:defRPr sz="1100">
-                <a:solidFill>
-                  <a:srgbClr val="1E1E1E"/>
-                </a:solidFill>
-                <a:latin typeface="Arial"/>
-              </a:defRPr>
-            </a:pPr>
-            <a:r>
-              <a:rPr sz="1400" dirty="0">
-                <a:latin typeface="Times New Roman" panose="02020603050405020304" pitchFamily="18" charset="0"/>
-                <a:cs typeface="Times New Roman" panose="02020603050405020304" pitchFamily="18" charset="0"/>
-              </a:rPr>
-              <a:t>   - </a:t>
-            </a:r>
-            <a:r>
-              <a:rPr sz="1400" b="1" dirty="0">
-                <a:latin typeface="Times New Roman" panose="02020603050405020304" pitchFamily="18" charset="0"/>
-                <a:cs typeface="Times New Roman" panose="02020603050405020304" pitchFamily="18" charset="0"/>
-              </a:rPr>
-              <a:t>STAC Collection: </a:t>
-            </a:r>
-            <a:r>
-              <a:rPr sz="1400" dirty="0">
-                <a:latin typeface="Times New Roman" panose="02020603050405020304" pitchFamily="18" charset="0"/>
-                <a:cs typeface="Times New Roman" panose="02020603050405020304" pitchFamily="18" charset="0"/>
-              </a:rPr>
-              <a:t>Groups related UAV images, documenting camera specs, focal length, and spatial boundaries.</a:t>
-            </a:r>
-          </a:p>
-          <a:p>
-            <a:pPr lvl="1">
-              <a:defRPr sz="1100">
-                <a:solidFill>
-                  <a:srgbClr val="1E1E1E"/>
-                </a:solidFill>
-                <a:latin typeface="Arial"/>
-              </a:defRPr>
-            </a:pPr>
-            <a:r>
-              <a:rPr sz="1400" dirty="0">
-                <a:latin typeface="Times New Roman" panose="02020603050405020304" pitchFamily="18" charset="0"/>
-                <a:cs typeface="Times New Roman" panose="02020603050405020304" pitchFamily="18" charset="0"/>
-              </a:rPr>
-              <a:t>   - </a:t>
-            </a:r>
-            <a:r>
-              <a:rPr sz="1400" b="1" dirty="0">
-                <a:latin typeface="Times New Roman" panose="02020603050405020304" pitchFamily="18" charset="0"/>
-                <a:cs typeface="Times New Roman" panose="02020603050405020304" pitchFamily="18" charset="0"/>
-              </a:rPr>
-              <a:t>STAC Item</a:t>
-            </a:r>
-            <a:r>
-              <a:rPr sz="1400" dirty="0">
-                <a:latin typeface="Times New Roman" panose="02020603050405020304" pitchFamily="18" charset="0"/>
-                <a:cs typeface="Times New Roman" panose="02020603050405020304" pitchFamily="18" charset="0"/>
-              </a:rPr>
-              <a:t>: </a:t>
-            </a:r>
-            <a:r>
-              <a:rPr sz="1400" dirty="0" err="1">
-                <a:latin typeface="Times New Roman" panose="02020603050405020304" pitchFamily="18" charset="0"/>
-                <a:cs typeface="Times New Roman" panose="02020603050405020304" pitchFamily="18" charset="0"/>
-              </a:rPr>
-              <a:t>GeoJSON</a:t>
-            </a:r>
-            <a:r>
-              <a:rPr sz="1400" dirty="0">
-                <a:latin typeface="Times New Roman" panose="02020603050405020304" pitchFamily="18" charset="0"/>
-                <a:cs typeface="Times New Roman" panose="02020603050405020304" pitchFamily="18" charset="0"/>
-              </a:rPr>
-              <a:t>-based metadata document describing a single image, linked to the raw JPG asset.</a:t>
-            </a:r>
-            <a:endParaRPr lang="en-IN" sz="1400" dirty="0">
-              <a:latin typeface="Times New Roman" panose="02020603050405020304" pitchFamily="18" charset="0"/>
-              <a:cs typeface="Times New Roman" panose="02020603050405020304" pitchFamily="18" charset="0"/>
-            </a:endParaRPr>
-          </a:p>
-          <a:p>
-            <a:pPr lvl="1">
-              <a:defRPr sz="1100">
-                <a:solidFill>
-                  <a:srgbClr val="1E1E1E"/>
-                </a:solidFill>
-                <a:latin typeface="Arial"/>
-              </a:defRPr>
-            </a:pPr>
-            <a:endParaRPr sz="1400" dirty="0">
-              <a:latin typeface="Times New Roman" panose="02020603050405020304" pitchFamily="18" charset="0"/>
-              <a:cs typeface="Times New Roman" panose="02020603050405020304" pitchFamily="18" charset="0"/>
-            </a:endParaRPr>
+              <a:t>   - Standardizes services like CSW (Catalog Service for Web) to publish and search ISO XML documents.</a:t>
+            </a:r>
           </a:p>
           <a:p>
             <a:pPr>
@@ -5128,25 +4322,7 @@
               </a:defRPr>
             </a:pPr>
             <a:r>
-              <a:rPr sz="1400" dirty="0">
-                <a:latin typeface="Times New Roman" panose="02020603050405020304" pitchFamily="18" charset="0"/>
-                <a:cs typeface="Times New Roman" panose="02020603050405020304" pitchFamily="18" charset="0"/>
-              </a:rPr>
-              <a:t>• </a:t>
-            </a:r>
-            <a:r>
-              <a:rPr sz="1400" b="1" dirty="0">
-                <a:latin typeface="Times New Roman" panose="02020603050405020304" pitchFamily="18" charset="0"/>
-                <a:cs typeface="Times New Roman" panose="02020603050405020304" pitchFamily="18" charset="0"/>
-              </a:rPr>
-              <a:t>STAC API: </a:t>
-            </a:r>
-            <a:r>
-              <a:rPr sz="1400" dirty="0">
-                <a:latin typeface="Times New Roman" panose="02020603050405020304" pitchFamily="18" charset="0"/>
-                <a:cs typeface="Times New Roman" panose="02020603050405020304" pitchFamily="18" charset="0"/>
-              </a:rPr>
-              <a:t>Defines a standard RESTful query API to search drone photos by time ranges and footprint bounding boxes.</a:t>
+              <a:t>• Main Limitation: Complex XML encoding makes them difficult for cloud software and web APIs to read rapidly.</a:t>
             </a:r>
           </a:p>
         </p:txBody>
@@ -5160,7 +4336,7 @@
 </file>
 
 <file path=ppt/slides/slide7.xml><?xml version="1.0" encoding="utf-8"?>
-<p:sld xmlns:a="http://schemas.openxmlformats.org/drawingml/2006/main" xmlns:r="http://schemas.openxmlformats.org/officeDocument/2006/relationships" xmlns:p="http://schemas.openxmlformats.org/presentationml/2006/main">
+<p:sld xmlns:a="http://schemas.openxmlformats.org/drawingml/2006/main" xmlns:p="http://schemas.openxmlformats.org/presentationml/2006/main" xmlns:r="http://schemas.openxmlformats.org/officeDocument/2006/relationships">
   <p:cSld>
     <p:spTree>
       <p:nvGrpSpPr>
@@ -5168,14 +4344,7 @@
         <p:cNvGrpSpPr/>
         <p:nvPr/>
       </p:nvGrpSpPr>
-      <p:grpSpPr>
-        <a:xfrm>
-          <a:off x="0" y="0"/>
-          <a:ext cx="0" cy="0"/>
-          <a:chOff x="0" y="0"/>
-          <a:chExt cx="0" cy="0"/>
-        </a:xfrm>
-      </p:grpSpPr>
+      <p:grpSpPr/>
       <p:sp>
         <p:nvSpPr>
           <p:cNvPr id="2" name="TextBox 1"/>
@@ -5207,7 +4376,7 @@
               </a:defRPr>
             </a:pPr>
             <a:r>
-              <a:t>COMPARATIVE ANALYSIS FOR UAV INTEROPERABILITY</a:t>
+              <a:t>CLOUD-OPTIMIZED FORMATS (COG &amp; COPC)</a:t>
             </a:r>
           </a:p>
         </p:txBody>
@@ -5220,8 +4389,8 @@
         </p:nvSpPr>
         <p:spPr>
           <a:xfrm>
-            <a:off x="457199" y="1097279"/>
-            <a:ext cx="5048451" cy="3108543"/>
+            <a:off x="457200" y="1097280"/>
+            <a:ext cx="8229600" cy="3657600"/>
           </a:xfrm>
           <a:prstGeom prst="rect">
             <a:avLst/>
@@ -5243,44 +4412,47 @@
               </a:defRPr>
             </a:pPr>
             <a:r>
-              <a:rPr sz="1400" dirty="0">
-                <a:latin typeface="Times New Roman" panose="02020603050405020304" pitchFamily="18" charset="0"/>
-                <a:cs typeface="Times New Roman" panose="02020603050405020304" pitchFamily="18" charset="0"/>
-              </a:rPr>
-              <a:t>• </a:t>
-            </a:r>
-            <a:r>
-              <a:rPr sz="1400" b="1" dirty="0">
-                <a:latin typeface="Times New Roman" panose="02020603050405020304" pitchFamily="18" charset="0"/>
-                <a:cs typeface="Times New Roman" panose="02020603050405020304" pitchFamily="18" charset="0"/>
-              </a:rPr>
-              <a:t>ISO Standards: </a:t>
-            </a:r>
-            <a:r>
-              <a:rPr sz="1400" dirty="0">
-                <a:latin typeface="Times New Roman" panose="02020603050405020304" pitchFamily="18" charset="0"/>
-                <a:cs typeface="Times New Roman" panose="02020603050405020304" pitchFamily="18" charset="0"/>
-              </a:rPr>
-              <a:t>Heavyweight, structured for formal catalogs, but difficult to implement for single </a:t>
-            </a:r>
-            <a:r>
-              <a:rPr sz="1400" dirty="0" err="1">
-                <a:latin typeface="Times New Roman" panose="02020603050405020304" pitchFamily="18" charset="0"/>
-                <a:cs typeface="Times New Roman" panose="02020603050405020304" pitchFamily="18" charset="0"/>
-              </a:rPr>
-              <a:t>uav</a:t>
-            </a:r>
-            <a:r>
-              <a:rPr sz="1400" dirty="0">
-                <a:latin typeface="Times New Roman" panose="02020603050405020304" pitchFamily="18" charset="0"/>
-                <a:cs typeface="Times New Roman" panose="02020603050405020304" pitchFamily="18" charset="0"/>
-              </a:rPr>
-              <a:t> frames.</a:t>
-            </a:r>
-            <a:endParaRPr lang="en-IN" sz="1400" dirty="0">
-              <a:latin typeface="Times New Roman" panose="02020603050405020304" pitchFamily="18" charset="0"/>
-              <a:cs typeface="Times New Roman" panose="02020603050405020304" pitchFamily="18" charset="0"/>
-            </a:endParaRPr>
+              <a:t>• GeoTIFF vs. Cloud Optimized GeoTIFF (COG):</a:t>
+            </a:r>
+          </a:p>
+          <a:p>
+            <a:pPr lvl="1">
+              <a:defRPr sz="1100">
+                <a:solidFill>
+                  <a:srgbClr val="1E1E1E"/>
+                </a:solidFill>
+                <a:latin typeface="Arial"/>
+              </a:defRPr>
+            </a:pPr>
+            <a:r>
+              <a:t>   - Standard GeoTIFF has to be read entirely to query an elevation point.</a:t>
+            </a:r>
+          </a:p>
+          <a:p>
+            <a:pPr lvl="1">
+              <a:defRPr sz="1100">
+                <a:solidFill>
+                  <a:srgbClr val="1E1E1E"/>
+                </a:solidFill>
+                <a:latin typeface="Arial"/>
+              </a:defRPr>
+            </a:pPr>
+            <a:r>
+              <a:t>   - COG organizes elevation cells into HTTP range request tiles.</a:t>
+            </a:r>
+          </a:p>
+          <a:p>
+            <a:pPr lvl="1">
+              <a:defRPr sz="1100">
+                <a:solidFill>
+                  <a:srgbClr val="1E1E1E"/>
+                </a:solidFill>
+                <a:latin typeface="Arial"/>
+              </a:defRPr>
+            </a:pPr>
+            <a:r>
+              <a:t>   - Allows GIS apps to query terrain elevation in milliseconds over a network without downloading the full gigabyte file.</a:t>
+            </a:r>
           </a:p>
           <a:p>
             <a:pPr>
@@ -5291,11 +4463,126 @@
                 <a:latin typeface="Arial"/>
               </a:defRPr>
             </a:pPr>
-            <a:endParaRPr sz="1400" dirty="0">
-              <a:latin typeface="Times New Roman" panose="02020603050405020304" pitchFamily="18" charset="0"/>
-              <a:cs typeface="Times New Roman" panose="02020603050405020304" pitchFamily="18" charset="0"/>
-            </a:endParaRPr>
-          </a:p>
+            <a:r>
+              <a:t>• LAS/LAZ vs. Cloud Optimized Point Cloud (COPC):</a:t>
+            </a:r>
+          </a:p>
+          <a:p>
+            <a:pPr lvl="1">
+              <a:defRPr sz="1100">
+                <a:solidFill>
+                  <a:srgbClr val="1E1E1E"/>
+                </a:solidFill>
+                <a:latin typeface="Arial"/>
+              </a:defRPr>
+            </a:pPr>
+            <a:r>
+              <a:t>   - LAZ files are compressed point clouds but lack spatial indexes.</a:t>
+            </a:r>
+          </a:p>
+          <a:p>
+            <a:pPr lvl="1">
+              <a:defRPr sz="1100">
+                <a:solidFill>
+                  <a:srgbClr val="1E1E1E"/>
+                </a:solidFill>
+                <a:latin typeface="Arial"/>
+              </a:defRPr>
+            </a:pPr>
+            <a:r>
+              <a:t>   - COPC structures point clouds as an octree layout inside a LAZ file.</a:t>
+            </a:r>
+          </a:p>
+          <a:p>
+            <a:pPr lvl="1">
+              <a:defRPr sz="1100">
+                <a:solidFill>
+                  <a:srgbClr val="1E1E1E"/>
+                </a:solidFill>
+                <a:latin typeface="Arial"/>
+              </a:defRPr>
+            </a:pPr>
+            <a:r>
+              <a:t>   - Enables streaming of points based on resolution and bounding boxes.</a:t>
+            </a:r>
+          </a:p>
+        </p:txBody>
+      </p:sp>
+    </p:spTree>
+  </p:cSld>
+  <p:clrMapOvr>
+    <a:masterClrMapping/>
+  </p:clrMapOvr>
+</p:sld>
+</file>
+
+<file path=ppt/slides/slide8.xml><?xml version="1.0" encoding="utf-8"?>
+<p:sld xmlns:a="http://schemas.openxmlformats.org/drawingml/2006/main" xmlns:p="http://schemas.openxmlformats.org/presentationml/2006/main" xmlns:r="http://schemas.openxmlformats.org/officeDocument/2006/relationships">
+  <p:cSld>
+    <p:spTree>
+      <p:nvGrpSpPr>
+        <p:cNvPr id="1" name=""/>
+        <p:cNvGrpSpPr/>
+        <p:nvPr/>
+      </p:nvGrpSpPr>
+      <p:grpSpPr/>
+      <p:sp>
+        <p:nvSpPr>
+          <p:cNvPr id="2" name="TextBox 1"/>
+          <p:cNvSpPr txBox="1"/>
+          <p:nvPr/>
+        </p:nvSpPr>
+        <p:spPr>
+          <a:xfrm>
+            <a:off x="457200" y="182880"/>
+            <a:ext cx="8229600" cy="731520"/>
+          </a:xfrm>
+          <a:prstGeom prst="rect">
+            <a:avLst/>
+          </a:prstGeom>
+          <a:noFill/>
+        </p:spPr>
+        <p:txBody>
+          <a:bodyPr wrap="square">
+            <a:spAutoFit/>
+          </a:bodyPr>
+          <a:lstStyle/>
+          <a:p>
+            <a:pPr algn="ctr">
+              <a:defRPr sz="2400" b="1" u="sng">
+                <a:solidFill>
+                  <a:srgbClr val="33B3FF"/>
+                </a:solidFill>
+                <a:latin typeface="Arial"/>
+              </a:defRPr>
+            </a:pPr>
+            <a:r>
+              <a:t>SPATIOTEMPORAL ASSET CATALOG (STAC)</a:t>
+            </a:r>
+          </a:p>
+        </p:txBody>
+      </p:sp>
+      <p:sp>
+        <p:nvSpPr>
+          <p:cNvPr id="3" name="TextBox 2"/>
+          <p:cNvSpPr txBox="1"/>
+          <p:nvPr/>
+        </p:nvSpPr>
+        <p:spPr>
+          <a:xfrm>
+            <a:off x="457200" y="1097280"/>
+            <a:ext cx="4937760" cy="3657600"/>
+          </a:xfrm>
+          <a:prstGeom prst="rect">
+            <a:avLst/>
+          </a:prstGeom>
+          <a:noFill/>
+        </p:spPr>
+        <p:txBody>
+          <a:bodyPr wrap="square">
+            <a:spAutoFit/>
+          </a:bodyPr>
+          <a:lstStyle/>
           <a:p>
             <a:pPr>
               <a:defRPr sz="1300">
@@ -5306,37 +4593,8 @@
               </a:defRPr>
             </a:pPr>
             <a:r>
-              <a:rPr sz="1400" dirty="0">
-                <a:latin typeface="Times New Roman" panose="02020603050405020304" pitchFamily="18" charset="0"/>
-                <a:cs typeface="Times New Roman" panose="02020603050405020304" pitchFamily="18" charset="0"/>
-              </a:rPr>
-              <a:t>• </a:t>
-            </a:r>
-            <a:r>
-              <a:rPr sz="1400" b="1" dirty="0" err="1">
-                <a:latin typeface="Times New Roman" panose="02020603050405020304" pitchFamily="18" charset="0"/>
-                <a:cs typeface="Times New Roman" panose="02020603050405020304" pitchFamily="18" charset="0"/>
-              </a:rPr>
-              <a:t>GeoJSON</a:t>
-            </a:r>
-            <a:r>
-              <a:rPr sz="1400" b="1" dirty="0">
-                <a:latin typeface="Times New Roman" panose="02020603050405020304" pitchFamily="18" charset="0"/>
-                <a:cs typeface="Times New Roman" panose="02020603050405020304" pitchFamily="18" charset="0"/>
-              </a:rPr>
-              <a:t>: </a:t>
-            </a:r>
-            <a:r>
-              <a:rPr sz="1400" dirty="0">
-                <a:latin typeface="Times New Roman" panose="02020603050405020304" pitchFamily="18" charset="0"/>
-                <a:cs typeface="Times New Roman" panose="02020603050405020304" pitchFamily="18" charset="0"/>
-              </a:rPr>
-              <a:t>Excellent vector format for footprints, but lacks metadata tags for camera calibration and gimbal angles.</a:t>
-            </a:r>
-            <a:endParaRPr lang="en-IN" sz="1400" dirty="0">
-              <a:latin typeface="Times New Roman" panose="02020603050405020304" pitchFamily="18" charset="0"/>
-              <a:cs typeface="Times New Roman" panose="02020603050405020304" pitchFamily="18" charset="0"/>
-            </a:endParaRPr>
+              <a:t>• STAC Specification: A modern JSON-LD metadata standard built to catalog geospatial assets (photos, DEMs, point clouds).</a:t>
+            </a:r>
           </a:p>
           <a:p>
             <a:pPr>
@@ -5347,10 +4605,48 @@
                 <a:latin typeface="Arial"/>
               </a:defRPr>
             </a:pPr>
-            <a:endParaRPr sz="1400" dirty="0">
-              <a:latin typeface="Times New Roman" panose="02020603050405020304" pitchFamily="18" charset="0"/>
-              <a:cs typeface="Times New Roman" panose="02020603050405020304" pitchFamily="18" charset="0"/>
-            </a:endParaRPr>
+            <a:r>
+              <a:t>• Three core components in the STAC hierarchy:</a:t>
+            </a:r>
+          </a:p>
+          <a:p>
+            <a:pPr lvl="1">
+              <a:defRPr sz="1100">
+                <a:solidFill>
+                  <a:srgbClr val="1E1E1E"/>
+                </a:solidFill>
+                <a:latin typeface="Arial"/>
+              </a:defRPr>
+            </a:pPr>
+            <a:r>
+              <a:t>   - STAC Catalog: The root JSON file indexing the structure.</a:t>
+            </a:r>
+          </a:p>
+          <a:p>
+            <a:pPr lvl="1">
+              <a:defRPr sz="1100">
+                <a:solidFill>
+                  <a:srgbClr val="1E1E1E"/>
+                </a:solidFill>
+                <a:latin typeface="Arial"/>
+              </a:defRPr>
+            </a:pPr>
+            <a:r>
+              <a:t>   - STAC Collection: Groups related UAV images, documenting camera specs, focal length, and spatial boundaries.</a:t>
+            </a:r>
+          </a:p>
+          <a:p>
+            <a:pPr lvl="1">
+              <a:defRPr sz="1100">
+                <a:solidFill>
+                  <a:srgbClr val="1E1E1E"/>
+                </a:solidFill>
+                <a:latin typeface="Arial"/>
+              </a:defRPr>
+            </a:pPr>
+            <a:r>
+              <a:t>   - STAC Item: GeoJSON-based metadata document describing a single image, linked to the raw JPG asset.</a:t>
+            </a:r>
           </a:p>
           <a:p>
             <a:pPr>
@@ -5362,45 +4658,110 @@
               </a:defRPr>
             </a:pPr>
             <a:r>
-              <a:rPr sz="1400" dirty="0">
-                <a:latin typeface="Times New Roman" panose="02020603050405020304" pitchFamily="18" charset="0"/>
-                <a:cs typeface="Times New Roman" panose="02020603050405020304" pitchFamily="18" charset="0"/>
-              </a:rPr>
-              <a:t>• </a:t>
-            </a:r>
-            <a:r>
-              <a:rPr sz="1400" b="1" dirty="0">
-                <a:latin typeface="Times New Roman" panose="02020603050405020304" pitchFamily="18" charset="0"/>
-                <a:cs typeface="Times New Roman" panose="02020603050405020304" pitchFamily="18" charset="0"/>
-              </a:rPr>
-              <a:t>STAC: </a:t>
-            </a:r>
-            <a:r>
-              <a:rPr sz="1400" dirty="0">
-                <a:latin typeface="Times New Roman" panose="02020603050405020304" pitchFamily="18" charset="0"/>
-                <a:cs typeface="Times New Roman" panose="02020603050405020304" pitchFamily="18" charset="0"/>
-              </a:rPr>
-              <a:t>Combines the best of both worlds. Represents footprints in </a:t>
-            </a:r>
-            <a:r>
-              <a:rPr sz="1400" dirty="0" err="1">
-                <a:latin typeface="Times New Roman" panose="02020603050405020304" pitchFamily="18" charset="0"/>
-                <a:cs typeface="Times New Roman" panose="02020603050405020304" pitchFamily="18" charset="0"/>
-              </a:rPr>
-              <a:t>GeoJSON</a:t>
-            </a:r>
-            <a:r>
-              <a:rPr sz="1400" dirty="0">
-                <a:latin typeface="Times New Roman" panose="02020603050405020304" pitchFamily="18" charset="0"/>
-                <a:cs typeface="Times New Roman" panose="02020603050405020304" pitchFamily="18" charset="0"/>
-              </a:rPr>
-              <a:t> while storing rich camera assets and flight telemetry in structured JSON-LD properties.</a:t>
-            </a:r>
-            <a:endParaRPr lang="en-IN" sz="1400" dirty="0">
-              <a:latin typeface="Times New Roman" panose="02020603050405020304" pitchFamily="18" charset="0"/>
-              <a:cs typeface="Times New Roman" panose="02020603050405020304" pitchFamily="18" charset="0"/>
-            </a:endParaRPr>
-          </a:p>
+              <a:t>• STAC API: Defines a standard RESTful query API to search drone photos by time ranges and footprint bounding boxes.</a:t>
+            </a:r>
+          </a:p>
+        </p:txBody>
+      </p:sp>
+      <p:pic>
+        <p:nvPicPr>
+          <p:cNvPr id="4" name="Picture 3" descr="fig_stac.png"/>
+          <p:cNvPicPr>
+            <a:picLocks noChangeAspect="1"/>
+          </p:cNvPicPr>
+          <p:nvPr/>
+        </p:nvPicPr>
+        <p:blipFill>
+          <a:blip r:embed="rId2"/>
+          <a:stretch>
+            <a:fillRect/>
+          </a:stretch>
+        </p:blipFill>
+        <p:spPr>
+          <a:xfrm>
+            <a:off x="5577840" y="1097280"/>
+            <a:ext cx="3108960" cy="2872185"/>
+          </a:xfrm>
+          <a:prstGeom prst="rect">
+            <a:avLst/>
+          </a:prstGeom>
+        </p:spPr>
+      </p:pic>
+    </p:spTree>
+  </p:cSld>
+  <p:clrMapOvr>
+    <a:masterClrMapping/>
+  </p:clrMapOvr>
+</p:sld>
+</file>
+
+<file path=ppt/slides/slide9.xml><?xml version="1.0" encoding="utf-8"?>
+<p:sld xmlns:a="http://schemas.openxmlformats.org/drawingml/2006/main" xmlns:p="http://schemas.openxmlformats.org/presentationml/2006/main" xmlns:r="http://schemas.openxmlformats.org/officeDocument/2006/relationships">
+  <p:cSld>
+    <p:spTree>
+      <p:nvGrpSpPr>
+        <p:cNvPr id="1" name=""/>
+        <p:cNvGrpSpPr/>
+        <p:nvPr/>
+      </p:nvGrpSpPr>
+      <p:grpSpPr/>
+      <p:sp>
+        <p:nvSpPr>
+          <p:cNvPr id="2" name="TextBox 1"/>
+          <p:cNvSpPr txBox="1"/>
+          <p:nvPr/>
+        </p:nvSpPr>
+        <p:spPr>
+          <a:xfrm>
+            <a:off x="457200" y="182880"/>
+            <a:ext cx="8229600" cy="731520"/>
+          </a:xfrm>
+          <a:prstGeom prst="rect">
+            <a:avLst/>
+          </a:prstGeom>
+          <a:noFill/>
+        </p:spPr>
+        <p:txBody>
+          <a:bodyPr wrap="square">
+            <a:spAutoFit/>
+          </a:bodyPr>
+          <a:lstStyle/>
+          <a:p>
+            <a:pPr algn="ctr">
+              <a:defRPr sz="2400" b="1" u="sng">
+                <a:solidFill>
+                  <a:srgbClr val="33B3FF"/>
+                </a:solidFill>
+                <a:latin typeface="Arial"/>
+              </a:defRPr>
+            </a:pPr>
+            <a:r>
+              <a:t>COMPARATIVE ANALYSIS FOR UAV INTEROPERABILITY</a:t>
+            </a:r>
+          </a:p>
+        </p:txBody>
+      </p:sp>
+      <p:sp>
+        <p:nvSpPr>
+          <p:cNvPr id="3" name="TextBox 2"/>
+          <p:cNvSpPr txBox="1"/>
+          <p:nvPr/>
+        </p:nvSpPr>
+        <p:spPr>
+          <a:xfrm>
+            <a:off x="457200" y="1097280"/>
+            <a:ext cx="4937760" cy="3657600"/>
+          </a:xfrm>
+          <a:prstGeom prst="rect">
+            <a:avLst/>
+          </a:prstGeom>
+          <a:noFill/>
+        </p:spPr>
+        <p:txBody>
+          <a:bodyPr wrap="square">
+            <a:spAutoFit/>
+          </a:bodyPr>
+          <a:lstStyle/>
           <a:p>
             <a:pPr>
               <a:defRPr sz="1300">
@@ -5410,10 +4771,9 @@
                 <a:latin typeface="Arial"/>
               </a:defRPr>
             </a:pPr>
-            <a:endParaRPr sz="1400" dirty="0">
-              <a:latin typeface="Times New Roman" panose="02020603050405020304" pitchFamily="18" charset="0"/>
-              <a:cs typeface="Times New Roman" panose="02020603050405020304" pitchFamily="18" charset="0"/>
-            </a:endParaRPr>
+            <a:r>
+              <a:t>• ISO Standards: Heavyweight, structured for formal catalogs, but difficult to implement for single uav frames.</a:t>
+            </a:r>
           </a:p>
           <a:p>
             <a:pPr>
@@ -5425,10 +4785,32 @@
               </a:defRPr>
             </a:pPr>
             <a:r>
-              <a:rPr sz="1400" dirty="0">
-                <a:latin typeface="Times New Roman" panose="02020603050405020304" pitchFamily="18" charset="0"/>
-                <a:cs typeface="Times New Roman" panose="02020603050405020304" pitchFamily="18" charset="0"/>
-              </a:rPr>
+              <a:t>• GeoJSON: Excellent vector format for footprints, but lacks metadata tags for camera calibration and gimbal angles.</a:t>
+            </a:r>
+          </a:p>
+          <a:p>
+            <a:pPr>
+              <a:defRPr sz="1300">
+                <a:solidFill>
+                  <a:srgbClr val="1E1E1E"/>
+                </a:solidFill>
+                <a:latin typeface="Arial"/>
+              </a:defRPr>
+            </a:pPr>
+            <a:r>
+              <a:t>• STAC: Combines the best of both worlds. Represents footprints in GeoJSON while storing rich camera assets and flight telemetry in structured JSON-LD properties.</a:t>
+            </a:r>
+          </a:p>
+          <a:p>
+            <a:pPr>
+              <a:defRPr sz="1300">
+                <a:solidFill>
+                  <a:srgbClr val="1E1E1E"/>
+                </a:solidFill>
+                <a:latin typeface="Arial"/>
+              </a:defRPr>
+            </a:pPr>
+            <a:r>
               <a:t>• Recommendation for UAV GIS Workflows:</a:t>
             </a:r>
           </a:p>
@@ -5442,10 +4824,6 @@
               </a:defRPr>
             </a:pPr>
             <a:r>
-              <a:rPr sz="1400" dirty="0">
-                <a:latin typeface="Times New Roman" panose="02020603050405020304" pitchFamily="18" charset="0"/>
-                <a:cs typeface="Times New Roman" panose="02020603050405020304" pitchFamily="18" charset="0"/>
-              </a:rPr>
               <a:t>   - Store raw telemetry in STAC Items.</a:t>
             </a:r>
           </a:p>
@@ -5459,25 +4837,7 @@
               </a:defRPr>
             </a:pPr>
             <a:r>
-              <a:rPr sz="1400" dirty="0">
-                <a:latin typeface="Times New Roman" panose="02020603050405020304" pitchFamily="18" charset="0"/>
-                <a:cs typeface="Times New Roman" panose="02020603050405020304" pitchFamily="18" charset="0"/>
-              </a:rPr>
-              <a:t>   - Export footprint boundaries as </a:t>
-            </a:r>
-            <a:r>
-              <a:rPr sz="1400" dirty="0" err="1">
-                <a:latin typeface="Times New Roman" panose="02020603050405020304" pitchFamily="18" charset="0"/>
-                <a:cs typeface="Times New Roman" panose="02020603050405020304" pitchFamily="18" charset="0"/>
-              </a:rPr>
-              <a:t>GeoJSON</a:t>
-            </a:r>
-            <a:r>
-              <a:rPr sz="1400" dirty="0">
-                <a:latin typeface="Times New Roman" panose="02020603050405020304" pitchFamily="18" charset="0"/>
-                <a:cs typeface="Times New Roman" panose="02020603050405020304" pitchFamily="18" charset="0"/>
-              </a:rPr>
-              <a:t> features.</a:t>
+              <a:t>   - Export footprint boundaries as GeoJSON features.</a:t>
             </a:r>
           </a:p>
           <a:p>
@@ -5490,10 +4850,6 @@
               </a:defRPr>
             </a:pPr>
             <a:r>
-              <a:rPr sz="1400" dirty="0">
-                <a:latin typeface="Times New Roman" panose="02020603050405020304" pitchFamily="18" charset="0"/>
-                <a:cs typeface="Times New Roman" panose="02020603050405020304" pitchFamily="18" charset="0"/>
-              </a:rPr>
               <a:t>   - Stream elevation and point clouds via COG and COPC.</a:t>
             </a:r>
           </a:p>
@@ -5509,13 +4865,14 @@
         </p:nvPicPr>
         <p:blipFill>
           <a:blip r:embed="rId2"/>
-          <a:srcRect t="26553" b="24676"/>
-          <a:stretch/>
+          <a:stretch>
+            <a:fillRect/>
+          </a:stretch>
         </p:blipFill>
         <p:spPr>
           <a:xfrm>
-            <a:off x="5577839" y="1617045"/>
-            <a:ext cx="3421781" cy="1790298"/>
+            <a:off x="5577840" y="1097280"/>
+            <a:ext cx="3108960" cy="1957493"/>
           </a:xfrm>
           <a:prstGeom prst="rect">
             <a:avLst/>

</xml_diff>

<commit_message>
Synchronize slide values with exact dynamic EXIF calculation outputs
</commit_message>
<xml_diff>
--- a/Drone_Footprint_Mapping_and_Metadata_Standards.pptx
+++ b/Drone_Footprint_Mapping_and_Metadata_Standards.pptx
@@ -3472,7 +3472,7 @@
               </a:defRPr>
             </a:pPr>
             <a:r>
-              <a:t>   - Horizontal FOV = 2 * arctan(Sw / (2 * f)) = 81.03°</a:t>
+              <a:t>   - Horizontal FOV = 2 * arctan(Sw / (2 * f)) = 81.20°</a:t>
             </a:r>
           </a:p>
           <a:p>
@@ -3485,7 +3485,7 @@
               </a:defRPr>
             </a:pPr>
             <a:r>
-              <a:t>   - Corrected Vertical FOV = 2 * arctan(Sh / (2 * f)) = 50.64° (instead of 64.44°)</a:t>
+              <a:t>   - Corrected Vertical FOV = 2 * arctan(Sh / (2 * f)) = 51.35° (instead of 64.44°)</a:t>
             </a:r>
           </a:p>
           <a:p>

</xml_diff>

<commit_message>
Update presentation slides with detailed Mathematical Footprint Computation and Geometric Polygon Generation slides for director review
</commit_message>
<xml_diff>
--- a/Drone_Footprint_Mapping_and_Metadata_Standards.pptx
+++ b/Drone_Footprint_Mapping_and_Metadata_Standards.pptx
@@ -3371,7 +3371,7 @@
               </a:defRPr>
             </a:pPr>
             <a:r>
-              <a:t>CAMERA FIELD OF VIEW &amp; COVERAGE MATH</a:t>
+              <a:t>MATHEMATICAL FOOTPRINT COMPUTATION</a:t>
             </a:r>
           </a:p>
         </p:txBody>
@@ -3407,7 +3407,7 @@
               </a:defRPr>
             </a:pPr>
             <a:r>
-              <a:t>• Camera parameters: Focal length (f = 3.61 mm), Sensor width (Sw = 6.17 mm).</a:t>
+              <a:t>• Objective: Calculate the physical ground dimensions of the camera sensor's Field of View (FOV) using flight parameters.</a:t>
             </a:r>
           </a:p>
           <a:p>
@@ -3420,7 +3420,7 @@
               </a:defRPr>
             </a:pPr>
             <a:r>
-              <a:t>• Sensor Height aspect crop adjustment:</a:t>
+              <a:t>• Step 6: Calculating viewing angles (FOV):</a:t>
             </a:r>
           </a:p>
           <a:p>
@@ -3433,7 +3433,7 @@
               </a:defRPr>
             </a:pPr>
             <a:r>
-              <a:t>   - Widescreen 16:9 images (4000x2250) crop the physical 4:3 sensor (4.55 mm).</a:t>
+              <a:t>   - Horizontal FOV = 2 * arctan(Sw / (2 * f)) = 81.20°</a:t>
             </a:r>
           </a:p>
           <a:p>
@@ -3446,7 +3446,33 @@
               </a:defRPr>
             </a:pPr>
             <a:r>
-              <a:t>   - Effective sensor height: Sh = 6.17 * (2250 / 4000) = 3.47 mm.</a:t>
+              <a:t>     (using sensor width Sw = 6.17 mm and focal length f = 3.6 mm)</a:t>
+            </a:r>
+          </a:p>
+          <a:p>
+            <a:pPr lvl="1">
+              <a:defRPr sz="1100">
+                <a:solidFill>
+                  <a:srgbClr val="1E1E1E"/>
+                </a:solidFill>
+                <a:latin typeface="Arial"/>
+              </a:defRPr>
+            </a:pPr>
+            <a:r>
+              <a:t>   - Corrected Vertical FOV = 2 * arctan(Sh / (2 * f)) = 51.35°</a:t>
+            </a:r>
+          </a:p>
+          <a:p>
+            <a:pPr lvl="1">
+              <a:defRPr sz="1100">
+                <a:solidFill>
+                  <a:srgbClr val="1E1E1E"/>
+                </a:solidFill>
+                <a:latin typeface="Arial"/>
+              </a:defRPr>
+            </a:pPr>
+            <a:r>
+              <a:t>     (using effective sensor height Sh = 3.47 mm, adjusted for 16:9 crop)</a:t>
             </a:r>
           </a:p>
           <a:p>
@@ -3459,7 +3485,7 @@
               </a:defRPr>
             </a:pPr>
             <a:r>
-              <a:t>• Step 6: Calculating viewing angles (FOV):</a:t>
+              <a:t>• Step 7: Ground footprint dimensions (at nadir/straight-down):</a:t>
             </a:r>
           </a:p>
           <a:p>
@@ -3472,7 +3498,7 @@
               </a:defRPr>
             </a:pPr>
             <a:r>
-              <a:t>   - Horizontal FOV = 2 * arctan(Sw / (2 * f)) = 81.20°</a:t>
+              <a:t>   - Width = 2 * Altitude * tan(Horizontal FOV / 2) ≈ 1.71 * Altitude</a:t>
             </a:r>
           </a:p>
           <a:p>
@@ -3485,7 +3511,20 @@
               </a:defRPr>
             </a:pPr>
             <a:r>
-              <a:t>   - Corrected Vertical FOV = 2 * arctan(Sh / (2 * f)) = 51.35° (instead of 64.44°)</a:t>
+              <a:t>   - Corrected Height = 2 * Altitude * tan(Vertical FOV / 2) ≈ 0.96 * Altitude</a:t>
+            </a:r>
+          </a:p>
+          <a:p>
+            <a:pPr lvl="1">
+              <a:defRPr sz="1100">
+                <a:solidFill>
+                  <a:srgbClr val="1E1E1E"/>
+                </a:solidFill>
+                <a:latin typeface="Arial"/>
+              </a:defRPr>
+            </a:pPr>
+            <a:r>
+              <a:t>     (Corrects a +33% scale error caused by using the physical 4:3 height)</a:t>
             </a:r>
           </a:p>
           <a:p>
@@ -3498,33 +3537,7 @@
               </a:defRPr>
             </a:pPr>
             <a:r>
-              <a:t>• Step 7: Ground footprint dimensions (at nadir/straight-down):</a:t>
-            </a:r>
-          </a:p>
-          <a:p>
-            <a:pPr lvl="1">
-              <a:defRPr sz="1100">
-                <a:solidFill>
-                  <a:srgbClr val="1E1E1E"/>
-                </a:solidFill>
-                <a:latin typeface="Arial"/>
-              </a:defRPr>
-            </a:pPr>
-            <a:r>
-              <a:t>   - Width = 2 * Altitude * tan(Horizontal FOV / 2) ≈ 1.71 * Altitude</a:t>
-            </a:r>
-          </a:p>
-          <a:p>
-            <a:pPr lvl="1">
-              <a:defRPr sz="1100">
-                <a:solidFill>
-                  <a:srgbClr val="1E1E1E"/>
-                </a:solidFill>
-                <a:latin typeface="Arial"/>
-              </a:defRPr>
-            </a:pPr>
-            <a:r>
-              <a:t>   - Corrected Height = 2 * Altitude * tan(Vertical FOV / 2) ≈ 0.96 * Altitude (instead of 1.28)</a:t>
+              <a:t>• Oblique Alignment: Camera tilt (pitch) distorts footprints from symmetric rectangles into quadrilaterals.</a:t>
             </a:r>
           </a:p>
           <a:p>
@@ -3537,33 +3550,7 @@
               </a:defRPr>
             </a:pPr>
             <a:r>
-              <a:t>• Step 8: 2D Rotation using Yaw Orientation:</a:t>
-            </a:r>
-          </a:p>
-          <a:p>
-            <a:pPr lvl="1">
-              <a:defRPr sz="1100">
-                <a:solidFill>
-                  <a:srgbClr val="1E1E1E"/>
-                </a:solidFill>
-                <a:latin typeface="Arial"/>
-              </a:defRPr>
-            </a:pPr>
-            <a:r>
-              <a:t>   - X_rot = X_local * cos(yaw) + Y_local * sin(yaw)</a:t>
-            </a:r>
-          </a:p>
-          <a:p>
-            <a:pPr lvl="1">
-              <a:defRPr sz="1100">
-                <a:solidFill>
-                  <a:srgbClr val="1E1E1E"/>
-                </a:solidFill>
-                <a:latin typeface="Arial"/>
-              </a:defRPr>
-            </a:pPr>
-            <a:r>
-              <a:t>   - Y_rot = -X_local * sin(yaw) + Y_local * cos(yaw)</a:t>
+              <a:t>• Practical Value: Prevents overlap calculation errors, ensuring proper flight alignment and GSD resolutions.</a:t>
             </a:r>
           </a:p>
         </p:txBody>
@@ -3641,7 +3628,7 @@
               </a:defRPr>
             </a:pPr>
             <a:r>
-              <a:t>COORDINATE REFERENCE SYSTEMS &amp; PROJECTIONS</a:t>
+              <a:t>GEOMETRIC POLYGON GENERATION</a:t>
             </a:r>
           </a:p>
         </p:txBody>
@@ -3677,7 +3664,7 @@
               </a:defRPr>
             </a:pPr>
             <a:r>
-              <a:t>• Global Reference System: Drone images log coordinates in WGS 84 (EPSG:4326) degrees.</a:t>
+              <a:t>• Objective: Translate calculated physical ground dimensions into spatial map coordinates to create 2D vector polygons.</a:t>
             </a:r>
           </a:p>
           <a:p>
@@ -3690,7 +3677,20 @@
               </a:defRPr>
             </a:pPr>
             <a:r>
-              <a:t>• Flattening Map System: Calculations (meters) require projecting to UTM grid.</a:t>
+              <a:t>• Step 8: Flat Grid Conversion (Geospatial Projection):</a:t>
+            </a:r>
+          </a:p>
+          <a:p>
+            <a:pPr lvl="1">
+              <a:defRPr sz="1100">
+                <a:solidFill>
+                  <a:srgbClr val="1E1E1E"/>
+                </a:solidFill>
+                <a:latin typeface="Arial"/>
+              </a:defRPr>
+            </a:pPr>
+            <a:r>
+              <a:t>   - Projects GPS latitude and longitude (WGS 84 / EPSG:4326 degrees) to flat map meters (UTM Zone 15N / EPSG:32615) using pyproj.</a:t>
             </a:r>
           </a:p>
           <a:p>
@@ -3703,7 +3703,46 @@
               </a:defRPr>
             </a:pPr>
             <a:r>
-              <a:t>• UTM Zone 15N (EPSG:32615) covers Duluth, Minnesota area.</a:t>
+              <a:t>• Corner Rotations using 2D Rotation Matrix (Gimbal Yaw θ):</a:t>
+            </a:r>
+          </a:p>
+          <a:p>
+            <a:pPr lvl="1">
+              <a:defRPr sz="1100">
+                <a:solidFill>
+                  <a:srgbClr val="1E1E1E"/>
+                </a:solidFill>
+                <a:latin typeface="Arial"/>
+              </a:defRPr>
+            </a:pPr>
+            <a:r>
+              <a:t>   - X_rotated = X_drone + X_local * cos(θ) + Y_local * sin(θ)</a:t>
+            </a:r>
+          </a:p>
+          <a:p>
+            <a:pPr lvl="1">
+              <a:defRPr sz="1100">
+                <a:solidFill>
+                  <a:srgbClr val="1E1E1E"/>
+                </a:solidFill>
+                <a:latin typeface="Arial"/>
+              </a:defRPr>
+            </a:pPr>
+            <a:r>
+              <a:t>   - Y_rotated = Y_drone - X_local * sin(θ) + Y_local * cos(θ)</a:t>
+            </a:r>
+          </a:p>
+          <a:p>
+            <a:pPr lvl="1">
+              <a:defRPr sz="1100">
+                <a:solidFill>
+                  <a:srgbClr val="1E1E1E"/>
+                </a:solidFill>
+                <a:latin typeface="Arial"/>
+              </a:defRPr>
+            </a:pPr>
+            <a:r>
+              <a:t>     (Rotates corners around the projected drone center coordinate)</a:t>
             </a:r>
           </a:p>
           <a:p>
@@ -3716,7 +3755,7 @@
               </a:defRPr>
             </a:pPr>
             <a:r>
-              <a:t>• OGR Coordinate Transformations (in C++ App):</a:t>
+              <a:t>• Step 9: Closed Loop Construction:</a:t>
             </a:r>
           </a:p>
           <a:p>
@@ -3729,7 +3768,7 @@
               </a:defRPr>
             </a:pPr>
             <a:r>
-              <a:t>   - Translates UTM 15N to standard spherical GPS coordinates for GeoJSON export.</a:t>
+              <a:t>   - Joins corners sequentially: Top-Left ➔ Top-Right ➔ Bottom-Right ➔ Bottom-Left.</a:t>
             </a:r>
           </a:p>
           <a:p>
@@ -3742,7 +3781,7 @@
               </a:defRPr>
             </a:pPr>
             <a:r>
-              <a:t>   - Translates UTM 15N to UTM 10N (EPSG:32610) to query the dsm.tif GeoTIFF elevation raster.</a:t>
+              <a:t>   - Closes the ring by repeating the first coordinate point as the final entry.</a:t>
             </a:r>
           </a:p>
           <a:p>
@@ -3755,7 +3794,20 @@
               </a:defRPr>
             </a:pPr>
             <a:r>
-              <a:t>• Robust Parsing: Validates numeric data when reading point cloud text blocks and skips text headers (X,Y,Z) to prevent (0,0) coordinate origin drift.</a:t>
+              <a:t>• Step 10: GIS Format Export:</a:t>
+            </a:r>
+          </a:p>
+          <a:p>
+            <a:pPr lvl="1">
+              <a:defRPr sz="1100">
+                <a:solidFill>
+                  <a:srgbClr val="1E1E1E"/>
+                </a:solidFill>
+                <a:latin typeface="Arial"/>
+              </a:defRPr>
+            </a:pPr>
+            <a:r>
+              <a:t>   - Converts coordinates back to standard GPS degrees and writes them as a standardized GeoJSON FeatureCollection ready for QGIS / ArcGIS.</a:t>
             </a:r>
           </a:p>
         </p:txBody>

</xml_diff>

<commit_message>
Update Slide 2 with dynamic similar-triangles hourglass projection diagram matching notebook sketch
</commit_message>
<xml_diff>
--- a/Drone_Footprint_Mapping_and_Metadata_Standards.pptx
+++ b/Drone_Footprint_Mapping_and_Metadata_Standards.pptx
@@ -3420,7 +3420,7 @@
               </a:defRPr>
             </a:pPr>
             <a:r>
-              <a:t>• Step 6: Calculating viewing angles (FOV):</a:t>
+              <a:t>• Camera Field of View (FOV) Angles:</a:t>
             </a:r>
           </a:p>
           <a:p>
@@ -3433,7 +3433,7 @@
               </a:defRPr>
             </a:pPr>
             <a:r>
-              <a:t>   - Horizontal FOV = 2 * arctan(Sw / (2 * f)) = 81.20°</a:t>
+              <a:t>   - fov_h = 2 * math.atan(sensor_width_mm / (2 * focal_length_mm)) = 81.20°</a:t>
             </a:r>
           </a:p>
           <a:p>
@@ -3446,7 +3446,20 @@
               </a:defRPr>
             </a:pPr>
             <a:r>
-              <a:t>     (using sensor width Sw = 6.17 mm and focal length f = 3.6 mm)</a:t>
+              <a:t>   - fov_v = 2 * math.atan(sensor_height_mm / (2 * focal_length_mm)) = 51.35°</a:t>
+            </a:r>
+          </a:p>
+          <a:p>
+            <a:pPr>
+              <a:defRPr sz="1300">
+                <a:solidFill>
+                  <a:srgbClr val="1E1E1E"/>
+                </a:solidFill>
+                <a:latin typeface="Arial"/>
+              </a:defRPr>
+            </a:pPr>
+            <a:r>
+              <a:t>• Aspect Ratio Height Adjustment (Correction):</a:t>
             </a:r>
           </a:p>
           <a:p>
@@ -3459,7 +3472,7 @@
               </a:defRPr>
             </a:pPr>
             <a:r>
-              <a:t>   - Corrected Vertical FOV = 2 * arctan(Sh / (2 * f)) = 51.35°</a:t>
+              <a:t>   - Widescreen 16:9 images crop the physical sensor height to sensor_height_mm = 3.47 mm.</a:t>
             </a:r>
           </a:p>
           <a:p>
@@ -3472,7 +3485,7 @@
               </a:defRPr>
             </a:pPr>
             <a:r>
-              <a:t>     (using effective sensor height Sh = 3.47 mm, adjusted for 16:9 crop)</a:t>
+              <a:t>   - Resolves a +33% scale error caused by using the native physical 4.55 mm height.</a:t>
             </a:r>
           </a:p>
           <a:p>
@@ -3485,7 +3498,7 @@
               </a:defRPr>
             </a:pPr>
             <a:r>
-              <a:t>• Step 7: Ground footprint dimensions (at nadir/straight-down):</a:t>
+              <a:t>• Ground Dimensions Covered by Photo (Meters):</a:t>
             </a:r>
           </a:p>
           <a:p>
@@ -3498,7 +3511,7 @@
               </a:defRPr>
             </a:pPr>
             <a:r>
-              <a:t>   - Width = 2 * Altitude * tan(Horizontal FOV / 2) ≈ 1.71 * Altitude</a:t>
+              <a:t>   - ground_width = 2 * relative_alt * math.tan(fov_h / 2) ≈ 1.71 * relative_alt</a:t>
             </a:r>
           </a:p>
           <a:p>
@@ -3511,7 +3524,20 @@
               </a:defRPr>
             </a:pPr>
             <a:r>
-              <a:t>   - Corrected Height = 2 * Altitude * tan(Vertical FOV / 2) ≈ 0.96 * Altitude</a:t>
+              <a:t>   - ground_height = 2 * relative_alt * math.tan(fov_v / 2) ≈ 0.96 * relative_alt</a:t>
+            </a:r>
+          </a:p>
+          <a:p>
+            <a:pPr>
+              <a:defRPr sz="1300">
+                <a:solidFill>
+                  <a:srgbClr val="1E1E1E"/>
+                </a:solidFill>
+                <a:latin typeface="Arial"/>
+              </a:defRPr>
+            </a:pPr>
+            <a:r>
+              <a:t>• Direct Scaling Equivalence (Mathematical Proof):</a:t>
             </a:r>
           </a:p>
           <a:p>
@@ -3524,33 +3550,20 @@
               </a:defRPr>
             </a:pPr>
             <a:r>
-              <a:t>     (Corrects a +33% scale error caused by using the physical 4:3 height)</a:t>
-            </a:r>
-          </a:p>
-          <a:p>
-            <a:pPr>
-              <a:defRPr sz="1300">
-                <a:solidFill>
-                  <a:srgbClr val="1E1E1E"/>
-                </a:solidFill>
-                <a:latin typeface="Arial"/>
-              </a:defRPr>
-            </a:pPr>
-            <a:r>
-              <a:t>• Oblique Alignment: Camera tilt (pitch) distorts footprints from symmetric rectangles into quadrilaterals.</a:t>
-            </a:r>
-          </a:p>
-          <a:p>
-            <a:pPr>
-              <a:defRPr sz="1300">
-                <a:solidFill>
-                  <a:srgbClr val="1E1E1E"/>
-                </a:solidFill>
-                <a:latin typeface="Arial"/>
-              </a:defRPr>
-            </a:pPr>
-            <a:r>
-              <a:t>• Practical Value: Prevents overlap calculation errors, ensuring proper flight alignment and GSD resolutions.</a:t>
+              <a:t>   - Footprint (W or H) = (Sensor dimension * Altitude) / Focal length</a:t>
+            </a:r>
+          </a:p>
+          <a:p>
+            <a:pPr lvl="1">
+              <a:defRPr sz="1100">
+                <a:solidFill>
+                  <a:srgbClr val="1E1E1E"/>
+                </a:solidFill>
+                <a:latin typeface="Arial"/>
+              </a:defRPr>
+            </a:pPr>
+            <a:r>
+              <a:t>   - Identical to trigonometric projection because tan(arctan(x)) = x.</a:t>
             </a:r>
           </a:p>
         </p:txBody>
@@ -3572,7 +3585,7 @@
         <p:spPr>
           <a:xfrm>
             <a:off x="5577840" y="1097280"/>
-            <a:ext cx="3108960" cy="3236507"/>
+            <a:ext cx="3108960" cy="3748209"/>
           </a:xfrm>
           <a:prstGeom prst="rect">
             <a:avLst/>
@@ -3677,7 +3690,7 @@
               </a:defRPr>
             </a:pPr>
             <a:r>
-              <a:t>• Step 8: Flat Grid Conversion (Geospatial Projection):</a:t>
+              <a:t>• 1. Calculate Unrotated Local Metric Corners (Meters centered at camera 0,0):</a:t>
             </a:r>
           </a:p>
           <a:p>
@@ -3690,7 +3703,46 @@
               </a:defRPr>
             </a:pPr>
             <a:r>
-              <a:t>   - Projects GPS latitude and longitude (WGS 84 / EPSG:4326 degrees) to flat map meters (UTM Zone 15N / EPSG:32615) using pyproj.</a:t>
+              <a:t>   - half_w = ground_width / 2.0</a:t>
+            </a:r>
+          </a:p>
+          <a:p>
+            <a:pPr lvl="1">
+              <a:defRPr sz="1100">
+                <a:solidFill>
+                  <a:srgbClr val="1E1E1E"/>
+                </a:solidFill>
+                <a:latin typeface="Arial"/>
+              </a:defRPr>
+            </a:pPr>
+            <a:r>
+              <a:t>   - half_h = ground_height / 2.0</a:t>
+            </a:r>
+          </a:p>
+          <a:p>
+            <a:pPr lvl="1">
+              <a:defRPr sz="1100">
+                <a:solidFill>
+                  <a:srgbClr val="1E1E1E"/>
+                </a:solidFill>
+                <a:latin typeface="Arial"/>
+              </a:defRPr>
+            </a:pPr>
+            <a:r>
+              <a:t>   - local_corners = [ (-half_w, half_h), (half_w, half_h), (half_w, -half_h), (-half_w, -half_h) ]</a:t>
+            </a:r>
+          </a:p>
+          <a:p>
+            <a:pPr lvl="1">
+              <a:defRPr sz="1100">
+                <a:solidFill>
+                  <a:srgbClr val="1E1E1E"/>
+                </a:solidFill>
+                <a:latin typeface="Arial"/>
+              </a:defRPr>
+            </a:pPr>
+            <a:r>
+              <a:t>     (Orientation: +y is Local North, +x is Local East)</a:t>
             </a:r>
           </a:p>
           <a:p>
@@ -3703,7 +3755,7 @@
               </a:defRPr>
             </a:pPr>
             <a:r>
-              <a:t>• Corner Rotations using 2D Rotation Matrix (Gimbal Yaw θ):</a:t>
+              <a:t>• 2. Geospatial Grid Projection:</a:t>
             </a:r>
           </a:p>
           <a:p>
@@ -3716,7 +3768,20 @@
               </a:defRPr>
             </a:pPr>
             <a:r>
-              <a:t>   - X_rotated = X_drone + X_local * cos(θ) + Y_local * sin(θ)</a:t>
+              <a:t>   - Converts GPS center (WGS 84 degrees) to flat map meters (UTM Zone 15N) using pyproj.</a:t>
+            </a:r>
+          </a:p>
+          <a:p>
+            <a:pPr>
+              <a:defRPr sz="1300">
+                <a:solidFill>
+                  <a:srgbClr val="1E1E1E"/>
+                </a:solidFill>
+                <a:latin typeface="Arial"/>
+              </a:defRPr>
+            </a:pPr>
+            <a:r>
+              <a:t>• 3. Apply 2D Rotation Matrix (Gimbal Yaw θ):</a:t>
             </a:r>
           </a:p>
           <a:p>
@@ -3729,7 +3794,7 @@
               </a:defRPr>
             </a:pPr>
             <a:r>
-              <a:t>   - Y_rotated = Y_drone - X_local * sin(θ) + Y_local * cos(θ)</a:t>
+              <a:t>   - X_rot = X_drone + X_local * cos(yaw) + Y_local * sin(yaw)</a:t>
             </a:r>
           </a:p>
           <a:p>
@@ -3742,7 +3807,7 @@
               </a:defRPr>
             </a:pPr>
             <a:r>
-              <a:t>     (Rotates corners around the projected drone center coordinate)</a:t>
+              <a:t>   - Y_rot = Y_drone - X_local * sin(yaw) + Y_local * cos(yaw)</a:t>
             </a:r>
           </a:p>
           <a:p>
@@ -3755,7 +3820,7 @@
               </a:defRPr>
             </a:pPr>
             <a:r>
-              <a:t>• Step 9: Closed Loop Construction:</a:t>
+              <a:t>• 4. Closed Loop &amp; GeoJSON Export:</a:t>
             </a:r>
           </a:p>
           <a:p>
@@ -3768,7 +3833,7 @@
               </a:defRPr>
             </a:pPr>
             <a:r>
-              <a:t>   - Joins corners sequentially: Top-Left ➔ Top-Right ➔ Bottom-Right ➔ Bottom-Left.</a:t>
+              <a:t>   - Join corners sequentially (TL ➔ TR ➔ BR ➔ BL) and repeat TL at the end to close the geometry ring.</a:t>
             </a:r>
           </a:p>
           <a:p>
@@ -3781,33 +3846,7 @@
               </a:defRPr>
             </a:pPr>
             <a:r>
-              <a:t>   - Closes the ring by repeating the first coordinate point as the final entry.</a:t>
-            </a:r>
-          </a:p>
-          <a:p>
-            <a:pPr>
-              <a:defRPr sz="1300">
-                <a:solidFill>
-                  <a:srgbClr val="1E1E1E"/>
-                </a:solidFill>
-                <a:latin typeface="Arial"/>
-              </a:defRPr>
-            </a:pPr>
-            <a:r>
-              <a:t>• Step 10: GIS Format Export:</a:t>
-            </a:r>
-          </a:p>
-          <a:p>
-            <a:pPr lvl="1">
-              <a:defRPr sz="1100">
-                <a:solidFill>
-                  <a:srgbClr val="1E1E1E"/>
-                </a:solidFill>
-                <a:latin typeface="Arial"/>
-              </a:defRPr>
-            </a:pPr>
-            <a:r>
-              <a:t>   - Converts coordinates back to standard GPS degrees and writes them as a standardized GeoJSON FeatureCollection ready for QGIS / ArcGIS.</a:t>
+              <a:t>   - Convert corners back to GPS degrees and write to a standardized GIS GeoJSON file.</a:t>
             </a:r>
           </a:p>
         </p:txBody>

</xml_diff>

<commit_message>
Add Slide 10: Future Scope AI-driven Metadata Diagnostics and flowchart diagram
</commit_message>
<xml_diff>
--- a/Drone_Footprint_Mapping_and_Metadata_Standards.pptx
+++ b/Drone_Footprint_Mapping_and_Metadata_Standards.pptx
@@ -14,6 +14,7 @@
     <p:sldId id="262" r:id="rId13"/>
     <p:sldId id="263" r:id="rId14"/>
     <p:sldId id="264" r:id="rId15"/>
+    <p:sldId id="265" r:id="rId16"/>
   </p:sldIdLst>
   <p:sldSz cx="9144000" cy="5143500" type="screen4x3"/>
   <p:notesSz cx="6858000" cy="9144000"/>
@@ -3316,6 +3317,224 @@
           <a:xfrm>
             <a:off x="5577840" y="1097280"/>
             <a:ext cx="3108960" cy="3906129"/>
+          </a:xfrm>
+          <a:prstGeom prst="rect">
+            <a:avLst/>
+          </a:prstGeom>
+        </p:spPr>
+      </p:pic>
+    </p:spTree>
+  </p:cSld>
+  <p:clrMapOvr>
+    <a:masterClrMapping/>
+  </p:clrMapOvr>
+</p:sld>
+</file>
+
+<file path=ppt/slides/slide10.xml><?xml version="1.0" encoding="utf-8"?>
+<p:sld xmlns:a="http://schemas.openxmlformats.org/drawingml/2006/main" xmlns:p="http://schemas.openxmlformats.org/presentationml/2006/main" xmlns:r="http://schemas.openxmlformats.org/officeDocument/2006/relationships">
+  <p:cSld>
+    <p:spTree>
+      <p:nvGrpSpPr>
+        <p:cNvPr id="1" name=""/>
+        <p:cNvGrpSpPr/>
+        <p:nvPr/>
+      </p:nvGrpSpPr>
+      <p:grpSpPr/>
+      <p:sp>
+        <p:nvSpPr>
+          <p:cNvPr id="2" name="TextBox 1"/>
+          <p:cNvSpPr txBox="1"/>
+          <p:nvPr/>
+        </p:nvSpPr>
+        <p:spPr>
+          <a:xfrm>
+            <a:off x="457200" y="182880"/>
+            <a:ext cx="8229600" cy="731520"/>
+          </a:xfrm>
+          <a:prstGeom prst="rect">
+            <a:avLst/>
+          </a:prstGeom>
+          <a:noFill/>
+        </p:spPr>
+        <p:txBody>
+          <a:bodyPr wrap="square">
+            <a:spAutoFit/>
+          </a:bodyPr>
+          <a:lstStyle/>
+          <a:p>
+            <a:pPr algn="ctr">
+              <a:defRPr sz="2400" b="1" u="sng">
+                <a:solidFill>
+                  <a:srgbClr val="33B3FF"/>
+                </a:solidFill>
+                <a:latin typeface="Arial"/>
+              </a:defRPr>
+            </a:pPr>
+            <a:r>
+              <a:t>FUTURE SCOPE: AI-DRIVEN METADATA DIAGNOSTICS</a:t>
+            </a:r>
+          </a:p>
+        </p:txBody>
+      </p:sp>
+      <p:sp>
+        <p:nvSpPr>
+          <p:cNvPr id="3" name="TextBox 2"/>
+          <p:cNvSpPr txBox="1"/>
+          <p:nvPr/>
+        </p:nvSpPr>
+        <p:spPr>
+          <a:xfrm>
+            <a:off x="457200" y="1097280"/>
+            <a:ext cx="4937760" cy="3657600"/>
+          </a:xfrm>
+          <a:prstGeom prst="rect">
+            <a:avLst/>
+          </a:prstGeom>
+          <a:noFill/>
+        </p:spPr>
+        <p:txBody>
+          <a:bodyPr wrap="square">
+            <a:spAutoFit/>
+          </a:bodyPr>
+          <a:lstStyle/>
+          <a:p>
+            <a:pPr>
+              <a:defRPr sz="1300">
+                <a:solidFill>
+                  <a:srgbClr val="1E1E1E"/>
+                </a:solidFill>
+                <a:latin typeface="Arial"/>
+              </a:defRPr>
+            </a:pPr>
+            <a:r>
+              <a:t>• The Core Problem: Processing massive drone datasets (orthomosaics/point clouds) consumes days of computing time, only to discover later that poor raw metadata yields no usable spatial insights.</a:t>
+            </a:r>
+          </a:p>
+          <a:p>
+            <a:pPr>
+              <a:defRPr sz="1300">
+                <a:solidFill>
+                  <a:srgbClr val="1E1E1E"/>
+                </a:solidFill>
+                <a:latin typeface="Arial"/>
+              </a:defRPr>
+            </a:pPr>
+            <a:r>
+              <a:t>• AI-Driven Pre-filtering Solution: Develop a predictive machine learning classifier to inspect EXIF/XMP headers before executing the photogrammetry pipeline.</a:t>
+            </a:r>
+          </a:p>
+          <a:p>
+            <a:pPr>
+              <a:defRPr sz="1300">
+                <a:solidFill>
+                  <a:srgbClr val="1E1E1E"/>
+                </a:solidFill>
+                <a:latin typeface="Arial"/>
+              </a:defRPr>
+            </a:pPr>
+            <a:r>
+              <a:t>• Key Diagnostics Checked by AI Model:</a:t>
+            </a:r>
+          </a:p>
+          <a:p>
+            <a:pPr lvl="1">
+              <a:defRPr sz="1100">
+                <a:solidFill>
+                  <a:srgbClr val="1E1E1E"/>
+                </a:solidFill>
+                <a:latin typeface="Arial"/>
+              </a:defRPr>
+            </a:pPr>
+            <a:r>
+              <a:t>   - Telemetry completeness (GPS coverage gaps, altitude flags).</a:t>
+            </a:r>
+          </a:p>
+          <a:p>
+            <a:pPr lvl="1">
+              <a:defRPr sz="1100">
+                <a:solidFill>
+                  <a:srgbClr val="1E1E1E"/>
+                </a:solidFill>
+                <a:latin typeface="Arial"/>
+              </a:defRPr>
+            </a:pPr>
+            <a:r>
+              <a:t>   - Flight safety and quality (pitch/roll stability, speed vectors).</a:t>
+            </a:r>
+          </a:p>
+          <a:p>
+            <a:pPr lvl="1">
+              <a:defRPr sz="1100">
+                <a:solidFill>
+                  <a:srgbClr val="1E1E1E"/>
+                </a:solidFill>
+                <a:latin typeface="Arial"/>
+              </a:defRPr>
+            </a:pPr>
+            <a:r>
+              <a:t>   - Radiometric readiness (exposure index, sensor brightness levels).</a:t>
+            </a:r>
+          </a:p>
+          <a:p>
+            <a:pPr>
+              <a:defRPr sz="1300">
+                <a:solidFill>
+                  <a:srgbClr val="1E1E1E"/>
+                </a:solidFill>
+                <a:latin typeface="Arial"/>
+              </a:defRPr>
+            </a:pPr>
+            <a:r>
+              <a:t>• Actionable Outcomes:</a:t>
+            </a:r>
+          </a:p>
+          <a:p>
+            <a:pPr lvl="1">
+              <a:defRPr sz="1100">
+                <a:solidFill>
+                  <a:srgbClr val="1E1E1E"/>
+                </a:solidFill>
+                <a:latin typeface="Arial"/>
+              </a:defRPr>
+            </a:pPr>
+            <a:r>
+              <a:t>   - PASS: Dataset is marked feasible and proceed automatically to processing.</a:t>
+            </a:r>
+          </a:p>
+          <a:p>
+            <a:pPr lvl="1">
+              <a:defRPr sz="1100">
+                <a:solidFill>
+                  <a:srgbClr val="1E1E1E"/>
+                </a:solidFill>
+                <a:latin typeface="Arial"/>
+              </a:defRPr>
+            </a:pPr>
+            <a:r>
+              <a:t>   - FAIL: Flight flagged immediately for re-run or sensor maintenance, saving critical human and computational resources.</a:t>
+            </a:r>
+          </a:p>
+        </p:txBody>
+      </p:sp>
+      <p:pic>
+        <p:nvPicPr>
+          <p:cNvPr id="4" name="Picture 3" descr="fig_future_work.png"/>
+          <p:cNvPicPr>
+            <a:picLocks noChangeAspect="1"/>
+          </p:cNvPicPr>
+          <p:nvPr/>
+        </p:nvPicPr>
+        <p:blipFill>
+          <a:blip r:embed="rId2"/>
+          <a:stretch>
+            <a:fillRect/>
+          </a:stretch>
+        </p:blipFill>
+        <p:spPr>
+          <a:xfrm>
+            <a:off x="5577840" y="1097280"/>
+            <a:ext cx="3108960" cy="2821093"/>
           </a:xfrm>
           <a:prstGeom prst="rect">
             <a:avLst/>

</xml_diff>